<commit_message>
Add expanded workflow diagrams with maximum detail
</commit_message>
<xml_diff>
--- a/presentation/test_detailed_workflow.pptx
+++ b/presentation/test_detailed_workflow.pptx
@@ -9,6 +9,8 @@
     <p:sldId id="257" r:id="rId8"/>
     <p:sldId id="258" r:id="rId9"/>
     <p:sldId id="259" r:id="rId10"/>
+    <p:sldId id="260" r:id="rId11"/>
+    <p:sldId id="261" r:id="rId12"/>
   </p:sldIdLst>
   <p:sldSz cx="9144000" cy="6858000" type="screen4x3"/>
   <p:notesSz cx="6858000" cy="9144000"/>
@@ -5816,6 +5818,2874 @@
             </a:pPr>
             <a:r>
               <a:t>└─────────────────────────────────────────────────────┘</a:t>
+            </a:r>
+          </a:p>
+        </p:txBody>
+      </p:sp>
+    </p:spTree>
+  </p:cSld>
+  <p:clrMapOvr>
+    <a:masterClrMapping/>
+  </p:clrMapOvr>
+</p:sld>
+</file>
+
+<file path=ppt/slides/slide5.xml><?xml version="1.0" encoding="utf-8"?>
+<p:sld xmlns:a="http://schemas.openxmlformats.org/drawingml/2006/main" xmlns:p="http://schemas.openxmlformats.org/presentationml/2006/main" xmlns:r="http://schemas.openxmlformats.org/officeDocument/2006/relationships">
+  <p:cSld>
+    <p:bg>
+      <p:bgPr>
+        <a:solidFill>
+          <a:srgbClr val="0D1117"/>
+        </a:solidFill>
+        <a:effectLst/>
+      </p:bgPr>
+    </p:bg>
+    <p:spTree>
+      <p:nvGrpSpPr>
+        <p:cNvPr id="1" name=""/>
+        <p:cNvGrpSpPr/>
+        <p:nvPr/>
+      </p:nvGrpSpPr>
+      <p:grpSpPr/>
+      <p:sp>
+        <p:nvSpPr>
+          <p:cNvPr id="2" name="TextBox 1"/>
+          <p:cNvSpPr txBox="1"/>
+          <p:nvPr/>
+        </p:nvSpPr>
+        <p:spPr>
+          <a:xfrm>
+            <a:off x="457200" y="274320"/>
+            <a:ext cx="8229600" cy="457200"/>
+          </a:xfrm>
+          <a:prstGeom prst="rect">
+            <a:avLst/>
+          </a:prstGeom>
+          <a:noFill/>
+        </p:spPr>
+        <p:txBody>
+          <a:bodyPr wrap="none">
+            <a:spAutoFit/>
+          </a:bodyPr>
+          <a:lstStyle/>
+          <a:p>
+            <a:pPr>
+              <a:defRPr sz="2400" b="1">
+                <a:solidFill>
+                  <a:srgbClr val="58A6FF"/>
+                </a:solidFill>
+                <a:latin typeface="Consolas"/>
+              </a:defRPr>
+            </a:pPr>
+            <a:r>
+              <a:t>$ cat workflow_expanded.txt</a:t>
+            </a:r>
+          </a:p>
+        </p:txBody>
+      </p:sp>
+      <p:sp>
+        <p:nvSpPr>
+          <p:cNvPr id="3" name="TextBox 2"/>
+          <p:cNvSpPr txBox="1"/>
+          <p:nvPr/>
+        </p:nvSpPr>
+        <p:spPr>
+          <a:xfrm>
+            <a:off x="274320" y="868680"/>
+            <a:ext cx="8595360" cy="5806440"/>
+          </a:xfrm>
+          <a:prstGeom prst="rect">
+            <a:avLst/>
+          </a:prstGeom>
+          <a:noFill/>
+        </p:spPr>
+        <p:txBody>
+          <a:bodyPr wrap="none">
+            <a:spAutoFit/>
+          </a:bodyPr>
+          <a:lstStyle/>
+          <a:p>
+            <a:pPr>
+              <a:lnSpc>
+                <a:spcPct val="100000"/>
+              </a:lnSpc>
+              <a:spcAft>
+                <a:spcPts val="0"/>
+              </a:spcAft>
+              <a:defRPr sz="800">
+                <a:solidFill>
+                  <a:srgbClr val="57AB5A"/>
+                </a:solidFill>
+                <a:latin typeface="Consolas"/>
+              </a:defRPr>
+            </a:pPr>
+            <a:r>
+              <a:t>INPUT: molecule.xyz (Cartesian coordinates, atom types)</a:t>
+            </a:r>
+          </a:p>
+          <a:p>
+            <a:pPr>
+              <a:lnSpc>
+                <a:spcPct val="100000"/>
+              </a:lnSpc>
+              <a:spcAft>
+                <a:spcPts val="0"/>
+              </a:spcAft>
+              <a:defRPr sz="800">
+                <a:solidFill>
+                  <a:srgbClr val="8B949E"/>
+                </a:solidFill>
+                <a:latin typeface="Consolas"/>
+              </a:defRPr>
+            </a:pPr>
+            <a:r>
+              <a:t>    │</a:t>
+            </a:r>
+          </a:p>
+          <a:p>
+            <a:pPr>
+              <a:lnSpc>
+                <a:spcPct val="100000"/>
+              </a:lnSpc>
+              <a:spcAft>
+                <a:spcPts val="0"/>
+              </a:spcAft>
+              <a:defRPr sz="800">
+                <a:solidFill>
+                  <a:srgbClr val="8B949E"/>
+                </a:solidFill>
+                <a:latin typeface="Consolas"/>
+              </a:defRPr>
+            </a:pPr>
+            <a:r>
+              <a:t>    ▼</a:t>
+            </a:r>
+          </a:p>
+          <a:p>
+            <a:pPr>
+              <a:lnSpc>
+                <a:spcPct val="100000"/>
+              </a:lnSpc>
+              <a:spcAft>
+                <a:spcPts val="0"/>
+              </a:spcAft>
+              <a:defRPr sz="800">
+                <a:solidFill>
+                  <a:srgbClr val="58A6FF"/>
+                </a:solidFill>
+                <a:latin typeface="Consolas"/>
+              </a:defRPr>
+            </a:pPr>
+            <a:r>
+              <a:t>┌─────────────────────────────────────────────────────────────────────────────────┐</a:t>
+            </a:r>
+          </a:p>
+          <a:p>
+            <a:pPr>
+              <a:lnSpc>
+                <a:spcPct val="100000"/>
+              </a:lnSpc>
+              <a:spcAft>
+                <a:spcPts val="0"/>
+              </a:spcAft>
+              <a:defRPr sz="800">
+                <a:solidFill>
+                  <a:srgbClr val="58A6FF"/>
+                </a:solidFill>
+                <a:latin typeface="Consolas"/>
+              </a:defRPr>
+            </a:pPr>
+            <a:r>
+              <a:t>│  PHASE 1: GEOMETRY OPTIMIZATION                                                 │</a:t>
+            </a:r>
+          </a:p>
+          <a:p>
+            <a:pPr>
+              <a:lnSpc>
+                <a:spcPct val="100000"/>
+              </a:lnSpc>
+              <a:spcAft>
+                <a:spcPts val="0"/>
+              </a:spcAft>
+              <a:defRPr sz="800">
+                <a:solidFill>
+                  <a:srgbClr val="C9D1D9"/>
+                </a:solidFill>
+                <a:latin typeface="Consolas"/>
+              </a:defRPr>
+            </a:pPr>
+            <a:r>
+              <a:t>│  Calculator: MACE-OMOL (default) | Options: MACE-OFF, MACE-MP                  │</a:t>
+            </a:r>
+          </a:p>
+          <a:p>
+            <a:pPr>
+              <a:lnSpc>
+                <a:spcPct val="100000"/>
+              </a:lnSpc>
+              <a:spcAft>
+                <a:spcPts val="0"/>
+              </a:spcAft>
+              <a:defRPr sz="800">
+                <a:solidFill>
+                  <a:srgbClr val="C9D1D9"/>
+                </a:solidFill>
+                <a:latin typeface="Consolas"/>
+              </a:defRPr>
+            </a:pPr>
+            <a:r>
+              <a:t>│  Method: BFGS optimizer, force convergence 0.01 eV/Å                           │</a:t>
+            </a:r>
+          </a:p>
+          <a:p>
+            <a:pPr>
+              <a:lnSpc>
+                <a:spcPct val="100000"/>
+              </a:lnSpc>
+              <a:spcAft>
+                <a:spcPts val="0"/>
+              </a:spcAft>
+              <a:defRPr sz="800">
+                <a:solidFill>
+                  <a:srgbClr val="C9D1D9"/>
+                </a:solidFill>
+                <a:latin typeface="Consolas"/>
+              </a:defRPr>
+            </a:pPr>
+            <a:r>
+              <a:t>│  Output: optimized.xyz (relaxed structure), geometry_opt/results.json          │</a:t>
+            </a:r>
+          </a:p>
+          <a:p>
+            <a:pPr>
+              <a:lnSpc>
+                <a:spcPct val="100000"/>
+              </a:lnSpc>
+              <a:spcAft>
+                <a:spcPts val="0"/>
+              </a:spcAft>
+              <a:defRPr sz="800">
+                <a:solidFill>
+                  <a:srgbClr val="C9D1D9"/>
+                </a:solidFill>
+                <a:latin typeface="Consolas"/>
+              </a:defRPr>
+            </a:pPr>
+            <a:r>
+              <a:t>│  Metrics: initial_energy, final_energy, n_steps, convergence_status            │</a:t>
+            </a:r>
+          </a:p>
+          <a:p>
+            <a:pPr>
+              <a:lnSpc>
+                <a:spcPct val="100000"/>
+              </a:lnSpc>
+              <a:spcAft>
+                <a:spcPts val="0"/>
+              </a:spcAft>
+              <a:defRPr sz="800">
+                <a:solidFill>
+                  <a:srgbClr val="58A6FF"/>
+                </a:solidFill>
+                <a:latin typeface="Consolas"/>
+              </a:defRPr>
+            </a:pPr>
+            <a:r>
+              <a:t>└─────────────────────────────────────────────────────────────────────────────────┘</a:t>
+            </a:r>
+          </a:p>
+          <a:p>
+            <a:pPr>
+              <a:lnSpc>
+                <a:spcPct val="100000"/>
+              </a:lnSpc>
+              <a:spcAft>
+                <a:spcPts val="0"/>
+              </a:spcAft>
+              <a:defRPr sz="800">
+                <a:solidFill>
+                  <a:srgbClr val="8B949E"/>
+                </a:solidFill>
+                <a:latin typeface="Consolas"/>
+              </a:defRPr>
+            </a:pPr>
+            <a:r>
+              <a:t>    │</a:t>
+            </a:r>
+          </a:p>
+          <a:p>
+            <a:pPr>
+              <a:lnSpc>
+                <a:spcPct val="100000"/>
+              </a:lnSpc>
+              <a:spcAft>
+                <a:spcPts val="0"/>
+              </a:spcAft>
+              <a:defRPr sz="800">
+                <a:solidFill>
+                  <a:srgbClr val="8B949E"/>
+                </a:solidFill>
+                <a:latin typeface="Consolas"/>
+              </a:defRPr>
+            </a:pPr>
+            <a:r>
+              <a:t>    ├─────────────────────────────────────┬──────────────────────────────────────┐</a:t>
+            </a:r>
+          </a:p>
+          <a:p>
+            <a:pPr>
+              <a:lnSpc>
+                <a:spcPct val="100000"/>
+              </a:lnSpc>
+              <a:spcAft>
+                <a:spcPts val="0"/>
+              </a:spcAft>
+              <a:defRPr sz="800">
+                <a:solidFill>
+                  <a:srgbClr val="8B949E"/>
+                </a:solidFill>
+                <a:latin typeface="Consolas"/>
+              </a:defRPr>
+            </a:pPr>
+            <a:r>
+              <a:t>    │                                     │                                      │</a:t>
+            </a:r>
+          </a:p>
+          <a:p>
+            <a:pPr>
+              <a:lnSpc>
+                <a:spcPct val="100000"/>
+              </a:lnSpc>
+              <a:spcAft>
+                <a:spcPts val="0"/>
+              </a:spcAft>
+              <a:defRPr sz="800">
+                <a:solidFill>
+                  <a:srgbClr val="8B949E"/>
+                </a:solidFill>
+                <a:latin typeface="Consolas"/>
+              </a:defRPr>
+            </a:pPr>
+            <a:r>
+              <a:t>    │ (optional, --skip-dft-baseline)     │ (default: True)                      │</a:t>
+            </a:r>
+          </a:p>
+          <a:p>
+            <a:pPr>
+              <a:lnSpc>
+                <a:spcPct val="100000"/>
+              </a:lnSpc>
+              <a:spcAft>
+                <a:spcPts val="0"/>
+              </a:spcAft>
+              <a:defRPr sz="800">
+                <a:solidFill>
+                  <a:srgbClr val="8B949E"/>
+                </a:solidFill>
+                <a:latin typeface="Consolas"/>
+              </a:defRPr>
+            </a:pPr>
+            <a:r>
+              <a:t>    ▼                                     ▼                                      ▼</a:t>
+            </a:r>
+          </a:p>
+          <a:p>
+            <a:pPr>
+              <a:lnSpc>
+                <a:spcPct val="100000"/>
+              </a:lnSpc>
+              <a:spcAft>
+                <a:spcPts val="0"/>
+              </a:spcAft>
+              <a:defRPr sz="800">
+                <a:solidFill>
+                  <a:srgbClr val="57AB5A"/>
+                </a:solidFill>
+                <a:latin typeface="Consolas"/>
+              </a:defRPr>
+            </a:pPr>
+            <a:r>
+              <a:t>┌───────────────────────┐  ┌──────────────────────────────────────────────────────────────┐</a:t>
+            </a:r>
+          </a:p>
+          <a:p>
+            <a:pPr>
+              <a:lnSpc>
+                <a:spcPct val="100000"/>
+              </a:lnSpc>
+              <a:spcAft>
+                <a:spcPts val="0"/>
+              </a:spcAft>
+              <a:defRPr sz="800">
+                <a:solidFill>
+                  <a:srgbClr val="57AB5A"/>
+                </a:solidFill>
+                <a:latin typeface="Consolas"/>
+              </a:defRPr>
+            </a:pPr>
+            <a:r>
+              <a:t>│  PHASE 2: DFT         │  │  PHASE 3: ML FREQUENCY CALCULATIONS                          │</a:t>
+            </a:r>
+          </a:p>
+          <a:p>
+            <a:pPr>
+              <a:lnSpc>
+                <a:spcPct val="100000"/>
+              </a:lnSpc>
+              <a:spcAft>
+                <a:spcPts val="0"/>
+              </a:spcAft>
+              <a:defRPr sz="800">
+                <a:solidFill>
+                  <a:srgbClr val="DB6D28"/>
+                </a:solidFill>
+                <a:latin typeface="Consolas"/>
+              </a:defRPr>
+            </a:pPr>
+            <a:r>
+              <a:t>│  BASELINE             │  │  Configuration: --energy-calculators, --dipole-calculators   │</a:t>
+            </a:r>
+          </a:p>
+          <a:p>
+            <a:pPr>
+              <a:lnSpc>
+                <a:spcPct val="100000"/>
+              </a:lnSpc>
+              <a:spcAft>
+                <a:spcPts val="0"/>
+              </a:spcAft>
+              <a:defRPr sz="800">
+                <a:solidFill>
+                  <a:srgbClr val="C9D1D9"/>
+                </a:solidFill>
+                <a:latin typeface="Consolas"/>
+              </a:defRPr>
+            </a:pPr>
+            <a:r>
+              <a:t>│  ─────────────────    │  │  ─────────────────────────────────────────────────────────   │</a:t>
+            </a:r>
+          </a:p>
+          <a:p>
+            <a:pPr>
+              <a:lnSpc>
+                <a:spcPct val="100000"/>
+              </a:lnSpc>
+              <a:spcAft>
+                <a:spcPts val="0"/>
+              </a:spcAft>
+              <a:defRPr sz="800">
+                <a:solidFill>
+                  <a:srgbClr val="C9D1D9"/>
+                </a:solidFill>
+                <a:latin typeface="Consolas"/>
+              </a:defRPr>
+            </a:pPr>
+            <a:r>
+              <a:t>│  Method: B3LYP        │  │  Energy Calculators:                                         │</a:t>
+            </a:r>
+          </a:p>
+          <a:p>
+            <a:pPr>
+              <a:lnSpc>
+                <a:spcPct val="100000"/>
+              </a:lnSpc>
+              <a:spcAft>
+                <a:spcPts val="0"/>
+              </a:spcAft>
+              <a:defRPr sz="800">
+                <a:solidFill>
+                  <a:srgbClr val="C9D1D9"/>
+                </a:solidFill>
+                <a:latin typeface="Consolas"/>
+              </a:defRPr>
+            </a:pPr>
+            <a:r>
+              <a:t>│  Basis: 6-31G(d,p)    │  │    • MACE-MP (large, 2M params, general chemistry)           │</a:t>
+            </a:r>
+          </a:p>
+          <a:p>
+            <a:pPr>
+              <a:lnSpc>
+                <a:spcPct val="100000"/>
+              </a:lnSpc>
+              <a:spcAft>
+                <a:spcPts val="0"/>
+              </a:spcAft>
+              <a:defRPr sz="800">
+                <a:solidFill>
+                  <a:srgbClr val="C9D1D9"/>
+                </a:solidFill>
+                <a:latin typeface="Consolas"/>
+              </a:defRPr>
+            </a:pPr>
+            <a:r>
+              <a:t>│  Freq: Harmonic       │  │    • MACE-OMOL (molecules, 1.5M params, organic focus)       │</a:t>
+            </a:r>
+          </a:p>
+          <a:p>
+            <a:pPr>
+              <a:lnSpc>
+                <a:spcPct val="100000"/>
+              </a:lnSpc>
+              <a:spcAft>
+                <a:spcPts val="0"/>
+              </a:spcAft>
+              <a:defRPr sz="800">
+                <a:solidFill>
+                  <a:srgbClr val="C9D1D9"/>
+                </a:solidFill>
+                <a:latin typeface="Consolas"/>
+              </a:defRPr>
+            </a:pPr>
+            <a:r>
+              <a:t>│  Program: Gaussian 16 │  │  Dipole Calculators (with automatic fallback):               │</a:t>
+            </a:r>
+          </a:p>
+          <a:p>
+            <a:pPr>
+              <a:lnSpc>
+                <a:spcPct val="100000"/>
+              </a:lnSpc>
+              <a:spcAft>
+                <a:spcPts val="0"/>
+              </a:spcAft>
+              <a:defRPr sz="800">
+                <a:solidFill>
+                  <a:srgbClr val="DB6D28"/>
+                </a:solidFill>
+                <a:latin typeface="Consolas"/>
+              </a:defRPr>
+            </a:pPr>
+            <a:r>
+              <a:t>│                       │  │    1. MACE-ML: Custom dipole model (~/dipole_model/)         │</a:t>
+            </a:r>
+          </a:p>
+          <a:p>
+            <a:pPr>
+              <a:lnSpc>
+                <a:spcPct val="100000"/>
+              </a:lnSpc>
+              <a:spcAft>
+                <a:spcPts val="0"/>
+              </a:spcAft>
+              <a:defRPr sz="800">
+                <a:solidFill>
+                  <a:srgbClr val="DB6D28"/>
+                </a:solidFill>
+                <a:latin typeface="Consolas"/>
+              </a:defRPr>
+            </a:pPr>
+            <a:r>
+              <a:t>│  Output:              │  │    2. Espaloma: Charge-based (Σ qᵢrᵢ)                        │</a:t>
+            </a:r>
+          </a:p>
+          <a:p>
+            <a:pPr>
+              <a:lnSpc>
+                <a:spcPct val="100000"/>
+              </a:lnSpc>
+              <a:spcAft>
+                <a:spcPts val="0"/>
+              </a:spcAft>
+              <a:defRPr sz="800">
+                <a:solidFill>
+                  <a:srgbClr val="DB6D28"/>
+                </a:solidFill>
+                <a:latin typeface="Consolas"/>
+              </a:defRPr>
+            </a:pPr>
+            <a:r>
+              <a:t>│  b3lyp_6-31Gdp/       │  │    3. xTB: GFN2-xTB semi-empirical                           │</a:t>
+            </a:r>
+          </a:p>
+          <a:p>
+            <a:pPr>
+              <a:lnSpc>
+                <a:spcPct val="100000"/>
+              </a:lnSpc>
+              <a:spcAft>
+                <a:spcPts val="0"/>
+              </a:spcAft>
+              <a:defRPr sz="800">
+                <a:solidFill>
+                  <a:srgbClr val="DB6D28"/>
+                </a:solidFill>
+                <a:latin typeface="Consolas"/>
+              </a:defRPr>
+            </a:pPr>
+            <a:r>
+              <a:t>│  results.json         │  │  ┌────────────────────────────────────────────────────────┐  │</a:t>
+            </a:r>
+          </a:p>
+          <a:p>
+            <a:pPr>
+              <a:lnSpc>
+                <a:spcPct val="100000"/>
+              </a:lnSpc>
+              <a:spcAft>
+                <a:spcPts val="0"/>
+              </a:spcAft>
+              <a:defRPr sz="800">
+                <a:solidFill>
+                  <a:srgbClr val="DB6D28"/>
+                </a:solidFill>
+                <a:latin typeface="Consolas"/>
+              </a:defRPr>
+            </a:pPr>
+            <a:r>
+              <a:t>│  ├─ frequencies[]     │  │  │  ZMQ BRIDGE ARCHITECTURE (IPC)                         │  │</a:t>
+            </a:r>
+          </a:p>
+          <a:p>
+            <a:pPr>
+              <a:lnSpc>
+                <a:spcPct val="100000"/>
+              </a:lnSpc>
+              <a:spcAft>
+                <a:spcPts val="0"/>
+              </a:spcAft>
+              <a:defRPr sz="800">
+                <a:solidFill>
+                  <a:srgbClr val="DB6D28"/>
+                </a:solidFill>
+                <a:latin typeface="Consolas"/>
+              </a:defRPr>
+            </a:pPr>
+            <a:r>
+              <a:t>│  ├─ intensities[]     │  │  │  ─────────────────────────────────                     │  │</a:t>
+            </a:r>
+          </a:p>
+          <a:p>
+            <a:pPr>
+              <a:lnSpc>
+                <a:spcPct val="100000"/>
+              </a:lnSpc>
+              <a:spcAft>
+                <a:spcPts val="0"/>
+              </a:spcAft>
+              <a:defRPr sz="800">
+                <a:solidFill>
+                  <a:srgbClr val="DB6D28"/>
+                </a:solidFill>
+                <a:latin typeface="Consolas"/>
+              </a:defRPr>
+            </a:pPr>
+            <a:r>
+              <a:t>│  └─ runtime_s         │  │  │  Main Process (gm_main.py):                            │  │</a:t>
+            </a:r>
+          </a:p>
+          <a:p>
+            <a:pPr>
+              <a:lnSpc>
+                <a:spcPct val="100000"/>
+              </a:lnSpc>
+              <a:spcAft>
+                <a:spcPts val="0"/>
+              </a:spcAft>
+              <a:defRPr sz="800">
+                <a:solidFill>
+                  <a:srgbClr val="DB6D28"/>
+                </a:solidFill>
+                <a:latin typeface="Consolas"/>
+              </a:defRPr>
+            </a:pPr>
+            <a:r>
+              <a:t>│                       │  │  │    • Binds ZMQ server socket (.ipc_file)               │  │</a:t>
+            </a:r>
+          </a:p>
+          <a:p>
+            <a:pPr>
+              <a:lnSpc>
+                <a:spcPct val="100000"/>
+              </a:lnSpc>
+              <a:spcAft>
+                <a:spcPts val="0"/>
+              </a:spcAft>
+              <a:defRPr sz="800">
+                <a:solidFill>
+                  <a:srgbClr val="DB6D28"/>
+                </a:solidFill>
+                <a:latin typeface="Consolas"/>
+              </a:defRPr>
+            </a:pPr>
+            <a:r>
+              <a:t>└───────────────────────┘  │  │    • Loads ML dipole calculator                        │  │</a:t>
+            </a:r>
+          </a:p>
+          <a:p>
+            <a:pPr>
+              <a:lnSpc>
+                <a:spcPct val="100000"/>
+              </a:lnSpc>
+              <a:spcAft>
+                <a:spcPts val="0"/>
+              </a:spcAft>
+              <a:defRPr sz="800">
+                <a:solidFill>
+                  <a:srgbClr val="DB6D28"/>
+                </a:solidFill>
+                <a:latin typeface="Consolas"/>
+              </a:defRPr>
+            </a:pPr>
+            <a:r>
+              <a:t>    │                      │  │    • Waits for geometry requests                       │  │</a:t>
+            </a:r>
+          </a:p>
+          <a:p>
+            <a:pPr>
+              <a:lnSpc>
+                <a:spcPct val="100000"/>
+              </a:lnSpc>
+              <a:spcAft>
+                <a:spcPts val="0"/>
+              </a:spcAft>
+              <a:defRPr sz="800">
+                <a:solidFill>
+                  <a:srgbClr val="DB6D28"/>
+                </a:solidFill>
+                <a:latin typeface="Consolas"/>
+              </a:defRPr>
+            </a:pPr>
+            <a:r>
+              <a:t>    │                      │  │    • Computes dipole derivatives                       │  │</a:t>
+            </a:r>
+          </a:p>
+          <a:p>
+            <a:pPr>
+              <a:lnSpc>
+                <a:spcPct val="100000"/>
+              </a:lnSpc>
+              <a:spcAft>
+                <a:spcPts val="0"/>
+              </a:spcAft>
+              <a:defRPr sz="800">
+                <a:solidFill>
+                  <a:srgbClr val="DB6D28"/>
+                </a:solidFill>
+                <a:latin typeface="Consolas"/>
+              </a:defRPr>
+            </a:pPr>
+            <a:r>
+              <a:t>    │                      │  │    • Writes Gaussian-format output                     │  │</a:t>
+            </a:r>
+          </a:p>
+          <a:p>
+            <a:pPr>
+              <a:lnSpc>
+                <a:spcPct val="100000"/>
+              </a:lnSpc>
+              <a:spcAft>
+                <a:spcPts val="0"/>
+              </a:spcAft>
+              <a:defRPr sz="800">
+                <a:solidFill>
+                  <a:srgbClr val="DB6D28"/>
+                </a:solidFill>
+                <a:latin typeface="Consolas"/>
+              </a:defRPr>
+            </a:pPr>
+            <a:r>
+              <a:t>    │                      │  │  Helper Script (gm_helper.py):                         │  │</a:t>
+            </a:r>
+          </a:p>
+          <a:p>
+            <a:pPr>
+              <a:lnSpc>
+                <a:spcPct val="100000"/>
+              </a:lnSpc>
+              <a:spcAft>
+                <a:spcPts val="0"/>
+              </a:spcAft>
+              <a:defRPr sz="800">
+                <a:solidFill>
+                  <a:srgbClr val="DB6D28"/>
+                </a:solidFill>
+                <a:latin typeface="Consolas"/>
+              </a:defRPr>
+            </a:pPr>
+            <a:r>
+              <a:t>    │                      │  │    • Launched by Gaussian External directive           │  │</a:t>
+            </a:r>
+          </a:p>
+          <a:p>
+            <a:pPr>
+              <a:lnSpc>
+                <a:spcPct val="100000"/>
+              </a:lnSpc>
+              <a:spcAft>
+                <a:spcPts val="0"/>
+              </a:spcAft>
+              <a:defRPr sz="800">
+                <a:solidFill>
+                  <a:srgbClr val="DB6D28"/>
+                </a:solidFill>
+                <a:latin typeface="Consolas"/>
+              </a:defRPr>
+            </a:pPr>
+            <a:r>
+              <a:t>    │                      │  │    • Connects to ZMQ socket                            │  │</a:t>
+            </a:r>
+          </a:p>
+          <a:p>
+            <a:pPr>
+              <a:lnSpc>
+                <a:spcPct val="100000"/>
+              </a:lnSpc>
+              <a:spcAft>
+                <a:spcPts val="0"/>
+              </a:spcAft>
+              <a:defRPr sz="800">
+                <a:solidFill>
+                  <a:srgbClr val="DB6D28"/>
+                </a:solidFill>
+                <a:latin typeface="Consolas"/>
+              </a:defRPr>
+            </a:pPr>
+            <a:r>
+              <a:t>    │                      │  │    • Sends: 'infile|outfile'                           │  │</a:t>
+            </a:r>
+          </a:p>
+          <a:p>
+            <a:pPr>
+              <a:lnSpc>
+                <a:spcPct val="100000"/>
+              </a:lnSpc>
+              <a:spcAft>
+                <a:spcPts val="0"/>
+              </a:spcAft>
+              <a:defRPr sz="800">
+                <a:solidFill>
+                  <a:srgbClr val="DB6D28"/>
+                </a:solidFill>
+                <a:latin typeface="Consolas"/>
+              </a:defRPr>
+            </a:pPr>
+            <a:r>
+              <a:t>    │                      │  │    • Waits for: 'done' signal                          │  │</a:t>
+            </a:r>
+          </a:p>
+          <a:p>
+            <a:pPr>
+              <a:lnSpc>
+                <a:spcPct val="100000"/>
+              </a:lnSpc>
+              <a:spcAft>
+                <a:spcPts val="0"/>
+              </a:spcAft>
+              <a:defRPr sz="800">
+                <a:solidFill>
+                  <a:srgbClr val="DB6D28"/>
+                </a:solidFill>
+                <a:latin typeface="Consolas"/>
+              </a:defRPr>
+            </a:pPr>
+            <a:r>
+              <a:t>    │                      │  │    • Returns control to Gaussian                       │  │</a:t>
+            </a:r>
+          </a:p>
+          <a:p>
+            <a:pPr>
+              <a:lnSpc>
+                <a:spcPct val="100000"/>
+              </a:lnSpc>
+              <a:spcAft>
+                <a:spcPts val="0"/>
+              </a:spcAft>
+              <a:defRPr sz="800">
+                <a:solidFill>
+                  <a:srgbClr val="DB6D28"/>
+                </a:solidFill>
+                <a:latin typeface="Consolas"/>
+              </a:defRPr>
+            </a:pPr>
+            <a:r>
+              <a:t>    │                      │  │  Gaussian 16:                                          │  │</a:t>
+            </a:r>
+          </a:p>
+          <a:p>
+            <a:pPr>
+              <a:lnSpc>
+                <a:spcPct val="100000"/>
+              </a:lnSpc>
+              <a:spcAft>
+                <a:spcPts val="0"/>
+              </a:spcAft>
+              <a:defRPr sz="800">
+                <a:solidFill>
+                  <a:srgbClr val="DB6D28"/>
+                </a:solidFill>
+                <a:latin typeface="Consolas"/>
+              </a:defRPr>
+            </a:pPr>
+            <a:r>
+              <a:t>    │                      │  │    • Freq calculation (harmonic/anharmonic)            │  │</a:t>
+            </a:r>
+          </a:p>
+          <a:p>
+            <a:pPr>
+              <a:lnSpc>
+                <a:spcPct val="100000"/>
+              </a:lnSpc>
+              <a:spcAft>
+                <a:spcPts val="0"/>
+              </a:spcAft>
+              <a:defRPr sz="800">
+                <a:solidFill>
+                  <a:srgbClr val="DB6D28"/>
+                </a:solidFill>
+                <a:latin typeface="Consolas"/>
+              </a:defRPr>
+            </a:pPr>
+            <a:r>
+              <a:t>    │                      │  │    • Calls external for each geometry                  │  │</a:t>
+            </a:r>
+          </a:p>
+          <a:p>
+            <a:pPr>
+              <a:lnSpc>
+                <a:spcPct val="100000"/>
+              </a:lnSpc>
+              <a:spcAft>
+                <a:spcPts val="0"/>
+              </a:spcAft>
+              <a:defRPr sz="800">
+                <a:solidFill>
+                  <a:srgbClr val="DB6D28"/>
+                </a:solidFill>
+                <a:latin typeface="Consolas"/>
+              </a:defRPr>
+            </a:pPr>
+            <a:r>
+              <a:t>    │                      │  └────────────────────────────────────────────────────────┘  │</a:t>
+            </a:r>
+          </a:p>
+          <a:p>
+            <a:pPr>
+              <a:lnSpc>
+                <a:spcPct val="100000"/>
+              </a:lnSpc>
+              <a:spcAft>
+                <a:spcPts val="0"/>
+              </a:spcAft>
+              <a:defRPr sz="800">
+                <a:solidFill>
+                  <a:srgbClr val="C9D1D9"/>
+                </a:solidFill>
+                <a:latin typeface="Consolas"/>
+              </a:defRPr>
+            </a:pPr>
+            <a:r>
+              <a:t>    │                      │  Combinations tested (4 total):                              │</a:t>
+            </a:r>
+          </a:p>
+          <a:p>
+            <a:pPr>
+              <a:lnSpc>
+                <a:spcPct val="100000"/>
+              </a:lnSpc>
+              <a:spcAft>
+                <a:spcPts val="0"/>
+              </a:spcAft>
+              <a:defRPr sz="800">
+                <a:solidFill>
+                  <a:srgbClr val="C9D1D9"/>
+                </a:solidFill>
+                <a:latin typeface="Consolas"/>
+              </a:defRPr>
+            </a:pPr>
+            <a:r>
+              <a:t>    │                      │    • mace_mp_espaloma/results.json                           │</a:t>
+            </a:r>
+          </a:p>
+          <a:p>
+            <a:pPr>
+              <a:lnSpc>
+                <a:spcPct val="100000"/>
+              </a:lnSpc>
+              <a:spcAft>
+                <a:spcPts val="0"/>
+              </a:spcAft>
+              <a:defRPr sz="800">
+                <a:solidFill>
+                  <a:srgbClr val="C9D1D9"/>
+                </a:solidFill>
+                <a:latin typeface="Consolas"/>
+              </a:defRPr>
+            </a:pPr>
+            <a:r>
+              <a:t>    │                      │    • mace_mp_mace_ml/results.json                            │</a:t>
+            </a:r>
+          </a:p>
+          <a:p>
+            <a:pPr>
+              <a:lnSpc>
+                <a:spcPct val="100000"/>
+              </a:lnSpc>
+              <a:spcAft>
+                <a:spcPts val="0"/>
+              </a:spcAft>
+              <a:defRPr sz="800">
+                <a:solidFill>
+                  <a:srgbClr val="C9D1D9"/>
+                </a:solidFill>
+                <a:latin typeface="Consolas"/>
+              </a:defRPr>
+            </a:pPr>
+            <a:r>
+              <a:t>    │                      │    • mace_omol_espaloma/results.json                         │</a:t>
+            </a:r>
+          </a:p>
+          <a:p>
+            <a:pPr>
+              <a:lnSpc>
+                <a:spcPct val="100000"/>
+              </a:lnSpc>
+              <a:spcAft>
+                <a:spcPts val="0"/>
+              </a:spcAft>
+              <a:defRPr sz="800">
+                <a:solidFill>
+                  <a:srgbClr val="C9D1D9"/>
+                </a:solidFill>
+                <a:latin typeface="Consolas"/>
+              </a:defRPr>
+            </a:pPr>
+            <a:r>
+              <a:t>    │                      │    • mace_omol_mace_ml/results.json                          │</a:t>
+            </a:r>
+          </a:p>
+          <a:p>
+            <a:pPr>
+              <a:lnSpc>
+                <a:spcPct val="100000"/>
+              </a:lnSpc>
+              <a:spcAft>
+                <a:spcPts val="0"/>
+              </a:spcAft>
+              <a:defRPr sz="800">
+                <a:solidFill>
+                  <a:srgbClr val="57AB5A"/>
+                </a:solidFill>
+                <a:latin typeface="Consolas"/>
+              </a:defRPr>
+            </a:pPr>
+            <a:r>
+              <a:t>    │                      └──────────────────────────────────────────────────────────────┘</a:t>
+            </a:r>
+          </a:p>
+          <a:p>
+            <a:pPr>
+              <a:lnSpc>
+                <a:spcPct val="100000"/>
+              </a:lnSpc>
+              <a:spcAft>
+                <a:spcPts val="0"/>
+              </a:spcAft>
+              <a:defRPr sz="800">
+                <a:solidFill>
+                  <a:srgbClr val="8B949E"/>
+                </a:solidFill>
+                <a:latin typeface="Consolas"/>
+              </a:defRPr>
+            </a:pPr>
+            <a:r>
+              <a:t>    │                                     │</a:t>
+            </a:r>
+          </a:p>
+          <a:p>
+            <a:pPr>
+              <a:lnSpc>
+                <a:spcPct val="100000"/>
+              </a:lnSpc>
+              <a:spcAft>
+                <a:spcPts val="0"/>
+              </a:spcAft>
+              <a:defRPr sz="800">
+                <a:solidFill>
+                  <a:srgbClr val="8B949E"/>
+                </a:solidFill>
+                <a:latin typeface="Consolas"/>
+              </a:defRPr>
+            </a:pPr>
+            <a:r>
+              <a:t>    └─────────────────────────────────────┘</a:t>
+            </a:r>
+          </a:p>
+          <a:p>
+            <a:pPr>
+              <a:lnSpc>
+                <a:spcPct val="100000"/>
+              </a:lnSpc>
+              <a:spcAft>
+                <a:spcPts val="0"/>
+              </a:spcAft>
+              <a:defRPr sz="800">
+                <a:solidFill>
+                  <a:srgbClr val="8B949E"/>
+                </a:solidFill>
+                <a:latin typeface="Consolas"/>
+              </a:defRPr>
+            </a:pPr>
+            <a:r>
+              <a:t>    │</a:t>
+            </a:r>
+          </a:p>
+          <a:p>
+            <a:pPr>
+              <a:lnSpc>
+                <a:spcPct val="100000"/>
+              </a:lnSpc>
+              <a:spcAft>
+                <a:spcPts val="0"/>
+              </a:spcAft>
+              <a:defRPr sz="800">
+                <a:solidFill>
+                  <a:srgbClr val="8B949E"/>
+                </a:solidFill>
+                <a:latin typeface="Consolas"/>
+              </a:defRPr>
+            </a:pPr>
+            <a:r>
+              <a:t>    ▼</a:t>
+            </a:r>
+          </a:p>
+          <a:p>
+            <a:pPr>
+              <a:lnSpc>
+                <a:spcPct val="100000"/>
+              </a:lnSpc>
+              <a:spcAft>
+                <a:spcPts val="0"/>
+              </a:spcAft>
+              <a:defRPr sz="800">
+                <a:solidFill>
+                  <a:srgbClr val="58A6FF"/>
+                </a:solidFill>
+                <a:latin typeface="Consolas"/>
+              </a:defRPr>
+            </a:pPr>
+            <a:r>
+              <a:t>┌─────────────────────────────────────────────────────────────────────────────────┐</a:t>
+            </a:r>
+          </a:p>
+          <a:p>
+            <a:pPr>
+              <a:lnSpc>
+                <a:spcPct val="100000"/>
+              </a:lnSpc>
+              <a:spcAft>
+                <a:spcPts val="0"/>
+              </a:spcAft>
+              <a:defRPr sz="800">
+                <a:solidFill>
+                  <a:srgbClr val="58A6FF"/>
+                </a:solidFill>
+                <a:latin typeface="Consolas"/>
+              </a:defRPr>
+            </a:pPr>
+            <a:r>
+              <a:t>│  PHASE 4: ANALYSIS &amp; COMPARISON (comparison_workflow.py)                        │</a:t>
+            </a:r>
+          </a:p>
+          <a:p>
+            <a:pPr>
+              <a:lnSpc>
+                <a:spcPct val="100000"/>
+              </a:lnSpc>
+              <a:spcAft>
+                <a:spcPts val="0"/>
+              </a:spcAft>
+              <a:defRPr sz="800">
+                <a:solidFill>
+                  <a:srgbClr val="C9D1D9"/>
+                </a:solidFill>
+                <a:latin typeface="Consolas"/>
+              </a:defRPr>
+            </a:pPr>
+            <a:r>
+              <a:t>│  ─────────────────────────────────────────────────────────────────────────────  │</a:t>
+            </a:r>
+          </a:p>
+          <a:p>
+            <a:pPr>
+              <a:lnSpc>
+                <a:spcPct val="100000"/>
+              </a:lnSpc>
+              <a:spcAft>
+                <a:spcPts val="0"/>
+              </a:spcAft>
+              <a:defRPr sz="800">
+                <a:solidFill>
+                  <a:srgbClr val="C9D1D9"/>
+                </a:solidFill>
+                <a:latin typeface="Consolas"/>
+              </a:defRPr>
+            </a:pPr>
+            <a:r>
+              <a:t>│  Load Results: Parse all results.json files from comparison_results/            │</a:t>
+            </a:r>
+          </a:p>
+          <a:p>
+            <a:pPr>
+              <a:lnSpc>
+                <a:spcPct val="100000"/>
+              </a:lnSpc>
+              <a:spcAft>
+                <a:spcPts val="0"/>
+              </a:spcAft>
+              <a:defRPr sz="800">
+                <a:solidFill>
+                  <a:srgbClr val="C9D1D9"/>
+                </a:solidFill>
+                <a:latin typeface="Consolas"/>
+              </a:defRPr>
+            </a:pPr>
+            <a:r>
+              <a:t>│  Find Baseline: Auto-detect b3lyp_6-31Gdp as reference                          │</a:t>
+            </a:r>
+          </a:p>
+          <a:p>
+            <a:pPr>
+              <a:lnSpc>
+                <a:spcPct val="100000"/>
+              </a:lnSpc>
+              <a:spcAft>
+                <a:spcPts val="0"/>
+              </a:spcAft>
+              <a:defRPr sz="800">
+                <a:solidFill>
+                  <a:srgbClr val="C9D1D9"/>
+                </a:solidFill>
+                <a:latin typeface="Consolas"/>
+              </a:defRPr>
+            </a:pPr>
+            <a:r>
+              <a:t>│  Statistical Metrics:                                                           │</a:t>
+            </a:r>
+          </a:p>
+          <a:p>
+            <a:pPr>
+              <a:lnSpc>
+                <a:spcPct val="100000"/>
+              </a:lnSpc>
+              <a:spcAft>
+                <a:spcPts val="0"/>
+              </a:spcAft>
+              <a:defRPr sz="800">
+                <a:solidFill>
+                  <a:srgbClr val="C9D1D9"/>
+                </a:solidFill>
+                <a:latin typeface="Consolas"/>
+              </a:defRPr>
+            </a:pPr>
+            <a:r>
+              <a:t>│    • MAE (Mean Absolute Error) in cm⁻¹                                          │</a:t>
+            </a:r>
+          </a:p>
+          <a:p>
+            <a:pPr>
+              <a:lnSpc>
+                <a:spcPct val="100000"/>
+              </a:lnSpc>
+              <a:spcAft>
+                <a:spcPts val="0"/>
+              </a:spcAft>
+              <a:defRPr sz="800">
+                <a:solidFill>
+                  <a:srgbClr val="C9D1D9"/>
+                </a:solidFill>
+                <a:latin typeface="Consolas"/>
+              </a:defRPr>
+            </a:pPr>
+            <a:r>
+              <a:t>│    • RMSE (Root Mean Square Error) in cm⁻¹                                      │</a:t>
+            </a:r>
+          </a:p>
+          <a:p>
+            <a:pPr>
+              <a:lnSpc>
+                <a:spcPct val="100000"/>
+              </a:lnSpc>
+              <a:spcAft>
+                <a:spcPts val="0"/>
+              </a:spcAft>
+              <a:defRPr sz="800">
+                <a:solidFill>
+                  <a:srgbClr val="C9D1D9"/>
+                </a:solidFill>
+                <a:latin typeface="Consolas"/>
+              </a:defRPr>
+            </a:pPr>
+            <a:r>
+              <a:t>│    • R² (Coefficient of Determination)                                          │</a:t>
+            </a:r>
+          </a:p>
+          <a:p>
+            <a:pPr>
+              <a:lnSpc>
+                <a:spcPct val="100000"/>
+              </a:lnSpc>
+              <a:spcAft>
+                <a:spcPts val="0"/>
+              </a:spcAft>
+              <a:defRPr sz="800">
+                <a:solidFill>
+                  <a:srgbClr val="C9D1D9"/>
+                </a:solidFill>
+                <a:latin typeface="Consolas"/>
+              </a:defRPr>
+            </a:pPr>
+            <a:r>
+              <a:t>│    • Linear regression: slope, intercept                                        │</a:t>
+            </a:r>
+          </a:p>
+          <a:p>
+            <a:pPr>
+              <a:lnSpc>
+                <a:spcPct val="100000"/>
+              </a:lnSpc>
+              <a:spcAft>
+                <a:spcPts val="0"/>
+              </a:spcAft>
+              <a:defRPr sz="800">
+                <a:solidFill>
+                  <a:srgbClr val="C9D1D9"/>
+                </a:solidFill>
+                <a:latin typeface="Consolas"/>
+              </a:defRPr>
+            </a:pPr>
+            <a:r>
+              <a:t>│  Visualizations:                                                                │</a:t>
+            </a:r>
+          </a:p>
+          <a:p>
+            <a:pPr>
+              <a:lnSpc>
+                <a:spcPct val="100000"/>
+              </a:lnSpc>
+              <a:spcAft>
+                <a:spcPts val="0"/>
+              </a:spcAft>
+              <a:defRPr sz="800">
+                <a:solidFill>
+                  <a:srgbClr val="C9D1D9"/>
+                </a:solidFill>
+                <a:latin typeface="Consolas"/>
+              </a:defRPr>
+            </a:pPr>
+            <a:r>
+              <a:t>│    • Regression plots: ML freq vs DFT freq (scatter + fit line)                 │</a:t>
+            </a:r>
+          </a:p>
+          <a:p>
+            <a:pPr>
+              <a:lnSpc>
+                <a:spcPct val="100000"/>
+              </a:lnSpc>
+              <a:spcAft>
+                <a:spcPts val="0"/>
+              </a:spcAft>
+              <a:defRPr sz="800">
+                <a:solidFill>
+                  <a:srgbClr val="C9D1D9"/>
+                </a:solidFill>
+                <a:latin typeface="Consolas"/>
+              </a:defRPr>
+            </a:pPr>
+            <a:r>
+              <a:t>│    • KDE spectra: Gaussian broadening (FWHM=8.0 cm⁻¹, grid 400-4000 cm⁻¹)      │</a:t>
+            </a:r>
+          </a:p>
+          <a:p>
+            <a:pPr>
+              <a:lnSpc>
+                <a:spcPct val="100000"/>
+              </a:lnSpc>
+              <a:spcAft>
+                <a:spcPts val="0"/>
+              </a:spcAft>
+              <a:defRPr sz="800">
+                <a:solidFill>
+                  <a:srgbClr val="C9D1D9"/>
+                </a:solidFill>
+                <a:latin typeface="Consolas"/>
+              </a:defRPr>
+            </a:pPr>
+            <a:r>
+              <a:t>│    • Combined comparison plots (all methods overlaid)                           │</a:t>
+            </a:r>
+          </a:p>
+          <a:p>
+            <a:pPr>
+              <a:lnSpc>
+                <a:spcPct val="100000"/>
+              </a:lnSpc>
+              <a:spcAft>
+                <a:spcPts val="0"/>
+              </a:spcAft>
+              <a:defRPr sz="800">
+                <a:solidFill>
+                  <a:srgbClr val="C9D1D9"/>
+                </a:solidFill>
+                <a:latin typeface="Consolas"/>
+              </a:defRPr>
+            </a:pPr>
+            <a:r>
+              <a:t>│  Output: {molecule}_spectral_analysis.html (interactive, publication-ready)     │</a:t>
+            </a:r>
+          </a:p>
+          <a:p>
+            <a:pPr>
+              <a:lnSpc>
+                <a:spcPct val="100000"/>
+              </a:lnSpc>
+              <a:spcAft>
+                <a:spcPts val="0"/>
+              </a:spcAft>
+              <a:defRPr sz="800">
+                <a:solidFill>
+                  <a:srgbClr val="58A6FF"/>
+                </a:solidFill>
+                <a:latin typeface="Consolas"/>
+              </a:defRPr>
+            </a:pPr>
+            <a:r>
+              <a:t>└─────────────────────────────────────────────────────────────────────────────────┘</a:t>
+            </a:r>
+          </a:p>
+        </p:txBody>
+      </p:sp>
+    </p:spTree>
+  </p:cSld>
+  <p:clrMapOvr>
+    <a:masterClrMapping/>
+  </p:clrMapOvr>
+</p:sld>
+</file>
+
+<file path=ppt/slides/slide6.xml><?xml version="1.0" encoding="utf-8"?>
+<p:sld xmlns:a="http://schemas.openxmlformats.org/drawingml/2006/main" xmlns:p="http://schemas.openxmlformats.org/presentationml/2006/main" xmlns:r="http://schemas.openxmlformats.org/officeDocument/2006/relationships">
+  <p:cSld>
+    <p:bg>
+      <p:bgPr>
+        <a:solidFill>
+          <a:srgbClr val="0D1117"/>
+        </a:solidFill>
+        <a:effectLst/>
+      </p:bgPr>
+    </p:bg>
+    <p:spTree>
+      <p:nvGrpSpPr>
+        <p:cNvPr id="1" name=""/>
+        <p:cNvGrpSpPr/>
+        <p:nvPr/>
+      </p:nvGrpSpPr>
+      <p:grpSpPr/>
+      <p:sp>
+        <p:nvSpPr>
+          <p:cNvPr id="2" name="TextBox 1"/>
+          <p:cNvSpPr txBox="1"/>
+          <p:nvPr/>
+        </p:nvSpPr>
+        <p:spPr>
+          <a:xfrm>
+            <a:off x="457200" y="274320"/>
+            <a:ext cx="8229600" cy="457200"/>
+          </a:xfrm>
+          <a:prstGeom prst="rect">
+            <a:avLst/>
+          </a:prstGeom>
+          <a:noFill/>
+        </p:spPr>
+        <p:txBody>
+          <a:bodyPr wrap="none">
+            <a:spAutoFit/>
+          </a:bodyPr>
+          <a:lstStyle/>
+          <a:p>
+            <a:pPr>
+              <a:defRPr sz="2400" b="1">
+                <a:solidFill>
+                  <a:srgbClr val="8B949E"/>
+                </a:solidFill>
+                <a:latin typeface="Consolas"/>
+              </a:defRPr>
+            </a:pPr>
+            <a:r>
+              <a:t>$ cat workflow_monochrome.txt</a:t>
+            </a:r>
+          </a:p>
+        </p:txBody>
+      </p:sp>
+      <p:sp>
+        <p:nvSpPr>
+          <p:cNvPr id="3" name="TextBox 2"/>
+          <p:cNvSpPr txBox="1"/>
+          <p:nvPr/>
+        </p:nvSpPr>
+        <p:spPr>
+          <a:xfrm>
+            <a:off x="274320" y="868680"/>
+            <a:ext cx="8595360" cy="5806440"/>
+          </a:xfrm>
+          <a:prstGeom prst="rect">
+            <a:avLst/>
+          </a:prstGeom>
+          <a:noFill/>
+        </p:spPr>
+        <p:txBody>
+          <a:bodyPr wrap="none">
+            <a:spAutoFit/>
+          </a:bodyPr>
+          <a:lstStyle/>
+          <a:p>
+            <a:pPr>
+              <a:lnSpc>
+                <a:spcPct val="100000"/>
+              </a:lnSpc>
+              <a:spcAft>
+                <a:spcPts val="0"/>
+              </a:spcAft>
+              <a:defRPr sz="800">
+                <a:solidFill>
+                  <a:srgbClr val="8B949E"/>
+                </a:solidFill>
+                <a:latin typeface="Consolas"/>
+              </a:defRPr>
+            </a:pPr>
+            <a:r>
+              <a:t>INPUT: molecule.xyz (Cartesian coordinates, atom types)</a:t>
+            </a:r>
+          </a:p>
+          <a:p>
+            <a:pPr>
+              <a:lnSpc>
+                <a:spcPct val="100000"/>
+              </a:lnSpc>
+              <a:spcAft>
+                <a:spcPts val="0"/>
+              </a:spcAft>
+              <a:defRPr sz="800">
+                <a:solidFill>
+                  <a:srgbClr val="8B949E"/>
+                </a:solidFill>
+                <a:latin typeface="Consolas"/>
+              </a:defRPr>
+            </a:pPr>
+            <a:r>
+              <a:t>    │</a:t>
+            </a:r>
+          </a:p>
+          <a:p>
+            <a:pPr>
+              <a:lnSpc>
+                <a:spcPct val="100000"/>
+              </a:lnSpc>
+              <a:spcAft>
+                <a:spcPts val="0"/>
+              </a:spcAft>
+              <a:defRPr sz="800">
+                <a:solidFill>
+                  <a:srgbClr val="8B949E"/>
+                </a:solidFill>
+                <a:latin typeface="Consolas"/>
+              </a:defRPr>
+            </a:pPr>
+            <a:r>
+              <a:t>    ▼</a:t>
+            </a:r>
+          </a:p>
+          <a:p>
+            <a:pPr>
+              <a:lnSpc>
+                <a:spcPct val="100000"/>
+              </a:lnSpc>
+              <a:spcAft>
+                <a:spcPts val="0"/>
+              </a:spcAft>
+              <a:defRPr sz="800">
+                <a:solidFill>
+                  <a:srgbClr val="8B949E"/>
+                </a:solidFill>
+                <a:latin typeface="Consolas"/>
+              </a:defRPr>
+            </a:pPr>
+            <a:r>
+              <a:t>┌─────────────────────────────────────────────────────────────────────────────────┐</a:t>
+            </a:r>
+          </a:p>
+          <a:p>
+            <a:pPr>
+              <a:lnSpc>
+                <a:spcPct val="100000"/>
+              </a:lnSpc>
+              <a:spcAft>
+                <a:spcPts val="0"/>
+              </a:spcAft>
+              <a:defRPr sz="800">
+                <a:solidFill>
+                  <a:srgbClr val="8B949E"/>
+                </a:solidFill>
+                <a:latin typeface="Consolas"/>
+              </a:defRPr>
+            </a:pPr>
+            <a:r>
+              <a:t>│  PHASE 1: GEOMETRY OPTIMIZATION                                                 │</a:t>
+            </a:r>
+          </a:p>
+          <a:p>
+            <a:pPr>
+              <a:lnSpc>
+                <a:spcPct val="100000"/>
+              </a:lnSpc>
+              <a:spcAft>
+                <a:spcPts val="0"/>
+              </a:spcAft>
+              <a:defRPr sz="800">
+                <a:solidFill>
+                  <a:srgbClr val="8B949E"/>
+                </a:solidFill>
+                <a:latin typeface="Consolas"/>
+              </a:defRPr>
+            </a:pPr>
+            <a:r>
+              <a:t>│  Calculator: MACE-OMOL (default) | Options: MACE-OFF, MACE-MP                  │</a:t>
+            </a:r>
+          </a:p>
+          <a:p>
+            <a:pPr>
+              <a:lnSpc>
+                <a:spcPct val="100000"/>
+              </a:lnSpc>
+              <a:spcAft>
+                <a:spcPts val="0"/>
+              </a:spcAft>
+              <a:defRPr sz="800">
+                <a:solidFill>
+                  <a:srgbClr val="8B949E"/>
+                </a:solidFill>
+                <a:latin typeface="Consolas"/>
+              </a:defRPr>
+            </a:pPr>
+            <a:r>
+              <a:t>│  Method: BFGS optimizer, force convergence 0.01 eV/Å                           │</a:t>
+            </a:r>
+          </a:p>
+          <a:p>
+            <a:pPr>
+              <a:lnSpc>
+                <a:spcPct val="100000"/>
+              </a:lnSpc>
+              <a:spcAft>
+                <a:spcPts val="0"/>
+              </a:spcAft>
+              <a:defRPr sz="800">
+                <a:solidFill>
+                  <a:srgbClr val="8B949E"/>
+                </a:solidFill>
+                <a:latin typeface="Consolas"/>
+              </a:defRPr>
+            </a:pPr>
+            <a:r>
+              <a:t>│  Output: optimized.xyz (relaxed structure), geometry_opt/results.json          │</a:t>
+            </a:r>
+          </a:p>
+          <a:p>
+            <a:pPr>
+              <a:lnSpc>
+                <a:spcPct val="100000"/>
+              </a:lnSpc>
+              <a:spcAft>
+                <a:spcPts val="0"/>
+              </a:spcAft>
+              <a:defRPr sz="800">
+                <a:solidFill>
+                  <a:srgbClr val="8B949E"/>
+                </a:solidFill>
+                <a:latin typeface="Consolas"/>
+              </a:defRPr>
+            </a:pPr>
+            <a:r>
+              <a:t>│  Metrics: initial_energy, final_energy, n_steps, convergence_status            │</a:t>
+            </a:r>
+          </a:p>
+          <a:p>
+            <a:pPr>
+              <a:lnSpc>
+                <a:spcPct val="100000"/>
+              </a:lnSpc>
+              <a:spcAft>
+                <a:spcPts val="0"/>
+              </a:spcAft>
+              <a:defRPr sz="800">
+                <a:solidFill>
+                  <a:srgbClr val="8B949E"/>
+                </a:solidFill>
+                <a:latin typeface="Consolas"/>
+              </a:defRPr>
+            </a:pPr>
+            <a:r>
+              <a:t>└─────────────────────────────────────────────────────────────────────────────────┘</a:t>
+            </a:r>
+          </a:p>
+          <a:p>
+            <a:pPr>
+              <a:lnSpc>
+                <a:spcPct val="100000"/>
+              </a:lnSpc>
+              <a:spcAft>
+                <a:spcPts val="0"/>
+              </a:spcAft>
+              <a:defRPr sz="800">
+                <a:solidFill>
+                  <a:srgbClr val="8B949E"/>
+                </a:solidFill>
+                <a:latin typeface="Consolas"/>
+              </a:defRPr>
+            </a:pPr>
+            <a:r>
+              <a:t>    │</a:t>
+            </a:r>
+          </a:p>
+          <a:p>
+            <a:pPr>
+              <a:lnSpc>
+                <a:spcPct val="100000"/>
+              </a:lnSpc>
+              <a:spcAft>
+                <a:spcPts val="0"/>
+              </a:spcAft>
+              <a:defRPr sz="800">
+                <a:solidFill>
+                  <a:srgbClr val="8B949E"/>
+                </a:solidFill>
+                <a:latin typeface="Consolas"/>
+              </a:defRPr>
+            </a:pPr>
+            <a:r>
+              <a:t>    ├─────────────────────────────────────┬──────────────────────────────────────┐</a:t>
+            </a:r>
+          </a:p>
+          <a:p>
+            <a:pPr>
+              <a:lnSpc>
+                <a:spcPct val="100000"/>
+              </a:lnSpc>
+              <a:spcAft>
+                <a:spcPts val="0"/>
+              </a:spcAft>
+              <a:defRPr sz="800">
+                <a:solidFill>
+                  <a:srgbClr val="8B949E"/>
+                </a:solidFill>
+                <a:latin typeface="Consolas"/>
+              </a:defRPr>
+            </a:pPr>
+            <a:r>
+              <a:t>    │                                     │                                      │</a:t>
+            </a:r>
+          </a:p>
+          <a:p>
+            <a:pPr>
+              <a:lnSpc>
+                <a:spcPct val="100000"/>
+              </a:lnSpc>
+              <a:spcAft>
+                <a:spcPts val="0"/>
+              </a:spcAft>
+              <a:defRPr sz="800">
+                <a:solidFill>
+                  <a:srgbClr val="8B949E"/>
+                </a:solidFill>
+                <a:latin typeface="Consolas"/>
+              </a:defRPr>
+            </a:pPr>
+            <a:r>
+              <a:t>    │ (optional, --skip-dft-baseline)     │ (default: True)                      │</a:t>
+            </a:r>
+          </a:p>
+          <a:p>
+            <a:pPr>
+              <a:lnSpc>
+                <a:spcPct val="100000"/>
+              </a:lnSpc>
+              <a:spcAft>
+                <a:spcPts val="0"/>
+              </a:spcAft>
+              <a:defRPr sz="800">
+                <a:solidFill>
+                  <a:srgbClr val="8B949E"/>
+                </a:solidFill>
+                <a:latin typeface="Consolas"/>
+              </a:defRPr>
+            </a:pPr>
+            <a:r>
+              <a:t>    ▼                                     ▼                                      ▼</a:t>
+            </a:r>
+          </a:p>
+          <a:p>
+            <a:pPr>
+              <a:lnSpc>
+                <a:spcPct val="100000"/>
+              </a:lnSpc>
+              <a:spcAft>
+                <a:spcPts val="0"/>
+              </a:spcAft>
+              <a:defRPr sz="800">
+                <a:solidFill>
+                  <a:srgbClr val="8B949E"/>
+                </a:solidFill>
+                <a:latin typeface="Consolas"/>
+              </a:defRPr>
+            </a:pPr>
+            <a:r>
+              <a:t>┌───────────────────────┐  ┌──────────────────────────────────────────────────────────────┐</a:t>
+            </a:r>
+          </a:p>
+          <a:p>
+            <a:pPr>
+              <a:lnSpc>
+                <a:spcPct val="100000"/>
+              </a:lnSpc>
+              <a:spcAft>
+                <a:spcPts val="0"/>
+              </a:spcAft>
+              <a:defRPr sz="800">
+                <a:solidFill>
+                  <a:srgbClr val="8B949E"/>
+                </a:solidFill>
+                <a:latin typeface="Consolas"/>
+              </a:defRPr>
+            </a:pPr>
+            <a:r>
+              <a:t>│  PHASE 2: DFT         │  │  PHASE 3: ML FREQUENCY CALCULATIONS                          │</a:t>
+            </a:r>
+          </a:p>
+          <a:p>
+            <a:pPr>
+              <a:lnSpc>
+                <a:spcPct val="100000"/>
+              </a:lnSpc>
+              <a:spcAft>
+                <a:spcPts val="0"/>
+              </a:spcAft>
+              <a:defRPr sz="800">
+                <a:solidFill>
+                  <a:srgbClr val="8B949E"/>
+                </a:solidFill>
+                <a:latin typeface="Consolas"/>
+              </a:defRPr>
+            </a:pPr>
+            <a:r>
+              <a:t>│  BASELINE             │  │  Configuration: --energy-calculators, --dipole-calculators   │</a:t>
+            </a:r>
+          </a:p>
+          <a:p>
+            <a:pPr>
+              <a:lnSpc>
+                <a:spcPct val="100000"/>
+              </a:lnSpc>
+              <a:spcAft>
+                <a:spcPts val="0"/>
+              </a:spcAft>
+              <a:defRPr sz="800">
+                <a:solidFill>
+                  <a:srgbClr val="8B949E"/>
+                </a:solidFill>
+                <a:latin typeface="Consolas"/>
+              </a:defRPr>
+            </a:pPr>
+            <a:r>
+              <a:t>│  ─────────────────    │  │  ─────────────────────────────────────────────────────────   │</a:t>
+            </a:r>
+          </a:p>
+          <a:p>
+            <a:pPr>
+              <a:lnSpc>
+                <a:spcPct val="100000"/>
+              </a:lnSpc>
+              <a:spcAft>
+                <a:spcPts val="0"/>
+              </a:spcAft>
+              <a:defRPr sz="800">
+                <a:solidFill>
+                  <a:srgbClr val="8B949E"/>
+                </a:solidFill>
+                <a:latin typeface="Consolas"/>
+              </a:defRPr>
+            </a:pPr>
+            <a:r>
+              <a:t>│  Method: B3LYP        │  │  Energy Calculators:                                         │</a:t>
+            </a:r>
+          </a:p>
+          <a:p>
+            <a:pPr>
+              <a:lnSpc>
+                <a:spcPct val="100000"/>
+              </a:lnSpc>
+              <a:spcAft>
+                <a:spcPts val="0"/>
+              </a:spcAft>
+              <a:defRPr sz="800">
+                <a:solidFill>
+                  <a:srgbClr val="8B949E"/>
+                </a:solidFill>
+                <a:latin typeface="Consolas"/>
+              </a:defRPr>
+            </a:pPr>
+            <a:r>
+              <a:t>│  Basis: 6-31G(d,p)    │  │    • MACE-MP (large, 2M params, general chemistry)           │</a:t>
+            </a:r>
+          </a:p>
+          <a:p>
+            <a:pPr>
+              <a:lnSpc>
+                <a:spcPct val="100000"/>
+              </a:lnSpc>
+              <a:spcAft>
+                <a:spcPts val="0"/>
+              </a:spcAft>
+              <a:defRPr sz="800">
+                <a:solidFill>
+                  <a:srgbClr val="8B949E"/>
+                </a:solidFill>
+                <a:latin typeface="Consolas"/>
+              </a:defRPr>
+            </a:pPr>
+            <a:r>
+              <a:t>│  Freq: Harmonic       │  │    • MACE-OMOL (molecules, 1.5M params, organic focus)       │</a:t>
+            </a:r>
+          </a:p>
+          <a:p>
+            <a:pPr>
+              <a:lnSpc>
+                <a:spcPct val="100000"/>
+              </a:lnSpc>
+              <a:spcAft>
+                <a:spcPts val="0"/>
+              </a:spcAft>
+              <a:defRPr sz="800">
+                <a:solidFill>
+                  <a:srgbClr val="8B949E"/>
+                </a:solidFill>
+                <a:latin typeface="Consolas"/>
+              </a:defRPr>
+            </a:pPr>
+            <a:r>
+              <a:t>│  Program: Gaussian 16 │  │  Dipole Calculators (with automatic fallback):               │</a:t>
+            </a:r>
+          </a:p>
+          <a:p>
+            <a:pPr>
+              <a:lnSpc>
+                <a:spcPct val="100000"/>
+              </a:lnSpc>
+              <a:spcAft>
+                <a:spcPts val="0"/>
+              </a:spcAft>
+              <a:defRPr sz="800">
+                <a:solidFill>
+                  <a:srgbClr val="8B949E"/>
+                </a:solidFill>
+                <a:latin typeface="Consolas"/>
+              </a:defRPr>
+            </a:pPr>
+            <a:r>
+              <a:t>│                       │  │    1. MACE-ML: Custom dipole model (~/dipole_model/)         │</a:t>
+            </a:r>
+          </a:p>
+          <a:p>
+            <a:pPr>
+              <a:lnSpc>
+                <a:spcPct val="100000"/>
+              </a:lnSpc>
+              <a:spcAft>
+                <a:spcPts val="0"/>
+              </a:spcAft>
+              <a:defRPr sz="800">
+                <a:solidFill>
+                  <a:srgbClr val="8B949E"/>
+                </a:solidFill>
+                <a:latin typeface="Consolas"/>
+              </a:defRPr>
+            </a:pPr>
+            <a:r>
+              <a:t>│  Output:              │  │    2. Espaloma: Charge-based (Σ qᵢrᵢ)                        │</a:t>
+            </a:r>
+          </a:p>
+          <a:p>
+            <a:pPr>
+              <a:lnSpc>
+                <a:spcPct val="100000"/>
+              </a:lnSpc>
+              <a:spcAft>
+                <a:spcPts val="0"/>
+              </a:spcAft>
+              <a:defRPr sz="800">
+                <a:solidFill>
+                  <a:srgbClr val="8B949E"/>
+                </a:solidFill>
+                <a:latin typeface="Consolas"/>
+              </a:defRPr>
+            </a:pPr>
+            <a:r>
+              <a:t>│  b3lyp_6-31Gdp/       │  │    3. xTB: GFN2-xTB semi-empirical                           │</a:t>
+            </a:r>
+          </a:p>
+          <a:p>
+            <a:pPr>
+              <a:lnSpc>
+                <a:spcPct val="100000"/>
+              </a:lnSpc>
+              <a:spcAft>
+                <a:spcPts val="0"/>
+              </a:spcAft>
+              <a:defRPr sz="800">
+                <a:solidFill>
+                  <a:srgbClr val="8B949E"/>
+                </a:solidFill>
+                <a:latin typeface="Consolas"/>
+              </a:defRPr>
+            </a:pPr>
+            <a:r>
+              <a:t>│  results.json         │  │  ┌────────────────────────────────────────────────────────┐  │</a:t>
+            </a:r>
+          </a:p>
+          <a:p>
+            <a:pPr>
+              <a:lnSpc>
+                <a:spcPct val="100000"/>
+              </a:lnSpc>
+              <a:spcAft>
+                <a:spcPts val="0"/>
+              </a:spcAft>
+              <a:defRPr sz="800">
+                <a:solidFill>
+                  <a:srgbClr val="8B949E"/>
+                </a:solidFill>
+                <a:latin typeface="Consolas"/>
+              </a:defRPr>
+            </a:pPr>
+            <a:r>
+              <a:t>│  ├─ frequencies[]     │  │  │  ZMQ BRIDGE ARCHITECTURE (IPC)                         │  │</a:t>
+            </a:r>
+          </a:p>
+          <a:p>
+            <a:pPr>
+              <a:lnSpc>
+                <a:spcPct val="100000"/>
+              </a:lnSpc>
+              <a:spcAft>
+                <a:spcPts val="0"/>
+              </a:spcAft>
+              <a:defRPr sz="800">
+                <a:solidFill>
+                  <a:srgbClr val="8B949E"/>
+                </a:solidFill>
+                <a:latin typeface="Consolas"/>
+              </a:defRPr>
+            </a:pPr>
+            <a:r>
+              <a:t>│  ├─ intensities[]     │  │  │  ─────────────────────────────────                     │  │</a:t>
+            </a:r>
+          </a:p>
+          <a:p>
+            <a:pPr>
+              <a:lnSpc>
+                <a:spcPct val="100000"/>
+              </a:lnSpc>
+              <a:spcAft>
+                <a:spcPts val="0"/>
+              </a:spcAft>
+              <a:defRPr sz="800">
+                <a:solidFill>
+                  <a:srgbClr val="8B949E"/>
+                </a:solidFill>
+                <a:latin typeface="Consolas"/>
+              </a:defRPr>
+            </a:pPr>
+            <a:r>
+              <a:t>│  └─ runtime_s         │  │  │  Main Process (gm_main.py):                            │  │</a:t>
+            </a:r>
+          </a:p>
+          <a:p>
+            <a:pPr>
+              <a:lnSpc>
+                <a:spcPct val="100000"/>
+              </a:lnSpc>
+              <a:spcAft>
+                <a:spcPts val="0"/>
+              </a:spcAft>
+              <a:defRPr sz="800">
+                <a:solidFill>
+                  <a:srgbClr val="8B949E"/>
+                </a:solidFill>
+                <a:latin typeface="Consolas"/>
+              </a:defRPr>
+            </a:pPr>
+            <a:r>
+              <a:t>│                       │  │  │    • Binds ZMQ server socket (.ipc_file)               │  │</a:t>
+            </a:r>
+          </a:p>
+          <a:p>
+            <a:pPr>
+              <a:lnSpc>
+                <a:spcPct val="100000"/>
+              </a:lnSpc>
+              <a:spcAft>
+                <a:spcPts val="0"/>
+              </a:spcAft>
+              <a:defRPr sz="800">
+                <a:solidFill>
+                  <a:srgbClr val="8B949E"/>
+                </a:solidFill>
+                <a:latin typeface="Consolas"/>
+              </a:defRPr>
+            </a:pPr>
+            <a:r>
+              <a:t>└───────────────────────┘  │  │    • Loads ML dipole calculator                        │  │</a:t>
+            </a:r>
+          </a:p>
+          <a:p>
+            <a:pPr>
+              <a:lnSpc>
+                <a:spcPct val="100000"/>
+              </a:lnSpc>
+              <a:spcAft>
+                <a:spcPts val="0"/>
+              </a:spcAft>
+              <a:defRPr sz="800">
+                <a:solidFill>
+                  <a:srgbClr val="8B949E"/>
+                </a:solidFill>
+                <a:latin typeface="Consolas"/>
+              </a:defRPr>
+            </a:pPr>
+            <a:r>
+              <a:t>    │                      │  │    • Waits for geometry requests                       │  │</a:t>
+            </a:r>
+          </a:p>
+          <a:p>
+            <a:pPr>
+              <a:lnSpc>
+                <a:spcPct val="100000"/>
+              </a:lnSpc>
+              <a:spcAft>
+                <a:spcPts val="0"/>
+              </a:spcAft>
+              <a:defRPr sz="800">
+                <a:solidFill>
+                  <a:srgbClr val="8B949E"/>
+                </a:solidFill>
+                <a:latin typeface="Consolas"/>
+              </a:defRPr>
+            </a:pPr>
+            <a:r>
+              <a:t>    │                      │  │    • Computes dipole derivatives                       │  │</a:t>
+            </a:r>
+          </a:p>
+          <a:p>
+            <a:pPr>
+              <a:lnSpc>
+                <a:spcPct val="100000"/>
+              </a:lnSpc>
+              <a:spcAft>
+                <a:spcPts val="0"/>
+              </a:spcAft>
+              <a:defRPr sz="800">
+                <a:solidFill>
+                  <a:srgbClr val="8B949E"/>
+                </a:solidFill>
+                <a:latin typeface="Consolas"/>
+              </a:defRPr>
+            </a:pPr>
+            <a:r>
+              <a:t>    │                      │  │    • Writes Gaussian-format output                     │  │</a:t>
+            </a:r>
+          </a:p>
+          <a:p>
+            <a:pPr>
+              <a:lnSpc>
+                <a:spcPct val="100000"/>
+              </a:lnSpc>
+              <a:spcAft>
+                <a:spcPts val="0"/>
+              </a:spcAft>
+              <a:defRPr sz="800">
+                <a:solidFill>
+                  <a:srgbClr val="8B949E"/>
+                </a:solidFill>
+                <a:latin typeface="Consolas"/>
+              </a:defRPr>
+            </a:pPr>
+            <a:r>
+              <a:t>    │                      │  │  Helper Script (gm_helper.py):                         │  │</a:t>
+            </a:r>
+          </a:p>
+          <a:p>
+            <a:pPr>
+              <a:lnSpc>
+                <a:spcPct val="100000"/>
+              </a:lnSpc>
+              <a:spcAft>
+                <a:spcPts val="0"/>
+              </a:spcAft>
+              <a:defRPr sz="800">
+                <a:solidFill>
+                  <a:srgbClr val="8B949E"/>
+                </a:solidFill>
+                <a:latin typeface="Consolas"/>
+              </a:defRPr>
+            </a:pPr>
+            <a:r>
+              <a:t>    │                      │  │    • Launched by Gaussian External directive           │  │</a:t>
+            </a:r>
+          </a:p>
+          <a:p>
+            <a:pPr>
+              <a:lnSpc>
+                <a:spcPct val="100000"/>
+              </a:lnSpc>
+              <a:spcAft>
+                <a:spcPts val="0"/>
+              </a:spcAft>
+              <a:defRPr sz="800">
+                <a:solidFill>
+                  <a:srgbClr val="8B949E"/>
+                </a:solidFill>
+                <a:latin typeface="Consolas"/>
+              </a:defRPr>
+            </a:pPr>
+            <a:r>
+              <a:t>    │                      │  │    • Connects to ZMQ socket                            │  │</a:t>
+            </a:r>
+          </a:p>
+          <a:p>
+            <a:pPr>
+              <a:lnSpc>
+                <a:spcPct val="100000"/>
+              </a:lnSpc>
+              <a:spcAft>
+                <a:spcPts val="0"/>
+              </a:spcAft>
+              <a:defRPr sz="800">
+                <a:solidFill>
+                  <a:srgbClr val="8B949E"/>
+                </a:solidFill>
+                <a:latin typeface="Consolas"/>
+              </a:defRPr>
+            </a:pPr>
+            <a:r>
+              <a:t>    │                      │  │    • Sends: 'infile|outfile'                           │  │</a:t>
+            </a:r>
+          </a:p>
+          <a:p>
+            <a:pPr>
+              <a:lnSpc>
+                <a:spcPct val="100000"/>
+              </a:lnSpc>
+              <a:spcAft>
+                <a:spcPts val="0"/>
+              </a:spcAft>
+              <a:defRPr sz="800">
+                <a:solidFill>
+                  <a:srgbClr val="8B949E"/>
+                </a:solidFill>
+                <a:latin typeface="Consolas"/>
+              </a:defRPr>
+            </a:pPr>
+            <a:r>
+              <a:t>    │                      │  │    • Waits for: 'done' signal                          │  │</a:t>
+            </a:r>
+          </a:p>
+          <a:p>
+            <a:pPr>
+              <a:lnSpc>
+                <a:spcPct val="100000"/>
+              </a:lnSpc>
+              <a:spcAft>
+                <a:spcPts val="0"/>
+              </a:spcAft>
+              <a:defRPr sz="800">
+                <a:solidFill>
+                  <a:srgbClr val="8B949E"/>
+                </a:solidFill>
+                <a:latin typeface="Consolas"/>
+              </a:defRPr>
+            </a:pPr>
+            <a:r>
+              <a:t>    │                      │  │    • Returns control to Gaussian                       │  │</a:t>
+            </a:r>
+          </a:p>
+          <a:p>
+            <a:pPr>
+              <a:lnSpc>
+                <a:spcPct val="100000"/>
+              </a:lnSpc>
+              <a:spcAft>
+                <a:spcPts val="0"/>
+              </a:spcAft>
+              <a:defRPr sz="800">
+                <a:solidFill>
+                  <a:srgbClr val="8B949E"/>
+                </a:solidFill>
+                <a:latin typeface="Consolas"/>
+              </a:defRPr>
+            </a:pPr>
+            <a:r>
+              <a:t>    │                      │  │  Gaussian 16:                                          │  │</a:t>
+            </a:r>
+          </a:p>
+          <a:p>
+            <a:pPr>
+              <a:lnSpc>
+                <a:spcPct val="100000"/>
+              </a:lnSpc>
+              <a:spcAft>
+                <a:spcPts val="0"/>
+              </a:spcAft>
+              <a:defRPr sz="800">
+                <a:solidFill>
+                  <a:srgbClr val="8B949E"/>
+                </a:solidFill>
+                <a:latin typeface="Consolas"/>
+              </a:defRPr>
+            </a:pPr>
+            <a:r>
+              <a:t>    │                      │  │    • Freq calculation (harmonic/anharmonic)            │  │</a:t>
+            </a:r>
+          </a:p>
+          <a:p>
+            <a:pPr>
+              <a:lnSpc>
+                <a:spcPct val="100000"/>
+              </a:lnSpc>
+              <a:spcAft>
+                <a:spcPts val="0"/>
+              </a:spcAft>
+              <a:defRPr sz="800">
+                <a:solidFill>
+                  <a:srgbClr val="8B949E"/>
+                </a:solidFill>
+                <a:latin typeface="Consolas"/>
+              </a:defRPr>
+            </a:pPr>
+            <a:r>
+              <a:t>    │                      │  │    • Calls external for each geometry                  │  │</a:t>
+            </a:r>
+          </a:p>
+          <a:p>
+            <a:pPr>
+              <a:lnSpc>
+                <a:spcPct val="100000"/>
+              </a:lnSpc>
+              <a:spcAft>
+                <a:spcPts val="0"/>
+              </a:spcAft>
+              <a:defRPr sz="800">
+                <a:solidFill>
+                  <a:srgbClr val="8B949E"/>
+                </a:solidFill>
+                <a:latin typeface="Consolas"/>
+              </a:defRPr>
+            </a:pPr>
+            <a:r>
+              <a:t>    │                      │  └────────────────────────────────────────────────────────┘  │</a:t>
+            </a:r>
+          </a:p>
+          <a:p>
+            <a:pPr>
+              <a:lnSpc>
+                <a:spcPct val="100000"/>
+              </a:lnSpc>
+              <a:spcAft>
+                <a:spcPts val="0"/>
+              </a:spcAft>
+              <a:defRPr sz="800">
+                <a:solidFill>
+                  <a:srgbClr val="8B949E"/>
+                </a:solidFill>
+                <a:latin typeface="Consolas"/>
+              </a:defRPr>
+            </a:pPr>
+            <a:r>
+              <a:t>    │                      │  Combinations tested (4 total):                              │</a:t>
+            </a:r>
+          </a:p>
+          <a:p>
+            <a:pPr>
+              <a:lnSpc>
+                <a:spcPct val="100000"/>
+              </a:lnSpc>
+              <a:spcAft>
+                <a:spcPts val="0"/>
+              </a:spcAft>
+              <a:defRPr sz="800">
+                <a:solidFill>
+                  <a:srgbClr val="8B949E"/>
+                </a:solidFill>
+                <a:latin typeface="Consolas"/>
+              </a:defRPr>
+            </a:pPr>
+            <a:r>
+              <a:t>    │                      │    • mace_mp_espaloma/results.json                           │</a:t>
+            </a:r>
+          </a:p>
+          <a:p>
+            <a:pPr>
+              <a:lnSpc>
+                <a:spcPct val="100000"/>
+              </a:lnSpc>
+              <a:spcAft>
+                <a:spcPts val="0"/>
+              </a:spcAft>
+              <a:defRPr sz="800">
+                <a:solidFill>
+                  <a:srgbClr val="8B949E"/>
+                </a:solidFill>
+                <a:latin typeface="Consolas"/>
+              </a:defRPr>
+            </a:pPr>
+            <a:r>
+              <a:t>    │                      │    • mace_mp_mace_ml/results.json                            │</a:t>
+            </a:r>
+          </a:p>
+          <a:p>
+            <a:pPr>
+              <a:lnSpc>
+                <a:spcPct val="100000"/>
+              </a:lnSpc>
+              <a:spcAft>
+                <a:spcPts val="0"/>
+              </a:spcAft>
+              <a:defRPr sz="800">
+                <a:solidFill>
+                  <a:srgbClr val="8B949E"/>
+                </a:solidFill>
+                <a:latin typeface="Consolas"/>
+              </a:defRPr>
+            </a:pPr>
+            <a:r>
+              <a:t>    │                      │    • mace_omol_espaloma/results.json                         │</a:t>
+            </a:r>
+          </a:p>
+          <a:p>
+            <a:pPr>
+              <a:lnSpc>
+                <a:spcPct val="100000"/>
+              </a:lnSpc>
+              <a:spcAft>
+                <a:spcPts val="0"/>
+              </a:spcAft>
+              <a:defRPr sz="800">
+                <a:solidFill>
+                  <a:srgbClr val="8B949E"/>
+                </a:solidFill>
+                <a:latin typeface="Consolas"/>
+              </a:defRPr>
+            </a:pPr>
+            <a:r>
+              <a:t>    │                      │    • mace_omol_mace_ml/results.json                          │</a:t>
+            </a:r>
+          </a:p>
+          <a:p>
+            <a:pPr>
+              <a:lnSpc>
+                <a:spcPct val="100000"/>
+              </a:lnSpc>
+              <a:spcAft>
+                <a:spcPts val="0"/>
+              </a:spcAft>
+              <a:defRPr sz="800">
+                <a:solidFill>
+                  <a:srgbClr val="8B949E"/>
+                </a:solidFill>
+                <a:latin typeface="Consolas"/>
+              </a:defRPr>
+            </a:pPr>
+            <a:r>
+              <a:t>    │                      └──────────────────────────────────────────────────────────────┘</a:t>
+            </a:r>
+          </a:p>
+          <a:p>
+            <a:pPr>
+              <a:lnSpc>
+                <a:spcPct val="100000"/>
+              </a:lnSpc>
+              <a:spcAft>
+                <a:spcPts val="0"/>
+              </a:spcAft>
+              <a:defRPr sz="800">
+                <a:solidFill>
+                  <a:srgbClr val="8B949E"/>
+                </a:solidFill>
+                <a:latin typeface="Consolas"/>
+              </a:defRPr>
+            </a:pPr>
+            <a:r>
+              <a:t>    │                                     │</a:t>
+            </a:r>
+          </a:p>
+          <a:p>
+            <a:pPr>
+              <a:lnSpc>
+                <a:spcPct val="100000"/>
+              </a:lnSpc>
+              <a:spcAft>
+                <a:spcPts val="0"/>
+              </a:spcAft>
+              <a:defRPr sz="800">
+                <a:solidFill>
+                  <a:srgbClr val="8B949E"/>
+                </a:solidFill>
+                <a:latin typeface="Consolas"/>
+              </a:defRPr>
+            </a:pPr>
+            <a:r>
+              <a:t>    └─────────────────────────────────────┘</a:t>
+            </a:r>
+          </a:p>
+          <a:p>
+            <a:pPr>
+              <a:lnSpc>
+                <a:spcPct val="100000"/>
+              </a:lnSpc>
+              <a:spcAft>
+                <a:spcPts val="0"/>
+              </a:spcAft>
+              <a:defRPr sz="800">
+                <a:solidFill>
+                  <a:srgbClr val="8B949E"/>
+                </a:solidFill>
+                <a:latin typeface="Consolas"/>
+              </a:defRPr>
+            </a:pPr>
+            <a:r>
+              <a:t>    │</a:t>
+            </a:r>
+          </a:p>
+          <a:p>
+            <a:pPr>
+              <a:lnSpc>
+                <a:spcPct val="100000"/>
+              </a:lnSpc>
+              <a:spcAft>
+                <a:spcPts val="0"/>
+              </a:spcAft>
+              <a:defRPr sz="800">
+                <a:solidFill>
+                  <a:srgbClr val="8B949E"/>
+                </a:solidFill>
+                <a:latin typeface="Consolas"/>
+              </a:defRPr>
+            </a:pPr>
+            <a:r>
+              <a:t>    ▼</a:t>
+            </a:r>
+          </a:p>
+          <a:p>
+            <a:pPr>
+              <a:lnSpc>
+                <a:spcPct val="100000"/>
+              </a:lnSpc>
+              <a:spcAft>
+                <a:spcPts val="0"/>
+              </a:spcAft>
+              <a:defRPr sz="800">
+                <a:solidFill>
+                  <a:srgbClr val="8B949E"/>
+                </a:solidFill>
+                <a:latin typeface="Consolas"/>
+              </a:defRPr>
+            </a:pPr>
+            <a:r>
+              <a:t>┌─────────────────────────────────────────────────────────────────────────────────┐</a:t>
+            </a:r>
+          </a:p>
+          <a:p>
+            <a:pPr>
+              <a:lnSpc>
+                <a:spcPct val="100000"/>
+              </a:lnSpc>
+              <a:spcAft>
+                <a:spcPts val="0"/>
+              </a:spcAft>
+              <a:defRPr sz="800">
+                <a:solidFill>
+                  <a:srgbClr val="8B949E"/>
+                </a:solidFill>
+                <a:latin typeface="Consolas"/>
+              </a:defRPr>
+            </a:pPr>
+            <a:r>
+              <a:t>│  PHASE 4: ANALYSIS &amp; COMPARISON (comparison_workflow.py)                        │</a:t>
+            </a:r>
+          </a:p>
+          <a:p>
+            <a:pPr>
+              <a:lnSpc>
+                <a:spcPct val="100000"/>
+              </a:lnSpc>
+              <a:spcAft>
+                <a:spcPts val="0"/>
+              </a:spcAft>
+              <a:defRPr sz="800">
+                <a:solidFill>
+                  <a:srgbClr val="8B949E"/>
+                </a:solidFill>
+                <a:latin typeface="Consolas"/>
+              </a:defRPr>
+            </a:pPr>
+            <a:r>
+              <a:t>│  ─────────────────────────────────────────────────────────────────────────────  │</a:t>
+            </a:r>
+          </a:p>
+          <a:p>
+            <a:pPr>
+              <a:lnSpc>
+                <a:spcPct val="100000"/>
+              </a:lnSpc>
+              <a:spcAft>
+                <a:spcPts val="0"/>
+              </a:spcAft>
+              <a:defRPr sz="800">
+                <a:solidFill>
+                  <a:srgbClr val="8B949E"/>
+                </a:solidFill>
+                <a:latin typeface="Consolas"/>
+              </a:defRPr>
+            </a:pPr>
+            <a:r>
+              <a:t>│  Load Results: Parse all results.json files from comparison_results/            │</a:t>
+            </a:r>
+          </a:p>
+          <a:p>
+            <a:pPr>
+              <a:lnSpc>
+                <a:spcPct val="100000"/>
+              </a:lnSpc>
+              <a:spcAft>
+                <a:spcPts val="0"/>
+              </a:spcAft>
+              <a:defRPr sz="800">
+                <a:solidFill>
+                  <a:srgbClr val="8B949E"/>
+                </a:solidFill>
+                <a:latin typeface="Consolas"/>
+              </a:defRPr>
+            </a:pPr>
+            <a:r>
+              <a:t>│  Find Baseline: Auto-detect b3lyp_6-31Gdp as reference                          │</a:t>
+            </a:r>
+          </a:p>
+          <a:p>
+            <a:pPr>
+              <a:lnSpc>
+                <a:spcPct val="100000"/>
+              </a:lnSpc>
+              <a:spcAft>
+                <a:spcPts val="0"/>
+              </a:spcAft>
+              <a:defRPr sz="800">
+                <a:solidFill>
+                  <a:srgbClr val="8B949E"/>
+                </a:solidFill>
+                <a:latin typeface="Consolas"/>
+              </a:defRPr>
+            </a:pPr>
+            <a:r>
+              <a:t>│  Statistical Metrics:                                                           │</a:t>
+            </a:r>
+          </a:p>
+          <a:p>
+            <a:pPr>
+              <a:lnSpc>
+                <a:spcPct val="100000"/>
+              </a:lnSpc>
+              <a:spcAft>
+                <a:spcPts val="0"/>
+              </a:spcAft>
+              <a:defRPr sz="800">
+                <a:solidFill>
+                  <a:srgbClr val="8B949E"/>
+                </a:solidFill>
+                <a:latin typeface="Consolas"/>
+              </a:defRPr>
+            </a:pPr>
+            <a:r>
+              <a:t>│    • MAE (Mean Absolute Error) in cm⁻¹                                          │</a:t>
+            </a:r>
+          </a:p>
+          <a:p>
+            <a:pPr>
+              <a:lnSpc>
+                <a:spcPct val="100000"/>
+              </a:lnSpc>
+              <a:spcAft>
+                <a:spcPts val="0"/>
+              </a:spcAft>
+              <a:defRPr sz="800">
+                <a:solidFill>
+                  <a:srgbClr val="8B949E"/>
+                </a:solidFill>
+                <a:latin typeface="Consolas"/>
+              </a:defRPr>
+            </a:pPr>
+            <a:r>
+              <a:t>│    • RMSE (Root Mean Square Error) in cm⁻¹                                      │</a:t>
+            </a:r>
+          </a:p>
+          <a:p>
+            <a:pPr>
+              <a:lnSpc>
+                <a:spcPct val="100000"/>
+              </a:lnSpc>
+              <a:spcAft>
+                <a:spcPts val="0"/>
+              </a:spcAft>
+              <a:defRPr sz="800">
+                <a:solidFill>
+                  <a:srgbClr val="8B949E"/>
+                </a:solidFill>
+                <a:latin typeface="Consolas"/>
+              </a:defRPr>
+            </a:pPr>
+            <a:r>
+              <a:t>│    • R² (Coefficient of Determination)                                          │</a:t>
+            </a:r>
+          </a:p>
+          <a:p>
+            <a:pPr>
+              <a:lnSpc>
+                <a:spcPct val="100000"/>
+              </a:lnSpc>
+              <a:spcAft>
+                <a:spcPts val="0"/>
+              </a:spcAft>
+              <a:defRPr sz="800">
+                <a:solidFill>
+                  <a:srgbClr val="8B949E"/>
+                </a:solidFill>
+                <a:latin typeface="Consolas"/>
+              </a:defRPr>
+            </a:pPr>
+            <a:r>
+              <a:t>│    • Linear regression: slope, intercept                                        │</a:t>
+            </a:r>
+          </a:p>
+          <a:p>
+            <a:pPr>
+              <a:lnSpc>
+                <a:spcPct val="100000"/>
+              </a:lnSpc>
+              <a:spcAft>
+                <a:spcPts val="0"/>
+              </a:spcAft>
+              <a:defRPr sz="800">
+                <a:solidFill>
+                  <a:srgbClr val="8B949E"/>
+                </a:solidFill>
+                <a:latin typeface="Consolas"/>
+              </a:defRPr>
+            </a:pPr>
+            <a:r>
+              <a:t>│  Visualizations:                                                                │</a:t>
+            </a:r>
+          </a:p>
+          <a:p>
+            <a:pPr>
+              <a:lnSpc>
+                <a:spcPct val="100000"/>
+              </a:lnSpc>
+              <a:spcAft>
+                <a:spcPts val="0"/>
+              </a:spcAft>
+              <a:defRPr sz="800">
+                <a:solidFill>
+                  <a:srgbClr val="8B949E"/>
+                </a:solidFill>
+                <a:latin typeface="Consolas"/>
+              </a:defRPr>
+            </a:pPr>
+            <a:r>
+              <a:t>│    • Regression plots: ML freq vs DFT freq (scatter + fit line)                 │</a:t>
+            </a:r>
+          </a:p>
+          <a:p>
+            <a:pPr>
+              <a:lnSpc>
+                <a:spcPct val="100000"/>
+              </a:lnSpc>
+              <a:spcAft>
+                <a:spcPts val="0"/>
+              </a:spcAft>
+              <a:defRPr sz="800">
+                <a:solidFill>
+                  <a:srgbClr val="8B949E"/>
+                </a:solidFill>
+                <a:latin typeface="Consolas"/>
+              </a:defRPr>
+            </a:pPr>
+            <a:r>
+              <a:t>│    • KDE spectra: Gaussian broadening (FWHM=8.0 cm⁻¹, grid 400-4000 cm⁻¹)      │</a:t>
+            </a:r>
+          </a:p>
+          <a:p>
+            <a:pPr>
+              <a:lnSpc>
+                <a:spcPct val="100000"/>
+              </a:lnSpc>
+              <a:spcAft>
+                <a:spcPts val="0"/>
+              </a:spcAft>
+              <a:defRPr sz="800">
+                <a:solidFill>
+                  <a:srgbClr val="8B949E"/>
+                </a:solidFill>
+                <a:latin typeface="Consolas"/>
+              </a:defRPr>
+            </a:pPr>
+            <a:r>
+              <a:t>│    • Combined comparison plots (all methods overlaid)                           │</a:t>
+            </a:r>
+          </a:p>
+          <a:p>
+            <a:pPr>
+              <a:lnSpc>
+                <a:spcPct val="100000"/>
+              </a:lnSpc>
+              <a:spcAft>
+                <a:spcPts val="0"/>
+              </a:spcAft>
+              <a:defRPr sz="800">
+                <a:solidFill>
+                  <a:srgbClr val="8B949E"/>
+                </a:solidFill>
+                <a:latin typeface="Consolas"/>
+              </a:defRPr>
+            </a:pPr>
+            <a:r>
+              <a:t>│  Output: {molecule}_spectral_analysis.html (interactive, publication-ready)     │</a:t>
+            </a:r>
+          </a:p>
+          <a:p>
+            <a:pPr>
+              <a:lnSpc>
+                <a:spcPct val="100000"/>
+              </a:lnSpc>
+              <a:spcAft>
+                <a:spcPts val="0"/>
+              </a:spcAft>
+              <a:defRPr sz="800">
+                <a:solidFill>
+                  <a:srgbClr val="8B949E"/>
+                </a:solidFill>
+                <a:latin typeface="Consolas"/>
+              </a:defRPr>
+            </a:pPr>
+            <a:r>
+              <a:t>└─────────────────────────────────────────────────────────────────────────────────┘</a:t>
             </a:r>
           </a:p>
         </p:txBody>

</xml_diff>

<commit_message>
Add modular box-based workflow diagrams (slides 7-8)
- Slide 7: Function-level modular boxes with interconnected arrows
  Shows individual functions: load_geometry, mace_omol.optimize,
  parse_freq, setup_zmq_server, eigenvector_mode_matching, etc.
- Slide 8: Grid modules with side-by-side layout
  Organizes workflow into major modules: Geometry Optimizer,
  DFT Baseline, ML Freq Calc (with nested ZMQ Bridge), and
  Analysis & Comparison
- Both use Terminal Dark styling with 8pt font for readability
- Full width layouts (9.6" and 9.4") to maximize detail
</commit_message>
<xml_diff>
--- a/presentation/test_detailed_workflow.pptx
+++ b/presentation/test_detailed_workflow.pptx
@@ -11,6 +11,8 @@
     <p:sldId id="259" r:id="rId10"/>
     <p:sldId id="260" r:id="rId11"/>
     <p:sldId id="261" r:id="rId12"/>
+    <p:sldId id="262" r:id="rId13"/>
+    <p:sldId id="263" r:id="rId14"/>
   </p:sldIdLst>
   <p:sldSz cx="9144000" cy="6858000" type="screen4x3"/>
   <p:notesSz cx="6858000" cy="9144000"/>
@@ -8686,6 +8688,2380 @@
             </a:pPr>
             <a:r>
               <a:t>└─────────────────────────────────────────────────────────────────────────────────┘</a:t>
+            </a:r>
+          </a:p>
+        </p:txBody>
+      </p:sp>
+    </p:spTree>
+  </p:cSld>
+  <p:clrMapOvr>
+    <a:masterClrMapping/>
+  </p:clrMapOvr>
+</p:sld>
+</file>
+
+<file path=ppt/slides/slide7.xml><?xml version="1.0" encoding="utf-8"?>
+<p:sld xmlns:a="http://schemas.openxmlformats.org/drawingml/2006/main" xmlns:p="http://schemas.openxmlformats.org/presentationml/2006/main" xmlns:r="http://schemas.openxmlformats.org/officeDocument/2006/relationships">
+  <p:cSld>
+    <p:bg>
+      <p:bgPr>
+        <a:solidFill>
+          <a:srgbClr val="0D1117"/>
+        </a:solidFill>
+        <a:effectLst/>
+      </p:bgPr>
+    </p:bg>
+    <p:spTree>
+      <p:nvGrpSpPr>
+        <p:cNvPr id="1" name=""/>
+        <p:cNvGrpSpPr/>
+        <p:nvPr/>
+      </p:nvGrpSpPr>
+      <p:grpSpPr/>
+      <p:sp>
+        <p:nvSpPr>
+          <p:cNvPr id="2" name="TextBox 1"/>
+          <p:cNvSpPr txBox="1"/>
+          <p:nvPr/>
+        </p:nvSpPr>
+        <p:spPr>
+          <a:xfrm>
+            <a:off x="457200" y="274320"/>
+            <a:ext cx="8229600" cy="457200"/>
+          </a:xfrm>
+          <a:prstGeom prst="rect">
+            <a:avLst/>
+          </a:prstGeom>
+          <a:noFill/>
+        </p:spPr>
+        <p:txBody>
+          <a:bodyPr wrap="none">
+            <a:spAutoFit/>
+          </a:bodyPr>
+          <a:lstStyle/>
+          <a:p>
+            <a:pPr>
+              <a:defRPr sz="2200" b="1">
+                <a:solidFill>
+                  <a:srgbClr val="58A6FF"/>
+                </a:solidFill>
+                <a:latin typeface="Consolas"/>
+              </a:defRPr>
+            </a:pPr>
+            <a:r>
+              <a:t>$ cat workflow_modular.txt</a:t>
+            </a:r>
+          </a:p>
+        </p:txBody>
+      </p:sp>
+      <p:sp>
+        <p:nvSpPr>
+          <p:cNvPr id="3" name="TextBox 2"/>
+          <p:cNvSpPr txBox="1"/>
+          <p:nvPr/>
+        </p:nvSpPr>
+        <p:spPr>
+          <a:xfrm>
+            <a:off x="182880" y="822960"/>
+            <a:ext cx="8778240" cy="5852160"/>
+          </a:xfrm>
+          <a:prstGeom prst="rect">
+            <a:avLst/>
+          </a:prstGeom>
+          <a:noFill/>
+        </p:spPr>
+        <p:txBody>
+          <a:bodyPr wrap="none">
+            <a:spAutoFit/>
+          </a:bodyPr>
+          <a:lstStyle/>
+          <a:p>
+            <a:pPr>
+              <a:lnSpc>
+                <a:spcPct val="100000"/>
+              </a:lnSpc>
+              <a:spcAft>
+                <a:spcPts val="0"/>
+              </a:spcAft>
+              <a:defRPr sz="800">
+                <a:solidFill>
+                  <a:srgbClr val="57AB5A"/>
+                </a:solidFill>
+                <a:latin typeface="Consolas"/>
+              </a:defRPr>
+            </a:pPr>
+            <a:r>
+              <a:t>[molecule.xyz]</a:t>
+            </a:r>
+          </a:p>
+          <a:p>
+            <a:pPr>
+              <a:lnSpc>
+                <a:spcPct val="100000"/>
+              </a:lnSpc>
+              <a:spcAft>
+                <a:spcPts val="0"/>
+              </a:spcAft>
+              <a:defRPr sz="800">
+                <a:solidFill>
+                  <a:srgbClr val="8B949E"/>
+                </a:solidFill>
+                <a:latin typeface="Consolas"/>
+              </a:defRPr>
+            </a:pPr>
+            <a:r>
+              <a:t>      │</a:t>
+            </a:r>
+          </a:p>
+          <a:p>
+            <a:pPr>
+              <a:lnSpc>
+                <a:spcPct val="100000"/>
+              </a:lnSpc>
+              <a:spcAft>
+                <a:spcPts val="0"/>
+              </a:spcAft>
+              <a:defRPr sz="800">
+                <a:solidFill>
+                  <a:srgbClr val="58A6FF"/>
+                </a:solidFill>
+                <a:latin typeface="Consolas"/>
+              </a:defRPr>
+            </a:pPr>
+            <a:r>
+              <a:t>┌─────▼──────────────────────┐</a:t>
+            </a:r>
+          </a:p>
+          <a:p>
+            <a:pPr>
+              <a:lnSpc>
+                <a:spcPct val="100000"/>
+              </a:lnSpc>
+              <a:spcAft>
+                <a:spcPts val="0"/>
+              </a:spcAft>
+              <a:defRPr sz="800">
+                <a:solidFill>
+                  <a:srgbClr val="58A6FF"/>
+                </a:solidFill>
+                <a:latin typeface="Consolas"/>
+              </a:defRPr>
+            </a:pPr>
+            <a:r>
+              <a:t>│ load_geometry()            │</a:t>
+            </a:r>
+          </a:p>
+          <a:p>
+            <a:pPr>
+              <a:lnSpc>
+                <a:spcPct val="100000"/>
+              </a:lnSpc>
+              <a:spcAft>
+                <a:spcPts val="0"/>
+              </a:spcAft>
+              <a:defRPr sz="800">
+                <a:solidFill>
+                  <a:srgbClr val="58A6FF"/>
+                </a:solidFill>
+                <a:latin typeface="Consolas"/>
+              </a:defRPr>
+            </a:pPr>
+            <a:r>
+              <a:t>└─────┬──────────────────────┘</a:t>
+            </a:r>
+          </a:p>
+          <a:p>
+            <a:pPr>
+              <a:lnSpc>
+                <a:spcPct val="100000"/>
+              </a:lnSpc>
+              <a:spcAft>
+                <a:spcPts val="0"/>
+              </a:spcAft>
+              <a:defRPr sz="800">
+                <a:solidFill>
+                  <a:srgbClr val="8B949E"/>
+                </a:solidFill>
+                <a:latin typeface="Consolas"/>
+              </a:defRPr>
+            </a:pPr>
+            <a:r>
+              <a:t>      │</a:t>
+            </a:r>
+          </a:p>
+          <a:p>
+            <a:pPr>
+              <a:lnSpc>
+                <a:spcPct val="100000"/>
+              </a:lnSpc>
+              <a:spcAft>
+                <a:spcPts val="0"/>
+              </a:spcAft>
+              <a:defRPr sz="800">
+                <a:solidFill>
+                  <a:srgbClr val="58A6FF"/>
+                </a:solidFill>
+                <a:latin typeface="Consolas"/>
+              </a:defRPr>
+            </a:pPr>
+            <a:r>
+              <a:t>┌─────▼──────────────────────┐</a:t>
+            </a:r>
+          </a:p>
+          <a:p>
+            <a:pPr>
+              <a:lnSpc>
+                <a:spcPct val="100000"/>
+              </a:lnSpc>
+              <a:spcAft>
+                <a:spcPts val="0"/>
+              </a:spcAft>
+              <a:defRPr sz="800">
+                <a:solidFill>
+                  <a:srgbClr val="58A6FF"/>
+                </a:solidFill>
+                <a:latin typeface="Consolas"/>
+              </a:defRPr>
+            </a:pPr>
+            <a:r>
+              <a:t>│ mace_omol.optimize()       │</a:t>
+            </a:r>
+          </a:p>
+          <a:p>
+            <a:pPr>
+              <a:lnSpc>
+                <a:spcPct val="100000"/>
+              </a:lnSpc>
+              <a:spcAft>
+                <a:spcPts val="0"/>
+              </a:spcAft>
+              <a:defRPr sz="800">
+                <a:solidFill>
+                  <a:srgbClr val="58A6FF"/>
+                </a:solidFill>
+                <a:latin typeface="Consolas"/>
+              </a:defRPr>
+            </a:pPr>
+            <a:r>
+              <a:t>└─────┬──────────────────────┘</a:t>
+            </a:r>
+          </a:p>
+          <a:p>
+            <a:pPr>
+              <a:lnSpc>
+                <a:spcPct val="100000"/>
+              </a:lnSpc>
+              <a:spcAft>
+                <a:spcPts val="0"/>
+              </a:spcAft>
+              <a:defRPr sz="800">
+                <a:solidFill>
+                  <a:srgbClr val="8B949E"/>
+                </a:solidFill>
+                <a:latin typeface="Consolas"/>
+              </a:defRPr>
+            </a:pPr>
+            <a:r>
+              <a:t>      ├──────────────────────────────────┬───────────────────────────────────┐</a:t>
+            </a:r>
+          </a:p>
+          <a:p>
+            <a:pPr>
+              <a:lnSpc>
+                <a:spcPct val="100000"/>
+              </a:lnSpc>
+              <a:spcAft>
+                <a:spcPts val="0"/>
+              </a:spcAft>
+              <a:defRPr sz="800">
+                <a:solidFill>
+                  <a:srgbClr val="8B949E"/>
+                </a:solidFill>
+                <a:latin typeface="Consolas"/>
+              </a:defRPr>
+            </a:pPr>
+            <a:r>
+              <a:t>      │                                  │                                   │</a:t>
+            </a:r>
+          </a:p>
+          <a:p>
+            <a:pPr>
+              <a:lnSpc>
+                <a:spcPct val="100000"/>
+              </a:lnSpc>
+              <a:spcAft>
+                <a:spcPts val="0"/>
+              </a:spcAft>
+              <a:defRPr sz="800">
+                <a:solidFill>
+                  <a:srgbClr val="57AB5A"/>
+                </a:solidFill>
+                <a:latin typeface="Consolas"/>
+              </a:defRPr>
+            </a:pPr>
+            <a:r>
+              <a:t>┌─────▼──────────┐  ┌──────────────────▼──────────────┐  ┌─────────────────▼─────────────┐</a:t>
+            </a:r>
+          </a:p>
+          <a:p>
+            <a:pPr>
+              <a:lnSpc>
+                <a:spcPct val="100000"/>
+              </a:lnSpc>
+              <a:spcAft>
+                <a:spcPts val="0"/>
+              </a:spcAft>
+              <a:defRPr sz="800">
+                <a:solidFill>
+                  <a:srgbClr val="57AB5A"/>
+                </a:solidFill>
+                <a:latin typeface="Consolas"/>
+              </a:defRPr>
+            </a:pPr>
+            <a:r>
+              <a:t>│ gaussian_dft() │  │ load_mace_calculator()          │  │ parse_geometry_results()      │</a:t>
+            </a:r>
+          </a:p>
+          <a:p>
+            <a:pPr>
+              <a:lnSpc>
+                <a:spcPct val="100000"/>
+              </a:lnSpc>
+              <a:spcAft>
+                <a:spcPts val="0"/>
+              </a:spcAft>
+              <a:defRPr sz="800">
+                <a:solidFill>
+                  <a:srgbClr val="C9D1D9"/>
+                </a:solidFill>
+                <a:latin typeface="Consolas"/>
+              </a:defRPr>
+            </a:pPr>
+            <a:r>
+              <a:t>│ B3LYP/6-31Gdp  │  │ (MACE-MP/MACE-OMOL)             │  │ → optimized.xyz               │</a:t>
+            </a:r>
+          </a:p>
+          <a:p>
+            <a:pPr>
+              <a:lnSpc>
+                <a:spcPct val="100000"/>
+              </a:lnSpc>
+              <a:spcAft>
+                <a:spcPts val="0"/>
+              </a:spcAft>
+              <a:defRPr sz="800">
+                <a:solidFill>
+                  <a:srgbClr val="57AB5A"/>
+                </a:solidFill>
+                <a:latin typeface="Consolas"/>
+              </a:defRPr>
+            </a:pPr>
+            <a:r>
+              <a:t>└─────┬──────────┘  └──────────────────┬──────────────┘  └───────────────────────────────┘</a:t>
+            </a:r>
+          </a:p>
+          <a:p>
+            <a:pPr>
+              <a:lnSpc>
+                <a:spcPct val="100000"/>
+              </a:lnSpc>
+              <a:spcAft>
+                <a:spcPts val="0"/>
+              </a:spcAft>
+              <a:defRPr sz="800">
+                <a:solidFill>
+                  <a:srgbClr val="8B949E"/>
+                </a:solidFill>
+                <a:latin typeface="Consolas"/>
+              </a:defRPr>
+            </a:pPr>
+            <a:r>
+              <a:t>      │                                │</a:t>
+            </a:r>
+          </a:p>
+          <a:p>
+            <a:pPr>
+              <a:lnSpc>
+                <a:spcPct val="100000"/>
+              </a:lnSpc>
+              <a:spcAft>
+                <a:spcPts val="0"/>
+              </a:spcAft>
+              <a:defRPr sz="800">
+                <a:solidFill>
+                  <a:srgbClr val="DB6D28"/>
+                </a:solidFill>
+                <a:latin typeface="Consolas"/>
+              </a:defRPr>
+            </a:pPr>
+            <a:r>
+              <a:t>┌─────▼──────────┐  ┌──────────────────▼──────────────┐</a:t>
+            </a:r>
+          </a:p>
+          <a:p>
+            <a:pPr>
+              <a:lnSpc>
+                <a:spcPct val="100000"/>
+              </a:lnSpc>
+              <a:spcAft>
+                <a:spcPts val="0"/>
+              </a:spcAft>
+              <a:defRPr sz="800">
+                <a:solidFill>
+                  <a:srgbClr val="DB6D28"/>
+                </a:solidFill>
+                <a:latin typeface="Consolas"/>
+              </a:defRPr>
+            </a:pPr>
+            <a:r>
+              <a:t>│ parse_freq()   │  │ get_dipole_calculator()         │</a:t>
+            </a:r>
+          </a:p>
+          <a:p>
+            <a:pPr>
+              <a:lnSpc>
+                <a:spcPct val="100000"/>
+              </a:lnSpc>
+              <a:spcAft>
+                <a:spcPts val="0"/>
+              </a:spcAft>
+              <a:defRPr sz="800">
+                <a:solidFill>
+                  <a:srgbClr val="C9D1D9"/>
+                </a:solidFill>
+                <a:latin typeface="Consolas"/>
+              </a:defRPr>
+            </a:pPr>
+            <a:r>
+              <a:t>└─────┬──────────┘  │ → espaloma/mace_ml/xtb          │</a:t>
+            </a:r>
+          </a:p>
+          <a:p>
+            <a:pPr>
+              <a:lnSpc>
+                <a:spcPct val="100000"/>
+              </a:lnSpc>
+              <a:spcAft>
+                <a:spcPts val="0"/>
+              </a:spcAft>
+              <a:defRPr sz="800">
+                <a:solidFill>
+                  <a:srgbClr val="DB6D28"/>
+                </a:solidFill>
+                <a:latin typeface="Consolas"/>
+              </a:defRPr>
+            </a:pPr>
+            <a:r>
+              <a:t>      │             └──────────────────┬──────────────┘</a:t>
+            </a:r>
+          </a:p>
+          <a:p>
+            <a:pPr>
+              <a:lnSpc>
+                <a:spcPct val="100000"/>
+              </a:lnSpc>
+              <a:spcAft>
+                <a:spcPts val="0"/>
+              </a:spcAft>
+              <a:defRPr sz="800">
+                <a:solidFill>
+                  <a:srgbClr val="8B949E"/>
+                </a:solidFill>
+                <a:latin typeface="Consolas"/>
+              </a:defRPr>
+            </a:pPr>
+            <a:r>
+              <a:t>      │                                │</a:t>
+            </a:r>
+          </a:p>
+          <a:p>
+            <a:pPr>
+              <a:lnSpc>
+                <a:spcPct val="100000"/>
+              </a:lnSpc>
+              <a:spcAft>
+                <a:spcPts val="0"/>
+              </a:spcAft>
+              <a:defRPr sz="800">
+                <a:solidFill>
+                  <a:srgbClr val="DB6D28"/>
+                </a:solidFill>
+                <a:latin typeface="Consolas"/>
+              </a:defRPr>
+            </a:pPr>
+            <a:r>
+              <a:t>      │             ┌──────────────────▼──────────────┐</a:t>
+            </a:r>
+          </a:p>
+          <a:p>
+            <a:pPr>
+              <a:lnSpc>
+                <a:spcPct val="100000"/>
+              </a:lnSpc>
+              <a:spcAft>
+                <a:spcPts val="0"/>
+              </a:spcAft>
+              <a:defRPr sz="800">
+                <a:solidFill>
+                  <a:srgbClr val="DB6D28"/>
+                </a:solidFill>
+                <a:latin typeface="Consolas"/>
+              </a:defRPr>
+            </a:pPr>
+            <a:r>
+              <a:t>      │             │ setup_zmq_server()              │</a:t>
+            </a:r>
+          </a:p>
+          <a:p>
+            <a:pPr>
+              <a:lnSpc>
+                <a:spcPct val="100000"/>
+              </a:lnSpc>
+              <a:spcAft>
+                <a:spcPts val="0"/>
+              </a:spcAft>
+              <a:defRPr sz="800">
+                <a:solidFill>
+                  <a:srgbClr val="C9D1D9"/>
+                </a:solidFill>
+                <a:latin typeface="Consolas"/>
+              </a:defRPr>
+            </a:pPr>
+            <a:r>
+              <a:t>      │             │ bind(.ipc_file)                 │</a:t>
+            </a:r>
+          </a:p>
+          <a:p>
+            <a:pPr>
+              <a:lnSpc>
+                <a:spcPct val="100000"/>
+              </a:lnSpc>
+              <a:spcAft>
+                <a:spcPts val="0"/>
+              </a:spcAft>
+              <a:defRPr sz="800">
+                <a:solidFill>
+                  <a:srgbClr val="DB6D28"/>
+                </a:solidFill>
+                <a:latin typeface="Consolas"/>
+              </a:defRPr>
+            </a:pPr>
+            <a:r>
+              <a:t>      │             └──────────────────┬──────────────┘</a:t>
+            </a:r>
+          </a:p>
+          <a:p>
+            <a:pPr>
+              <a:lnSpc>
+                <a:spcPct val="100000"/>
+              </a:lnSpc>
+              <a:spcAft>
+                <a:spcPts val="0"/>
+              </a:spcAft>
+              <a:defRPr sz="800">
+                <a:solidFill>
+                  <a:srgbClr val="8B949E"/>
+                </a:solidFill>
+                <a:latin typeface="Consolas"/>
+              </a:defRPr>
+            </a:pPr>
+            <a:r>
+              <a:t>      │                                │</a:t>
+            </a:r>
+          </a:p>
+          <a:p>
+            <a:pPr>
+              <a:lnSpc>
+                <a:spcPct val="100000"/>
+              </a:lnSpc>
+              <a:spcAft>
+                <a:spcPts val="0"/>
+              </a:spcAft>
+              <a:defRPr sz="800">
+                <a:solidFill>
+                  <a:srgbClr val="DB6D28"/>
+                </a:solidFill>
+                <a:latin typeface="Consolas"/>
+              </a:defRPr>
+            </a:pPr>
+            <a:r>
+              <a:t>      │             ┌──────────────────▼──────────────┐</a:t>
+            </a:r>
+          </a:p>
+          <a:p>
+            <a:pPr>
+              <a:lnSpc>
+                <a:spcPct val="100000"/>
+              </a:lnSpc>
+              <a:spcAft>
+                <a:spcPts val="0"/>
+              </a:spcAft>
+              <a:defRPr sz="800">
+                <a:solidFill>
+                  <a:srgbClr val="DB6D28"/>
+                </a:solidFill>
+                <a:latin typeface="Consolas"/>
+              </a:defRPr>
+            </a:pPr>
+            <a:r>
+              <a:t>      │             │ launch_gaussian()               │</a:t>
+            </a:r>
+          </a:p>
+          <a:p>
+            <a:pPr>
+              <a:lnSpc>
+                <a:spcPct val="100000"/>
+              </a:lnSpc>
+              <a:spcAft>
+                <a:spcPts val="0"/>
+              </a:spcAft>
+              <a:defRPr sz="800">
+                <a:solidFill>
+                  <a:srgbClr val="C9D1D9"/>
+                </a:solidFill>
+                <a:latin typeface="Consolas"/>
+              </a:defRPr>
+            </a:pPr>
+            <a:r>
+              <a:t>      │             │ External="gm_helper.py"         │</a:t>
+            </a:r>
+          </a:p>
+          <a:p>
+            <a:pPr>
+              <a:lnSpc>
+                <a:spcPct val="100000"/>
+              </a:lnSpc>
+              <a:spcAft>
+                <a:spcPts val="0"/>
+              </a:spcAft>
+              <a:defRPr sz="800">
+                <a:solidFill>
+                  <a:srgbClr val="DB6D28"/>
+                </a:solidFill>
+                <a:latin typeface="Consolas"/>
+              </a:defRPr>
+            </a:pPr>
+            <a:r>
+              <a:t>      │             └──────────────────┬──────────────┘</a:t>
+            </a:r>
+          </a:p>
+          <a:p>
+            <a:pPr>
+              <a:lnSpc>
+                <a:spcPct val="100000"/>
+              </a:lnSpc>
+              <a:spcAft>
+                <a:spcPts val="0"/>
+              </a:spcAft>
+              <a:defRPr sz="800">
+                <a:solidFill>
+                  <a:srgbClr val="8B949E"/>
+                </a:solidFill>
+                <a:latin typeface="Consolas"/>
+              </a:defRPr>
+            </a:pPr>
+            <a:r>
+              <a:t>      │                                │</a:t>
+            </a:r>
+          </a:p>
+          <a:p>
+            <a:pPr>
+              <a:lnSpc>
+                <a:spcPct val="100000"/>
+              </a:lnSpc>
+              <a:spcAft>
+                <a:spcPts val="0"/>
+              </a:spcAft>
+              <a:defRPr sz="800">
+                <a:solidFill>
+                  <a:srgbClr val="DB6D28"/>
+                </a:solidFill>
+                <a:latin typeface="Consolas"/>
+              </a:defRPr>
+            </a:pPr>
+            <a:r>
+              <a:t>      │             ┌──────────────────▼──────────────┐</a:t>
+            </a:r>
+          </a:p>
+          <a:p>
+            <a:pPr>
+              <a:lnSpc>
+                <a:spcPct val="100000"/>
+              </a:lnSpc>
+              <a:spcAft>
+                <a:spcPts val="0"/>
+              </a:spcAft>
+              <a:defRPr sz="800">
+                <a:solidFill>
+                  <a:srgbClr val="DB6D28"/>
+                </a:solidFill>
+                <a:latin typeface="Consolas"/>
+              </a:defRPr>
+            </a:pPr>
+            <a:r>
+              <a:t>      │             │ zmq_dipole_loop()               │</a:t>
+            </a:r>
+          </a:p>
+          <a:p>
+            <a:pPr>
+              <a:lnSpc>
+                <a:spcPct val="100000"/>
+              </a:lnSpc>
+              <a:spcAft>
+                <a:spcPts val="0"/>
+              </a:spcAft>
+              <a:defRPr sz="800">
+                <a:solidFill>
+                  <a:srgbClr val="C9D1D9"/>
+                </a:solidFill>
+                <a:latin typeface="Consolas"/>
+              </a:defRPr>
+            </a:pPr>
+            <a:r>
+              <a:t>      │             │ • receive geometry              │</a:t>
+            </a:r>
+          </a:p>
+          <a:p>
+            <a:pPr>
+              <a:lnSpc>
+                <a:spcPct val="100000"/>
+              </a:lnSpc>
+              <a:spcAft>
+                <a:spcPts val="0"/>
+              </a:spcAft>
+              <a:defRPr sz="800">
+                <a:solidFill>
+                  <a:srgbClr val="C9D1D9"/>
+                </a:solidFill>
+                <a:latin typeface="Consolas"/>
+              </a:defRPr>
+            </a:pPr>
+            <a:r>
+              <a:t>      │             │ • compute_dipoles()             │</a:t>
+            </a:r>
+          </a:p>
+          <a:p>
+            <a:pPr>
+              <a:lnSpc>
+                <a:spcPct val="100000"/>
+              </a:lnSpc>
+              <a:spcAft>
+                <a:spcPts val="0"/>
+              </a:spcAft>
+              <a:defRPr sz="800">
+                <a:solidFill>
+                  <a:srgbClr val="C9D1D9"/>
+                </a:solidFill>
+                <a:latin typeface="Consolas"/>
+              </a:defRPr>
+            </a:pPr>
+            <a:r>
+              <a:t>      │             │ • write_gaussian_format()       │</a:t>
+            </a:r>
+          </a:p>
+          <a:p>
+            <a:pPr>
+              <a:lnSpc>
+                <a:spcPct val="100000"/>
+              </a:lnSpc>
+              <a:spcAft>
+                <a:spcPts val="0"/>
+              </a:spcAft>
+              <a:defRPr sz="800">
+                <a:solidFill>
+                  <a:srgbClr val="DB6D28"/>
+                </a:solidFill>
+                <a:latin typeface="Consolas"/>
+              </a:defRPr>
+            </a:pPr>
+            <a:r>
+              <a:t>      │             └──────────────────┬──────────────┘</a:t>
+            </a:r>
+          </a:p>
+          <a:p>
+            <a:pPr>
+              <a:lnSpc>
+                <a:spcPct val="100000"/>
+              </a:lnSpc>
+              <a:spcAft>
+                <a:spcPts val="0"/>
+              </a:spcAft>
+              <a:defRPr sz="800">
+                <a:solidFill>
+                  <a:srgbClr val="8B949E"/>
+                </a:solidFill>
+                <a:latin typeface="Consolas"/>
+              </a:defRPr>
+            </a:pPr>
+            <a:r>
+              <a:t>      │                                │</a:t>
+            </a:r>
+          </a:p>
+          <a:p>
+            <a:pPr>
+              <a:lnSpc>
+                <a:spcPct val="100000"/>
+              </a:lnSpc>
+              <a:spcAft>
+                <a:spcPts val="0"/>
+              </a:spcAft>
+              <a:defRPr sz="800">
+                <a:solidFill>
+                  <a:srgbClr val="DB6D28"/>
+                </a:solidFill>
+                <a:latin typeface="Consolas"/>
+              </a:defRPr>
+            </a:pPr>
+            <a:r>
+              <a:t>      │             ┌──────────────────▼──────────────┐</a:t>
+            </a:r>
+          </a:p>
+          <a:p>
+            <a:pPr>
+              <a:lnSpc>
+                <a:spcPct val="100000"/>
+              </a:lnSpc>
+              <a:spcAft>
+                <a:spcPts val="0"/>
+              </a:spcAft>
+              <a:defRPr sz="800">
+                <a:solidFill>
+                  <a:srgbClr val="DB6D28"/>
+                </a:solidFill>
+                <a:latin typeface="Consolas"/>
+              </a:defRPr>
+            </a:pPr>
+            <a:r>
+              <a:t>      │             │ parse_ml_results()              │</a:t>
+            </a:r>
+          </a:p>
+          <a:p>
+            <a:pPr>
+              <a:lnSpc>
+                <a:spcPct val="100000"/>
+              </a:lnSpc>
+              <a:spcAft>
+                <a:spcPts val="0"/>
+              </a:spcAft>
+              <a:defRPr sz="800">
+                <a:solidFill>
+                  <a:srgbClr val="DB6D28"/>
+                </a:solidFill>
+                <a:latin typeface="Consolas"/>
+              </a:defRPr>
+            </a:pPr>
+            <a:r>
+              <a:t>      │             └──────────────────┬──────────────┘</a:t>
+            </a:r>
+          </a:p>
+          <a:p>
+            <a:pPr>
+              <a:lnSpc>
+                <a:spcPct val="100000"/>
+              </a:lnSpc>
+              <a:spcAft>
+                <a:spcPts val="0"/>
+              </a:spcAft>
+              <a:defRPr sz="800">
+                <a:solidFill>
+                  <a:srgbClr val="8B949E"/>
+                </a:solidFill>
+                <a:latin typeface="Consolas"/>
+              </a:defRPr>
+            </a:pPr>
+            <a:r>
+              <a:t>      │                                │</a:t>
+            </a:r>
+          </a:p>
+          <a:p>
+            <a:pPr>
+              <a:lnSpc>
+                <a:spcPct val="100000"/>
+              </a:lnSpc>
+              <a:spcAft>
+                <a:spcPts val="0"/>
+              </a:spcAft>
+              <a:defRPr sz="800">
+                <a:solidFill>
+                  <a:srgbClr val="8B949E"/>
+                </a:solidFill>
+                <a:latin typeface="Consolas"/>
+              </a:defRPr>
+            </a:pPr>
+            <a:r>
+              <a:t>      └────────────────────────────────┘</a:t>
+            </a:r>
+          </a:p>
+          <a:p>
+            <a:pPr>
+              <a:lnSpc>
+                <a:spcPct val="100000"/>
+              </a:lnSpc>
+              <a:spcAft>
+                <a:spcPts val="0"/>
+              </a:spcAft>
+              <a:defRPr sz="800">
+                <a:solidFill>
+                  <a:srgbClr val="8B949E"/>
+                </a:solidFill>
+                <a:latin typeface="Consolas"/>
+              </a:defRPr>
+            </a:pPr>
+            <a:r>
+              <a:t>      │</a:t>
+            </a:r>
+          </a:p>
+          <a:p>
+            <a:pPr>
+              <a:lnSpc>
+                <a:spcPct val="100000"/>
+              </a:lnSpc>
+              <a:spcAft>
+                <a:spcPts val="0"/>
+              </a:spcAft>
+              <a:defRPr sz="800">
+                <a:solidFill>
+                  <a:srgbClr val="58A6FF"/>
+                </a:solidFill>
+                <a:latin typeface="Consolas"/>
+              </a:defRPr>
+            </a:pPr>
+            <a:r>
+              <a:t>┌─────▼─────────────────────────────────┐</a:t>
+            </a:r>
+          </a:p>
+          <a:p>
+            <a:pPr>
+              <a:lnSpc>
+                <a:spcPct val="100000"/>
+              </a:lnSpc>
+              <a:spcAft>
+                <a:spcPts val="0"/>
+              </a:spcAft>
+              <a:defRPr sz="800">
+                <a:solidFill>
+                  <a:srgbClr val="58A6FF"/>
+                </a:solidFill>
+                <a:latin typeface="Consolas"/>
+              </a:defRPr>
+            </a:pPr>
+            <a:r>
+              <a:t>│ load_all_results()                    │</a:t>
+            </a:r>
+          </a:p>
+          <a:p>
+            <a:pPr>
+              <a:lnSpc>
+                <a:spcPct val="100000"/>
+              </a:lnSpc>
+              <a:spcAft>
+                <a:spcPts val="0"/>
+              </a:spcAft>
+              <a:defRPr sz="800">
+                <a:solidFill>
+                  <a:srgbClr val="C9D1D9"/>
+                </a:solidFill>
+                <a:latin typeface="Consolas"/>
+              </a:defRPr>
+            </a:pPr>
+            <a:r>
+              <a:t>│ comparison_results/**/results.json    │</a:t>
+            </a:r>
+          </a:p>
+          <a:p>
+            <a:pPr>
+              <a:lnSpc>
+                <a:spcPct val="100000"/>
+              </a:lnSpc>
+              <a:spcAft>
+                <a:spcPts val="0"/>
+              </a:spcAft>
+              <a:defRPr sz="800">
+                <a:solidFill>
+                  <a:srgbClr val="58A6FF"/>
+                </a:solidFill>
+                <a:latin typeface="Consolas"/>
+              </a:defRPr>
+            </a:pPr>
+            <a:r>
+              <a:t>└─────┬─────────────────────────────────┘</a:t>
+            </a:r>
+          </a:p>
+          <a:p>
+            <a:pPr>
+              <a:lnSpc>
+                <a:spcPct val="100000"/>
+              </a:lnSpc>
+              <a:spcAft>
+                <a:spcPts val="0"/>
+              </a:spcAft>
+              <a:defRPr sz="800">
+                <a:solidFill>
+                  <a:srgbClr val="8B949E"/>
+                </a:solidFill>
+                <a:latin typeface="Consolas"/>
+              </a:defRPr>
+            </a:pPr>
+            <a:r>
+              <a:t>      │</a:t>
+            </a:r>
+          </a:p>
+          <a:p>
+            <a:pPr>
+              <a:lnSpc>
+                <a:spcPct val="100000"/>
+              </a:lnSpc>
+              <a:spcAft>
+                <a:spcPts val="0"/>
+              </a:spcAft>
+              <a:defRPr sz="800">
+                <a:solidFill>
+                  <a:srgbClr val="58A6FF"/>
+                </a:solidFill>
+                <a:latin typeface="Consolas"/>
+              </a:defRPr>
+            </a:pPr>
+            <a:r>
+              <a:t>┌─────▼─────────────────────────────────┐</a:t>
+            </a:r>
+          </a:p>
+          <a:p>
+            <a:pPr>
+              <a:lnSpc>
+                <a:spcPct val="100000"/>
+              </a:lnSpc>
+              <a:spcAft>
+                <a:spcPts val="0"/>
+              </a:spcAft>
+              <a:defRPr sz="800">
+                <a:solidFill>
+                  <a:srgbClr val="58A6FF"/>
+                </a:solidFill>
+                <a:latin typeface="Consolas"/>
+              </a:defRPr>
+            </a:pPr>
+            <a:r>
+              <a:t>│ find_dft_baseline()                   │</a:t>
+            </a:r>
+          </a:p>
+          <a:p>
+            <a:pPr>
+              <a:lnSpc>
+                <a:spcPct val="100000"/>
+              </a:lnSpc>
+              <a:spcAft>
+                <a:spcPts val="0"/>
+              </a:spcAft>
+              <a:defRPr sz="800">
+                <a:solidFill>
+                  <a:srgbClr val="C9D1D9"/>
+                </a:solidFill>
+                <a:latin typeface="Consolas"/>
+              </a:defRPr>
+            </a:pPr>
+            <a:r>
+              <a:t>│ auto-detect b3lyp_6-31Gdp             │</a:t>
+            </a:r>
+          </a:p>
+          <a:p>
+            <a:pPr>
+              <a:lnSpc>
+                <a:spcPct val="100000"/>
+              </a:lnSpc>
+              <a:spcAft>
+                <a:spcPts val="0"/>
+              </a:spcAft>
+              <a:defRPr sz="800">
+                <a:solidFill>
+                  <a:srgbClr val="58A6FF"/>
+                </a:solidFill>
+                <a:latin typeface="Consolas"/>
+              </a:defRPr>
+            </a:pPr>
+            <a:r>
+              <a:t>└─────┬─────────────────────────────────┘</a:t>
+            </a:r>
+          </a:p>
+          <a:p>
+            <a:pPr>
+              <a:lnSpc>
+                <a:spcPct val="100000"/>
+              </a:lnSpc>
+              <a:spcAft>
+                <a:spcPts val="0"/>
+              </a:spcAft>
+              <a:defRPr sz="800">
+                <a:solidFill>
+                  <a:srgbClr val="8B949E"/>
+                </a:solidFill>
+                <a:latin typeface="Consolas"/>
+              </a:defRPr>
+            </a:pPr>
+            <a:r>
+              <a:t>      │</a:t>
+            </a:r>
+          </a:p>
+          <a:p>
+            <a:pPr>
+              <a:lnSpc>
+                <a:spcPct val="100000"/>
+              </a:lnSpc>
+              <a:spcAft>
+                <a:spcPts val="0"/>
+              </a:spcAft>
+              <a:defRPr sz="800">
+                <a:solidFill>
+                  <a:srgbClr val="58A6FF"/>
+                </a:solidFill>
+                <a:latin typeface="Consolas"/>
+              </a:defRPr>
+            </a:pPr>
+            <a:r>
+              <a:t>┌─────▼─────────────────────────────────┐</a:t>
+            </a:r>
+          </a:p>
+          <a:p>
+            <a:pPr>
+              <a:lnSpc>
+                <a:spcPct val="100000"/>
+              </a:lnSpc>
+              <a:spcAft>
+                <a:spcPts val="0"/>
+              </a:spcAft>
+              <a:defRPr sz="800">
+                <a:solidFill>
+                  <a:srgbClr val="58A6FF"/>
+                </a:solidFill>
+                <a:latin typeface="Consolas"/>
+              </a:defRPr>
+            </a:pPr>
+            <a:r>
+              <a:t>│ eigenvector_mode_matching()           │</a:t>
+            </a:r>
+          </a:p>
+          <a:p>
+            <a:pPr>
+              <a:lnSpc>
+                <a:spcPct val="100000"/>
+              </a:lnSpc>
+              <a:spcAft>
+                <a:spcPts val="0"/>
+              </a:spcAft>
+              <a:defRPr sz="800">
+                <a:solidFill>
+                  <a:srgbClr val="C9D1D9"/>
+                </a:solidFill>
+                <a:latin typeface="Consolas"/>
+              </a:defRPr>
+            </a:pPr>
+            <a:r>
+              <a:t>│ dot_product(modes_dft, modes_ml)      │</a:t>
+            </a:r>
+          </a:p>
+          <a:p>
+            <a:pPr>
+              <a:lnSpc>
+                <a:spcPct val="100000"/>
+              </a:lnSpc>
+              <a:spcAft>
+                <a:spcPts val="0"/>
+              </a:spcAft>
+              <a:defRPr sz="800">
+                <a:solidFill>
+                  <a:srgbClr val="58A6FF"/>
+                </a:solidFill>
+                <a:latin typeface="Consolas"/>
+              </a:defRPr>
+            </a:pPr>
+            <a:r>
+              <a:t>└─────┬─────────────────────────────────┘</a:t>
+            </a:r>
+          </a:p>
+          <a:p>
+            <a:pPr>
+              <a:lnSpc>
+                <a:spcPct val="100000"/>
+              </a:lnSpc>
+              <a:spcAft>
+                <a:spcPts val="0"/>
+              </a:spcAft>
+              <a:defRPr sz="800">
+                <a:solidFill>
+                  <a:srgbClr val="8B949E"/>
+                </a:solidFill>
+                <a:latin typeface="Consolas"/>
+              </a:defRPr>
+            </a:pPr>
+            <a:r>
+              <a:t>      │</a:t>
+            </a:r>
+          </a:p>
+          <a:p>
+            <a:pPr>
+              <a:lnSpc>
+                <a:spcPct val="100000"/>
+              </a:lnSpc>
+              <a:spcAft>
+                <a:spcPts val="0"/>
+              </a:spcAft>
+              <a:defRPr sz="800">
+                <a:solidFill>
+                  <a:srgbClr val="58A6FF"/>
+                </a:solidFill>
+                <a:latin typeface="Consolas"/>
+              </a:defRPr>
+            </a:pPr>
+            <a:r>
+              <a:t>┌─────▼─────────────────────────────────┐</a:t>
+            </a:r>
+          </a:p>
+          <a:p>
+            <a:pPr>
+              <a:lnSpc>
+                <a:spcPct val="100000"/>
+              </a:lnSpc>
+              <a:spcAft>
+                <a:spcPts val="0"/>
+              </a:spcAft>
+              <a:defRPr sz="800">
+                <a:solidFill>
+                  <a:srgbClr val="58A6FF"/>
+                </a:solidFill>
+                <a:latin typeface="Consolas"/>
+              </a:defRPr>
+            </a:pPr>
+            <a:r>
+              <a:t>│ calculate_metrics()                   │</a:t>
+            </a:r>
+          </a:p>
+          <a:p>
+            <a:pPr>
+              <a:lnSpc>
+                <a:spcPct val="100000"/>
+              </a:lnSpc>
+              <a:spcAft>
+                <a:spcPts val="0"/>
+              </a:spcAft>
+              <a:defRPr sz="800">
+                <a:solidFill>
+                  <a:srgbClr val="C9D1D9"/>
+                </a:solidFill>
+                <a:latin typeface="Consolas"/>
+              </a:defRPr>
+            </a:pPr>
+            <a:r>
+              <a:t>│ MAE, RMSE, R², regression             │</a:t>
+            </a:r>
+          </a:p>
+          <a:p>
+            <a:pPr>
+              <a:lnSpc>
+                <a:spcPct val="100000"/>
+              </a:lnSpc>
+              <a:spcAft>
+                <a:spcPts val="0"/>
+              </a:spcAft>
+              <a:defRPr sz="800">
+                <a:solidFill>
+                  <a:srgbClr val="58A6FF"/>
+                </a:solidFill>
+                <a:latin typeface="Consolas"/>
+              </a:defRPr>
+            </a:pPr>
+            <a:r>
+              <a:t>└─────┬─────────────────────────────────┘</a:t>
+            </a:r>
+          </a:p>
+          <a:p>
+            <a:pPr>
+              <a:lnSpc>
+                <a:spcPct val="100000"/>
+              </a:lnSpc>
+              <a:spcAft>
+                <a:spcPts val="0"/>
+              </a:spcAft>
+              <a:defRPr sz="800">
+                <a:solidFill>
+                  <a:srgbClr val="8B949E"/>
+                </a:solidFill>
+                <a:latin typeface="Consolas"/>
+              </a:defRPr>
+            </a:pPr>
+            <a:r>
+              <a:t>      ├─────────────────┬─────────────────┐</a:t>
+            </a:r>
+          </a:p>
+          <a:p>
+            <a:pPr>
+              <a:lnSpc>
+                <a:spcPct val="100000"/>
+              </a:lnSpc>
+              <a:spcAft>
+                <a:spcPts val="0"/>
+              </a:spcAft>
+              <a:defRPr sz="800">
+                <a:solidFill>
+                  <a:srgbClr val="8B949E"/>
+                </a:solidFill>
+                <a:latin typeface="Consolas"/>
+              </a:defRPr>
+            </a:pPr>
+            <a:r>
+              <a:t>      │                 │                 │</a:t>
+            </a:r>
+          </a:p>
+          <a:p>
+            <a:pPr>
+              <a:lnSpc>
+                <a:spcPct val="100000"/>
+              </a:lnSpc>
+              <a:spcAft>
+                <a:spcPts val="0"/>
+              </a:spcAft>
+              <a:defRPr sz="800">
+                <a:solidFill>
+                  <a:srgbClr val="58A6FF"/>
+                </a:solidFill>
+                <a:latin typeface="Consolas"/>
+              </a:defRPr>
+            </a:pPr>
+            <a:r>
+              <a:t>┌─────▼──────┐  ┌───────▼──────┐  ┌──────▼─────────┐</a:t>
+            </a:r>
+          </a:p>
+          <a:p>
+            <a:pPr>
+              <a:lnSpc>
+                <a:spcPct val="100000"/>
+              </a:lnSpc>
+              <a:spcAft>
+                <a:spcPts val="0"/>
+              </a:spcAft>
+              <a:defRPr sz="800">
+                <a:solidFill>
+                  <a:srgbClr val="58A6FF"/>
+                </a:solidFill>
+                <a:latin typeface="Consolas"/>
+              </a:defRPr>
+            </a:pPr>
+            <a:r>
+              <a:t>│ plot_      │  │ kde_         │  │ generate_html_ │</a:t>
+            </a:r>
+          </a:p>
+          <a:p>
+            <a:pPr>
+              <a:lnSpc>
+                <a:spcPct val="100000"/>
+              </a:lnSpc>
+              <a:spcAft>
+                <a:spcPts val="0"/>
+              </a:spcAft>
+              <a:defRPr sz="800">
+                <a:solidFill>
+                  <a:srgbClr val="58A6FF"/>
+                </a:solidFill>
+                <a:latin typeface="Consolas"/>
+              </a:defRPr>
+            </a:pPr>
+            <a:r>
+              <a:t>│ regression │  │ broadening() │  │ report()       │</a:t>
+            </a:r>
+          </a:p>
+          <a:p>
+            <a:pPr>
+              <a:lnSpc>
+                <a:spcPct val="100000"/>
+              </a:lnSpc>
+              <a:spcAft>
+                <a:spcPts val="0"/>
+              </a:spcAft>
+              <a:defRPr sz="800">
+                <a:solidFill>
+                  <a:srgbClr val="58A6FF"/>
+                </a:solidFill>
+                <a:latin typeface="Consolas"/>
+              </a:defRPr>
+            </a:pPr>
+            <a:r>
+              <a:t>└────────────┘  └──────────────┘  └────┬───────────┘</a:t>
+            </a:r>
+          </a:p>
+          <a:p>
+            <a:pPr>
+              <a:lnSpc>
+                <a:spcPct val="100000"/>
+              </a:lnSpc>
+              <a:spcAft>
+                <a:spcPts val="0"/>
+              </a:spcAft>
+              <a:defRPr sz="800">
+                <a:solidFill>
+                  <a:srgbClr val="8B949E"/>
+                </a:solidFill>
+                <a:latin typeface="Consolas"/>
+              </a:defRPr>
+            </a:pPr>
+            <a:r>
+              <a:t>                                       │</a:t>
+            </a:r>
+          </a:p>
+          <a:p>
+            <a:pPr>
+              <a:lnSpc>
+                <a:spcPct val="100000"/>
+              </a:lnSpc>
+              <a:spcAft>
+                <a:spcPts val="0"/>
+              </a:spcAft>
+              <a:defRPr sz="800">
+                <a:solidFill>
+                  <a:srgbClr val="57AB5A"/>
+                </a:solidFill>
+                <a:latin typeface="Consolas"/>
+              </a:defRPr>
+            </a:pPr>
+            <a:r>
+              <a:t>                          [{molecule}_spectral_analysis.html]</a:t>
+            </a:r>
+          </a:p>
+        </p:txBody>
+      </p:sp>
+    </p:spTree>
+  </p:cSld>
+  <p:clrMapOvr>
+    <a:masterClrMapping/>
+  </p:clrMapOvr>
+</p:sld>
+</file>
+
+<file path=ppt/slides/slide8.xml><?xml version="1.0" encoding="utf-8"?>
+<p:sld xmlns:a="http://schemas.openxmlformats.org/drawingml/2006/main" xmlns:p="http://schemas.openxmlformats.org/presentationml/2006/main" xmlns:r="http://schemas.openxmlformats.org/officeDocument/2006/relationships">
+  <p:cSld>
+    <p:bg>
+      <p:bgPr>
+        <a:solidFill>
+          <a:srgbClr val="0D1117"/>
+        </a:solidFill>
+        <a:effectLst/>
+      </p:bgPr>
+    </p:bg>
+    <p:spTree>
+      <p:nvGrpSpPr>
+        <p:cNvPr id="1" name=""/>
+        <p:cNvGrpSpPr/>
+        <p:nvPr/>
+      </p:nvGrpSpPr>
+      <p:grpSpPr/>
+      <p:sp>
+        <p:nvSpPr>
+          <p:cNvPr id="2" name="TextBox 1"/>
+          <p:cNvSpPr txBox="1"/>
+          <p:nvPr/>
+        </p:nvSpPr>
+        <p:spPr>
+          <a:xfrm>
+            <a:off x="457200" y="274320"/>
+            <a:ext cx="8229600" cy="457200"/>
+          </a:xfrm>
+          <a:prstGeom prst="rect">
+            <a:avLst/>
+          </a:prstGeom>
+          <a:noFill/>
+        </p:spPr>
+        <p:txBody>
+          <a:bodyPr wrap="none">
+            <a:spAutoFit/>
+          </a:bodyPr>
+          <a:lstStyle/>
+          <a:p>
+            <a:pPr>
+              <a:defRPr sz="2200" b="1">
+                <a:solidFill>
+                  <a:srgbClr val="58A6FF"/>
+                </a:solidFill>
+                <a:latin typeface="Consolas"/>
+              </a:defRPr>
+            </a:pPr>
+            <a:r>
+              <a:t>$ cat workflow_grid.txt</a:t>
+            </a:r>
+          </a:p>
+        </p:txBody>
+      </p:sp>
+      <p:sp>
+        <p:nvSpPr>
+          <p:cNvPr id="3" name="TextBox 2"/>
+          <p:cNvSpPr txBox="1"/>
+          <p:nvPr/>
+        </p:nvSpPr>
+        <p:spPr>
+          <a:xfrm>
+            <a:off x="182880" y="822960"/>
+            <a:ext cx="8778240" cy="5852160"/>
+          </a:xfrm>
+          <a:prstGeom prst="rect">
+            <a:avLst/>
+          </a:prstGeom>
+          <a:noFill/>
+        </p:spPr>
+        <p:txBody>
+          <a:bodyPr wrap="none">
+            <a:spAutoFit/>
+          </a:bodyPr>
+          <a:lstStyle/>
+          <a:p>
+            <a:pPr>
+              <a:lnSpc>
+                <a:spcPct val="100000"/>
+              </a:lnSpc>
+              <a:spcAft>
+                <a:spcPts val="0"/>
+              </a:spcAft>
+              <a:defRPr sz="800">
+                <a:solidFill>
+                  <a:srgbClr val="57AB5A"/>
+                </a:solidFill>
+                <a:latin typeface="Consolas"/>
+              </a:defRPr>
+            </a:pPr>
+            <a:r>
+              <a:t>[molecule.xyz] ─────────────────────────────────────────────────────────────┐</a:t>
+            </a:r>
+          </a:p>
+          <a:p>
+            <a:pPr>
+              <a:lnSpc>
+                <a:spcPct val="100000"/>
+              </a:lnSpc>
+              <a:spcAft>
+                <a:spcPts val="0"/>
+              </a:spcAft>
+              <a:defRPr sz="800">
+                <a:solidFill>
+                  <a:srgbClr val="8B949E"/>
+                </a:solidFill>
+                <a:latin typeface="Consolas"/>
+              </a:defRPr>
+            </a:pPr>
+            <a:r>
+              <a:t>      │                                                                      │</a:t>
+            </a:r>
+          </a:p>
+          <a:p>
+            <a:pPr>
+              <a:lnSpc>
+                <a:spcPct val="100000"/>
+              </a:lnSpc>
+              <a:spcAft>
+                <a:spcPts val="0"/>
+              </a:spcAft>
+              <a:defRPr sz="800">
+                <a:solidFill>
+                  <a:srgbClr val="58A6FF"/>
+                </a:solidFill>
+                <a:latin typeface="Consolas"/>
+              </a:defRPr>
+            </a:pPr>
+            <a:r>
+              <a:t>┌─────▼────────────────┐     ┌────────────────────┐     ┌─────────────────▼┐</a:t>
+            </a:r>
+          </a:p>
+          <a:p>
+            <a:pPr>
+              <a:lnSpc>
+                <a:spcPct val="100000"/>
+              </a:lnSpc>
+              <a:spcAft>
+                <a:spcPts val="0"/>
+              </a:spcAft>
+              <a:defRPr sz="800">
+                <a:solidFill>
+                  <a:srgbClr val="58A6FF"/>
+                </a:solidFill>
+                <a:latin typeface="Consolas"/>
+              </a:defRPr>
+            </a:pPr>
+            <a:r>
+              <a:t>│ GEOMETRY OPTIMIZER   │     │ DFT BASELINE       │     │ ML FREQ CALC     │</a:t>
+            </a:r>
+          </a:p>
+          <a:p>
+            <a:pPr>
+              <a:lnSpc>
+                <a:spcPct val="100000"/>
+              </a:lnSpc>
+              <a:spcAft>
+                <a:spcPts val="0"/>
+              </a:spcAft>
+              <a:defRPr sz="800">
+                <a:solidFill>
+                  <a:srgbClr val="C9D1D9"/>
+                </a:solidFill>
+                <a:latin typeface="Consolas"/>
+              </a:defRPr>
+            </a:pPr>
+            <a:r>
+              <a:t>│ ───────────────────  │     │ ─────────────────  │     │ ───────────────  │</a:t>
+            </a:r>
+          </a:p>
+          <a:p>
+            <a:pPr>
+              <a:lnSpc>
+                <a:spcPct val="100000"/>
+              </a:lnSpc>
+              <a:spcAft>
+                <a:spcPts val="0"/>
+              </a:spcAft>
+              <a:defRPr sz="800">
+                <a:solidFill>
+                  <a:srgbClr val="C9D1D9"/>
+                </a:solidFill>
+                <a:latin typeface="Consolas"/>
+              </a:defRPr>
+            </a:pPr>
+            <a:r>
+              <a:t>│ • load_geometry()    │     │ • gaussian_run()   │     │ • load_mace()    │</a:t>
+            </a:r>
+          </a:p>
+          <a:p>
+            <a:pPr>
+              <a:lnSpc>
+                <a:spcPct val="100000"/>
+              </a:lnSpc>
+              <a:spcAft>
+                <a:spcPts val="0"/>
+              </a:spcAft>
+              <a:defRPr sz="800">
+                <a:solidFill>
+                  <a:srgbClr val="C9D1D9"/>
+                </a:solidFill>
+                <a:latin typeface="Consolas"/>
+              </a:defRPr>
+            </a:pPr>
+            <a:r>
+              <a:t>│ • mace_omol.opt()    │────▶│ • parse_gaussian() │     │ • load_dipole()  │</a:t>
+            </a:r>
+          </a:p>
+          <a:p>
+            <a:pPr>
+              <a:lnSpc>
+                <a:spcPct val="100000"/>
+              </a:lnSpc>
+              <a:spcAft>
+                <a:spcPts val="0"/>
+              </a:spcAft>
+              <a:defRPr sz="800">
+                <a:solidFill>
+                  <a:srgbClr val="C9D1D9"/>
+                </a:solidFill>
+                <a:latin typeface="Consolas"/>
+              </a:defRPr>
+            </a:pPr>
+            <a:r>
+              <a:t>│ • save_optimized()   │     │ • extract_freqs()  │     │ • setup_zmq()    │</a:t>
+            </a:r>
+          </a:p>
+          <a:p>
+            <a:pPr>
+              <a:lnSpc>
+                <a:spcPct val="100000"/>
+              </a:lnSpc>
+              <a:spcAft>
+                <a:spcPts val="0"/>
+              </a:spcAft>
+              <a:defRPr sz="800">
+                <a:solidFill>
+                  <a:srgbClr val="58A6FF"/>
+                </a:solidFill>
+                <a:latin typeface="Consolas"/>
+              </a:defRPr>
+            </a:pPr>
+            <a:r>
+              <a:t>└──────────────────────┘     └────────┬───────────┘     └─────┬────────────┘</a:t>
+            </a:r>
+          </a:p>
+          <a:p>
+            <a:pPr>
+              <a:lnSpc>
+                <a:spcPct val="100000"/>
+              </a:lnSpc>
+              <a:spcAft>
+                <a:spcPts val="0"/>
+              </a:spcAft>
+              <a:defRPr sz="800">
+                <a:solidFill>
+                  <a:srgbClr val="8B949E"/>
+                </a:solidFill>
+                <a:latin typeface="Consolas"/>
+              </a:defRPr>
+            </a:pPr>
+            <a:r>
+              <a:t>                                      │                       │</a:t>
+            </a:r>
+          </a:p>
+          <a:p>
+            <a:pPr>
+              <a:lnSpc>
+                <a:spcPct val="100000"/>
+              </a:lnSpc>
+              <a:spcAft>
+                <a:spcPts val="0"/>
+              </a:spcAft>
+              <a:defRPr sz="800">
+                <a:solidFill>
+                  <a:srgbClr val="DB6D28"/>
+                </a:solidFill>
+                <a:latin typeface="Consolas"/>
+              </a:defRPr>
+            </a:pPr>
+            <a:r>
+              <a:t>                                      │     ┌─────────────────▼────────────┐</a:t>
+            </a:r>
+          </a:p>
+          <a:p>
+            <a:pPr>
+              <a:lnSpc>
+                <a:spcPct val="100000"/>
+              </a:lnSpc>
+              <a:spcAft>
+                <a:spcPts val="0"/>
+              </a:spcAft>
+              <a:defRPr sz="800">
+                <a:solidFill>
+                  <a:srgbClr val="DB6D28"/>
+                </a:solidFill>
+                <a:latin typeface="Consolas"/>
+              </a:defRPr>
+            </a:pPr>
+            <a:r>
+              <a:t>                                      │     │ ZMQ BRIDGE                   │</a:t>
+            </a:r>
+          </a:p>
+          <a:p>
+            <a:pPr>
+              <a:lnSpc>
+                <a:spcPct val="100000"/>
+              </a:lnSpc>
+              <a:spcAft>
+                <a:spcPts val="0"/>
+              </a:spcAft>
+              <a:defRPr sz="800">
+                <a:solidFill>
+                  <a:srgbClr val="C9D1D9"/>
+                </a:solidFill>
+                <a:latin typeface="Consolas"/>
+              </a:defRPr>
+            </a:pPr>
+            <a:r>
+              <a:t>                                      │     │ ──────────────────────────   │</a:t>
+            </a:r>
+          </a:p>
+          <a:p>
+            <a:pPr>
+              <a:lnSpc>
+                <a:spcPct val="100000"/>
+              </a:lnSpc>
+              <a:spcAft>
+                <a:spcPts val="0"/>
+              </a:spcAft>
+              <a:defRPr sz="800">
+                <a:solidFill>
+                  <a:srgbClr val="DB6D28"/>
+                </a:solidFill>
+                <a:latin typeface="Consolas"/>
+              </a:defRPr>
+            </a:pPr>
+            <a:r>
+              <a:t>                                      │     │ ┌─────────┐  ┌────────────┐ │</a:t>
+            </a:r>
+          </a:p>
+          <a:p>
+            <a:pPr>
+              <a:lnSpc>
+                <a:spcPct val="100000"/>
+              </a:lnSpc>
+              <a:spcAft>
+                <a:spcPts val="0"/>
+              </a:spcAft>
+              <a:defRPr sz="800">
+                <a:solidFill>
+                  <a:srgbClr val="DB6D28"/>
+                </a:solidFill>
+                <a:latin typeface="Consolas"/>
+              </a:defRPr>
+            </a:pPr>
+            <a:r>
+              <a:t>                                      │     │ │ Main    │  │ Helper     │ │</a:t>
+            </a:r>
+          </a:p>
+          <a:p>
+            <a:pPr>
+              <a:lnSpc>
+                <a:spcPct val="100000"/>
+              </a:lnSpc>
+              <a:spcAft>
+                <a:spcPts val="0"/>
+              </a:spcAft>
+              <a:defRPr sz="800">
+                <a:solidFill>
+                  <a:srgbClr val="DB6D28"/>
+                </a:solidFill>
+                <a:latin typeface="Consolas"/>
+              </a:defRPr>
+            </a:pPr>
+            <a:r>
+              <a:t>                                      │     │ │ Process │◀▶│ Script     │ │</a:t>
+            </a:r>
+          </a:p>
+          <a:p>
+            <a:pPr>
+              <a:lnSpc>
+                <a:spcPct val="100000"/>
+              </a:lnSpc>
+              <a:spcAft>
+                <a:spcPts val="0"/>
+              </a:spcAft>
+              <a:defRPr sz="800">
+                <a:solidFill>
+                  <a:srgbClr val="DB6D28"/>
+                </a:solidFill>
+                <a:latin typeface="Consolas"/>
+              </a:defRPr>
+            </a:pPr>
+            <a:r>
+              <a:t>                                      │     │ └────┬────┘  └──────┬─────┘ │</a:t>
+            </a:r>
+          </a:p>
+          <a:p>
+            <a:pPr>
+              <a:lnSpc>
+                <a:spcPct val="100000"/>
+              </a:lnSpc>
+              <a:spcAft>
+                <a:spcPts val="0"/>
+              </a:spcAft>
+              <a:defRPr sz="800">
+                <a:solidFill>
+                  <a:srgbClr val="8B949E"/>
+                </a:solidFill>
+                <a:latin typeface="Consolas"/>
+              </a:defRPr>
+            </a:pPr>
+            <a:r>
+              <a:t>                                      │     │      │              │       │</a:t>
+            </a:r>
+          </a:p>
+          <a:p>
+            <a:pPr>
+              <a:lnSpc>
+                <a:spcPct val="100000"/>
+              </a:lnSpc>
+              <a:spcAft>
+                <a:spcPts val="0"/>
+              </a:spcAft>
+              <a:defRPr sz="800">
+                <a:solidFill>
+                  <a:srgbClr val="8B949E"/>
+                </a:solidFill>
+                <a:latin typeface="Consolas"/>
+              </a:defRPr>
+            </a:pPr>
+            <a:r>
+              <a:t>                                      │     │      ▼              ▼       │</a:t>
+            </a:r>
+          </a:p>
+          <a:p>
+            <a:pPr>
+              <a:lnSpc>
+                <a:spcPct val="100000"/>
+              </a:lnSpc>
+              <a:spcAft>
+                <a:spcPts val="0"/>
+              </a:spcAft>
+              <a:defRPr sz="800">
+                <a:solidFill>
+                  <a:srgbClr val="DB6D28"/>
+                </a:solidFill>
+                <a:latin typeface="Consolas"/>
+              </a:defRPr>
+            </a:pPr>
+            <a:r>
+              <a:t>                                      │     │ ┌───────────────────────┐  │</a:t>
+            </a:r>
+          </a:p>
+          <a:p>
+            <a:pPr>
+              <a:lnSpc>
+                <a:spcPct val="100000"/>
+              </a:lnSpc>
+              <a:spcAft>
+                <a:spcPts val="0"/>
+              </a:spcAft>
+              <a:defRPr sz="800">
+                <a:solidFill>
+                  <a:srgbClr val="DB6D28"/>
+                </a:solidFill>
+                <a:latin typeface="Consolas"/>
+              </a:defRPr>
+            </a:pPr>
+            <a:r>
+              <a:t>                                      │     │ │ Gaussian Freq Calc    │  │</a:t>
+            </a:r>
+          </a:p>
+          <a:p>
+            <a:pPr>
+              <a:lnSpc>
+                <a:spcPct val="100000"/>
+              </a:lnSpc>
+              <a:spcAft>
+                <a:spcPts val="0"/>
+              </a:spcAft>
+              <a:defRPr sz="800">
+                <a:solidFill>
+                  <a:srgbClr val="DB6D28"/>
+                </a:solidFill>
+                <a:latin typeface="Consolas"/>
+              </a:defRPr>
+            </a:pPr>
+            <a:r>
+              <a:t>                                      │     │ └───────────────────────┘  │</a:t>
+            </a:r>
+          </a:p>
+          <a:p>
+            <a:pPr>
+              <a:lnSpc>
+                <a:spcPct val="100000"/>
+              </a:lnSpc>
+              <a:spcAft>
+                <a:spcPts val="0"/>
+              </a:spcAft>
+              <a:defRPr sz="800">
+                <a:solidFill>
+                  <a:srgbClr val="DB6D28"/>
+                </a:solidFill>
+                <a:latin typeface="Consolas"/>
+              </a:defRPr>
+            </a:pPr>
+            <a:r>
+              <a:t>                                      │     └──────────────┬───────────────┘</a:t>
+            </a:r>
+          </a:p>
+          <a:p>
+            <a:pPr>
+              <a:lnSpc>
+                <a:spcPct val="100000"/>
+              </a:lnSpc>
+              <a:spcAft>
+                <a:spcPts val="0"/>
+              </a:spcAft>
+              <a:defRPr sz="800">
+                <a:solidFill>
+                  <a:srgbClr val="8B949E"/>
+                </a:solidFill>
+                <a:latin typeface="Consolas"/>
+              </a:defRPr>
+            </a:pPr>
+            <a:r>
+              <a:t>                                      │                    │</a:t>
+            </a:r>
+          </a:p>
+          <a:p>
+            <a:pPr>
+              <a:lnSpc>
+                <a:spcPct val="100000"/>
+              </a:lnSpc>
+              <a:spcAft>
+                <a:spcPts val="0"/>
+              </a:spcAft>
+              <a:defRPr sz="800">
+                <a:solidFill>
+                  <a:srgbClr val="DB6D28"/>
+                </a:solidFill>
+                <a:latin typeface="Consolas"/>
+              </a:defRPr>
+            </a:pPr>
+            <a:r>
+              <a:t>                                      │     ┌──────────────▼────────────┐</a:t>
+            </a:r>
+          </a:p>
+          <a:p>
+            <a:pPr>
+              <a:lnSpc>
+                <a:spcPct val="100000"/>
+              </a:lnSpc>
+              <a:spcAft>
+                <a:spcPts val="0"/>
+              </a:spcAft>
+              <a:defRPr sz="800">
+                <a:solidFill>
+                  <a:srgbClr val="DB6D28"/>
+                </a:solidFill>
+                <a:latin typeface="Consolas"/>
+              </a:defRPr>
+            </a:pPr>
+            <a:r>
+              <a:t>                                      │     │ parse_ml_results()        │</a:t>
+            </a:r>
+          </a:p>
+          <a:p>
+            <a:pPr>
+              <a:lnSpc>
+                <a:spcPct val="100000"/>
+              </a:lnSpc>
+              <a:spcAft>
+                <a:spcPts val="0"/>
+              </a:spcAft>
+              <a:defRPr sz="800">
+                <a:solidFill>
+                  <a:srgbClr val="DB6D28"/>
+                </a:solidFill>
+                <a:latin typeface="Consolas"/>
+              </a:defRPr>
+            </a:pPr>
+            <a:r>
+              <a:t>                                      │     └──────────────┬────────────┘</a:t>
+            </a:r>
+          </a:p>
+          <a:p>
+            <a:pPr>
+              <a:lnSpc>
+                <a:spcPct val="100000"/>
+              </a:lnSpc>
+              <a:spcAft>
+                <a:spcPts val="0"/>
+              </a:spcAft>
+              <a:defRPr sz="800">
+                <a:solidFill>
+                  <a:srgbClr val="8B949E"/>
+                </a:solidFill>
+                <a:latin typeface="Consolas"/>
+              </a:defRPr>
+            </a:pPr>
+            <a:r>
+              <a:t>                                      │                    │</a:t>
+            </a:r>
+          </a:p>
+          <a:p>
+            <a:pPr>
+              <a:lnSpc>
+                <a:spcPct val="100000"/>
+              </a:lnSpc>
+              <a:spcAft>
+                <a:spcPts val="0"/>
+              </a:spcAft>
+              <a:defRPr sz="800">
+                <a:solidFill>
+                  <a:srgbClr val="8B949E"/>
+                </a:solidFill>
+                <a:latin typeface="Consolas"/>
+              </a:defRPr>
+            </a:pPr>
+            <a:r>
+              <a:t>                                      └────────────────────┘</a:t>
+            </a:r>
+          </a:p>
+          <a:p>
+            <a:pPr>
+              <a:lnSpc>
+                <a:spcPct val="100000"/>
+              </a:lnSpc>
+              <a:spcAft>
+                <a:spcPts val="0"/>
+              </a:spcAft>
+              <a:defRPr sz="800">
+                <a:solidFill>
+                  <a:srgbClr val="8B949E"/>
+                </a:solidFill>
+                <a:latin typeface="Consolas"/>
+              </a:defRPr>
+            </a:pPr>
+            <a:r>
+              <a:t>                                      │</a:t>
+            </a:r>
+          </a:p>
+          <a:p>
+            <a:pPr>
+              <a:lnSpc>
+                <a:spcPct val="100000"/>
+              </a:lnSpc>
+              <a:spcAft>
+                <a:spcPts val="0"/>
+              </a:spcAft>
+              <a:defRPr sz="800">
+                <a:solidFill>
+                  <a:srgbClr val="58A6FF"/>
+                </a:solidFill>
+                <a:latin typeface="Consolas"/>
+              </a:defRPr>
+            </a:pPr>
+            <a:r>
+              <a:t>┌─────────────────────────────────────▼──────────────────────────────────────┐</a:t>
+            </a:r>
+          </a:p>
+          <a:p>
+            <a:pPr>
+              <a:lnSpc>
+                <a:spcPct val="100000"/>
+              </a:lnSpc>
+              <a:spcAft>
+                <a:spcPts val="0"/>
+              </a:spcAft>
+              <a:defRPr sz="800">
+                <a:solidFill>
+                  <a:srgbClr val="58A6FF"/>
+                </a:solidFill>
+                <a:latin typeface="Consolas"/>
+              </a:defRPr>
+            </a:pPr>
+            <a:r>
+              <a:t>│ ANALYSIS &amp; COMPARISON                                                       │</a:t>
+            </a:r>
+          </a:p>
+          <a:p>
+            <a:pPr>
+              <a:lnSpc>
+                <a:spcPct val="100000"/>
+              </a:lnSpc>
+              <a:spcAft>
+                <a:spcPts val="0"/>
+              </a:spcAft>
+              <a:defRPr sz="800">
+                <a:solidFill>
+                  <a:srgbClr val="C9D1D9"/>
+                </a:solidFill>
+                <a:latin typeface="Consolas"/>
+              </a:defRPr>
+            </a:pPr>
+            <a:r>
+              <a:t>│ ──────────────────────────────────────────────────────────────────────────  │</a:t>
+            </a:r>
+          </a:p>
+          <a:p>
+            <a:pPr>
+              <a:lnSpc>
+                <a:spcPct val="100000"/>
+              </a:lnSpc>
+              <a:spcAft>
+                <a:spcPts val="0"/>
+              </a:spcAft>
+              <a:defRPr sz="800">
+                <a:solidFill>
+                  <a:srgbClr val="58A6FF"/>
+                </a:solidFill>
+                <a:latin typeface="Consolas"/>
+              </a:defRPr>
+            </a:pPr>
+            <a:r>
+              <a:t>│  ┌──────────────┐  ┌───────────────┐  ┌──────────┐  ┌──────────────────┐  │</a:t>
+            </a:r>
+          </a:p>
+          <a:p>
+            <a:pPr>
+              <a:lnSpc>
+                <a:spcPct val="100000"/>
+              </a:lnSpc>
+              <a:spcAft>
+                <a:spcPts val="0"/>
+              </a:spcAft>
+              <a:defRPr sz="800">
+                <a:solidFill>
+                  <a:srgbClr val="58A6FF"/>
+                </a:solidFill>
+                <a:latin typeface="Consolas"/>
+              </a:defRPr>
+            </a:pPr>
+            <a:r>
+              <a:t>│  │ load_all()   │─▶│ find_dft_     │─▶│ mode_    │─▶│ calc_metrics()   │  │</a:t>
+            </a:r>
+          </a:p>
+          <a:p>
+            <a:pPr>
+              <a:lnSpc>
+                <a:spcPct val="100000"/>
+              </a:lnSpc>
+              <a:spcAft>
+                <a:spcPts val="0"/>
+              </a:spcAft>
+              <a:defRPr sz="800">
+                <a:solidFill>
+                  <a:srgbClr val="C9D1D9"/>
+                </a:solidFill>
+                <a:latin typeface="Consolas"/>
+              </a:defRPr>
+            </a:pPr>
+            <a:r>
+              <a:t>│  │              │  │ baseline()    │  │ matching │  │ (MAE/RMSE/R²)    │  │</a:t>
+            </a:r>
+          </a:p>
+          <a:p>
+            <a:pPr>
+              <a:lnSpc>
+                <a:spcPct val="100000"/>
+              </a:lnSpc>
+              <a:spcAft>
+                <a:spcPts val="0"/>
+              </a:spcAft>
+              <a:defRPr sz="800">
+                <a:solidFill>
+                  <a:srgbClr val="58A6FF"/>
+                </a:solidFill>
+                <a:latin typeface="Consolas"/>
+              </a:defRPr>
+            </a:pPr>
+            <a:r>
+              <a:t>│  └──────────────┘  └───────────────┘  └──────────┘  └─────┬────────────┘  │</a:t>
+            </a:r>
+          </a:p>
+          <a:p>
+            <a:pPr>
+              <a:lnSpc>
+                <a:spcPct val="100000"/>
+              </a:lnSpc>
+              <a:spcAft>
+                <a:spcPts val="0"/>
+              </a:spcAft>
+              <a:defRPr sz="800">
+                <a:solidFill>
+                  <a:srgbClr val="8B949E"/>
+                </a:solidFill>
+                <a:latin typeface="Consolas"/>
+              </a:defRPr>
+            </a:pPr>
+            <a:r>
+              <a:t>│                                                            │               │</a:t>
+            </a:r>
+          </a:p>
+          <a:p>
+            <a:pPr>
+              <a:lnSpc>
+                <a:spcPct val="100000"/>
+              </a:lnSpc>
+              <a:spcAft>
+                <a:spcPts val="0"/>
+              </a:spcAft>
+              <a:defRPr sz="800">
+                <a:solidFill>
+                  <a:srgbClr val="58A6FF"/>
+                </a:solidFill>
+                <a:latin typeface="Consolas"/>
+              </a:defRPr>
+            </a:pPr>
+            <a:r>
+              <a:t>│  ┌──────────────┐  ┌───────────────┐  ┌────────────────────▼───────────┐  │</a:t>
+            </a:r>
+          </a:p>
+          <a:p>
+            <a:pPr>
+              <a:lnSpc>
+                <a:spcPct val="100000"/>
+              </a:lnSpc>
+              <a:spcAft>
+                <a:spcPts val="0"/>
+              </a:spcAft>
+              <a:defRPr sz="800">
+                <a:solidFill>
+                  <a:srgbClr val="58A6FF"/>
+                </a:solidFill>
+                <a:latin typeface="Consolas"/>
+              </a:defRPr>
+            </a:pPr>
+            <a:r>
+              <a:t>│  │ plot_        │  │ kde_          │  │ generate_html_report()         │  │</a:t>
+            </a:r>
+          </a:p>
+          <a:p>
+            <a:pPr>
+              <a:lnSpc>
+                <a:spcPct val="100000"/>
+              </a:lnSpc>
+              <a:spcAft>
+                <a:spcPts val="0"/>
+              </a:spcAft>
+              <a:defRPr sz="800">
+                <a:solidFill>
+                  <a:srgbClr val="C9D1D9"/>
+                </a:solidFill>
+                <a:latin typeface="Consolas"/>
+              </a:defRPr>
+            </a:pPr>
+            <a:r>
+              <a:t>│  │ regression() │  │ broadening()  │  │ (interactive, publication)     │  │</a:t>
+            </a:r>
+          </a:p>
+          <a:p>
+            <a:pPr>
+              <a:lnSpc>
+                <a:spcPct val="100000"/>
+              </a:lnSpc>
+              <a:spcAft>
+                <a:spcPts val="0"/>
+              </a:spcAft>
+              <a:defRPr sz="800">
+                <a:solidFill>
+                  <a:srgbClr val="58A6FF"/>
+                </a:solidFill>
+                <a:latin typeface="Consolas"/>
+              </a:defRPr>
+            </a:pPr>
+            <a:r>
+              <a:t>│  └──────────────┘  └───────────────┘  └────────────────────────────────┘  │</a:t>
+            </a:r>
+          </a:p>
+          <a:p>
+            <a:pPr>
+              <a:lnSpc>
+                <a:spcPct val="100000"/>
+              </a:lnSpc>
+              <a:spcAft>
+                <a:spcPts val="0"/>
+              </a:spcAft>
+              <a:defRPr sz="800">
+                <a:solidFill>
+                  <a:srgbClr val="58A6FF"/>
+                </a:solidFill>
+                <a:latin typeface="Consolas"/>
+              </a:defRPr>
+            </a:pPr>
+            <a:r>
+              <a:t>└─────────────────────────────────────────────┬───────────────────────────────┘</a:t>
+            </a:r>
+          </a:p>
+          <a:p>
+            <a:pPr>
+              <a:lnSpc>
+                <a:spcPct val="100000"/>
+              </a:lnSpc>
+              <a:spcAft>
+                <a:spcPts val="0"/>
+              </a:spcAft>
+              <a:defRPr sz="800">
+                <a:solidFill>
+                  <a:srgbClr val="8B949E"/>
+                </a:solidFill>
+                <a:latin typeface="Consolas"/>
+              </a:defRPr>
+            </a:pPr>
+            <a:r>
+              <a:t>                                              │</a:t>
+            </a:r>
+          </a:p>
+          <a:p>
+            <a:pPr>
+              <a:lnSpc>
+                <a:spcPct val="100000"/>
+              </a:lnSpc>
+              <a:spcAft>
+                <a:spcPts val="0"/>
+              </a:spcAft>
+              <a:defRPr sz="800">
+                <a:solidFill>
+                  <a:srgbClr val="57AB5A"/>
+                </a:solidFill>
+                <a:latin typeface="Consolas"/>
+              </a:defRPr>
+            </a:pPr>
+            <a:r>
+              <a:t>                                   [{molecule}_spectral_analysis.html]</a:t>
             </a:r>
           </a:p>
         </p:txBody>

</xml_diff>

<commit_message>
Simplify grid workflow: highlight DFT opt, condense ZMQ, expand width
- Add visual box showing DFT's built-in optimization step with arrow
- Simplify ML freq calc: condense ZMQ bridge (just reference dedicated slide)
- Expand horizontal width to 9.8" (from 9.6") for better space usage
- Keep Analysis module parent box structure
- More detailed function names (eigenvector_mode_matching, load_all_results)
</commit_message>
<xml_diff>
--- a/presentation/test_detailed_workflow.pptx
+++ b/presentation/test_detailed_workflow.pptx
@@ -10160,8 +10160,8 @@
         </p:nvSpPr>
         <p:spPr>
           <a:xfrm>
-            <a:off x="457200" y="274320"/>
-            <a:ext cx="8229600" cy="457200"/>
+            <a:off x="365760" y="274320"/>
+            <a:ext cx="8412480" cy="457200"/>
           </a:xfrm>
           <a:prstGeom prst="rect">
             <a:avLst/>
@@ -10196,8 +10196,8 @@
         </p:nvSpPr>
         <p:spPr>
           <a:xfrm>
-            <a:off x="182880" y="822960"/>
-            <a:ext cx="8778240" cy="5852160"/>
+            <a:off x="91440" y="822960"/>
+            <a:ext cx="8961120" cy="5852160"/>
           </a:xfrm>
           <a:prstGeom prst="rect">
             <a:avLst/>
@@ -10225,26 +10225,26 @@
               </a:defRPr>
             </a:pPr>
             <a:r>
-              <a:t>[molecule.xyz] ─────────────────────────────────────────────────────────────┐</a:t>
-            </a:r>
-          </a:p>
-          <a:p>
-            <a:pPr>
-              <a:lnSpc>
-                <a:spcPct val="100000"/>
-              </a:lnSpc>
-              <a:spcAft>
-                <a:spcPts val="0"/>
-              </a:spcAft>
-              <a:defRPr sz="800">
-                <a:solidFill>
-                  <a:srgbClr val="8B949E"/>
-                </a:solidFill>
-                <a:latin typeface="Consolas"/>
-              </a:defRPr>
-            </a:pPr>
-            <a:r>
-              <a:t>      │                                                                      │</a:t>
+              <a:t>[molecule.xyz] ───────────────────────────────────────────────────────────────────────────┐</a:t>
+            </a:r>
+          </a:p>
+          <a:p>
+            <a:pPr>
+              <a:lnSpc>
+                <a:spcPct val="100000"/>
+              </a:lnSpc>
+              <a:spcAft>
+                <a:spcPts val="0"/>
+              </a:spcAft>
+              <a:defRPr sz="800">
+                <a:solidFill>
+                  <a:srgbClr val="8B949E"/>
+                </a:solidFill>
+                <a:latin typeface="Consolas"/>
+              </a:defRPr>
+            </a:pPr>
+            <a:r>
+              <a:t>      │                                                                                    │</a:t>
             </a:r>
           </a:p>
           <a:p>
@@ -10263,7 +10263,7 @@
               </a:defRPr>
             </a:pPr>
             <a:r>
-              <a:t>┌─────▼────────────────┐     ┌────────────────────┐     ┌─────────────────▼┐</a:t>
+              <a:t>┌─────▼─────────────────────┐     ┌──────────────────────────────┐     ┌─────────────────▼──────────────┐</a:t>
             </a:r>
           </a:p>
           <a:p>
@@ -10282,7 +10282,7 @@
               </a:defRPr>
             </a:pPr>
             <a:r>
-              <a:t>│ GEOMETRY OPTIMIZER   │     │ DFT BASELINE       │     │ ML FREQ CALC     │</a:t>
+              <a:t>│ GEOMETRY OPTIMIZER        │     │ DFT BASELINE                 │     │ ML FREQ CALC                   │</a:t>
             </a:r>
           </a:p>
           <a:p>
@@ -10301,7 +10301,7 @@
               </a:defRPr>
             </a:pPr>
             <a:r>
-              <a:t>│ ───────────────────  │     │ ─────────────────  │     │ ───────────────  │</a:t>
+              <a:t>│ ────────────────────────  │     │ ───────────────────────────  │     │ ──────────────────────────────  │</a:t>
             </a:r>
           </a:p>
           <a:p>
@@ -10320,7 +10320,7 @@
               </a:defRPr>
             </a:pPr>
             <a:r>
-              <a:t>│ • load_geometry()    │     │ • gaussian_run()   │     │ • load_mace()    │</a:t>
+              <a:t>│ • load_geometry()         │     │    ╭─────────────────╮       │     │ • load_mace_calculator()       │</a:t>
             </a:r>
           </a:p>
           <a:p>
@@ -10339,7 +10339,7 @@
               </a:defRPr>
             </a:pPr>
             <a:r>
-              <a:t>│ • mace_omol.opt()    │────▶│ • parse_gaussian() │     │ • load_dipole()  │</a:t>
+              <a:t>│ • mace_omol.optimize()    │────▶│    │ Built-in opt    │       │     │   (MACE-MP/MACE-OMOL)          │</a:t>
             </a:r>
           </a:p>
           <a:p>
@@ -10358,7 +10358,102 @@
               </a:defRPr>
             </a:pPr>
             <a:r>
-              <a:t>│ • save_optimized()   │     │ • extract_freqs()  │     │ • setup_zmq()    │</a:t>
+              <a:t>│ • save_optimized()        │     │    │ B3LYP/6-31G(d,p)│       │     │ • get_dipole_calculator()      │</a:t>
+            </a:r>
+          </a:p>
+          <a:p>
+            <a:pPr>
+              <a:lnSpc>
+                <a:spcPct val="100000"/>
+              </a:lnSpc>
+              <a:spcAft>
+                <a:spcPts val="0"/>
+              </a:spcAft>
+              <a:defRPr sz="800">
+                <a:solidFill>
+                  <a:srgbClr val="C9D1D9"/>
+                </a:solidFill>
+                <a:latin typeface="Consolas"/>
+              </a:defRPr>
+            </a:pPr>
+            <a:r>
+              <a:t>│                           │     │    ╰────────┬────────╯       │     │   (Espaloma/MACE-ML/xTB)       │</a:t>
+            </a:r>
+          </a:p>
+          <a:p>
+            <a:pPr>
+              <a:lnSpc>
+                <a:spcPct val="100000"/>
+              </a:lnSpc>
+              <a:spcAft>
+                <a:spcPts val="0"/>
+              </a:spcAft>
+              <a:defRPr sz="800">
+                <a:solidFill>
+                  <a:srgbClr val="C9D1D9"/>
+                </a:solidFill>
+                <a:latin typeface="Consolas"/>
+              </a:defRPr>
+            </a:pPr>
+            <a:r>
+              <a:t>│                           │     │             ▼                │     │ • setup_zmq_server()           │</a:t>
+            </a:r>
+          </a:p>
+          <a:p>
+            <a:pPr>
+              <a:lnSpc>
+                <a:spcPct val="100000"/>
+              </a:lnSpc>
+              <a:spcAft>
+                <a:spcPts val="0"/>
+              </a:spcAft>
+              <a:defRPr sz="800">
+                <a:solidFill>
+                  <a:srgbClr val="C9D1D9"/>
+                </a:solidFill>
+                <a:latin typeface="Consolas"/>
+              </a:defRPr>
+            </a:pPr>
+            <a:r>
+              <a:t>│                           │     │ • gaussian_freq()            │     │ • launch_gaussian()            │</a:t>
+            </a:r>
+          </a:p>
+          <a:p>
+            <a:pPr>
+              <a:lnSpc>
+                <a:spcPct val="100000"/>
+              </a:lnSpc>
+              <a:spcAft>
+                <a:spcPts val="0"/>
+              </a:spcAft>
+              <a:defRPr sz="800">
+                <a:solidFill>
+                  <a:srgbClr val="C9D1D9"/>
+                </a:solidFill>
+                <a:latin typeface="Consolas"/>
+              </a:defRPr>
+            </a:pPr>
+            <a:r>
+              <a:t>│                           │     │ • parse_gaussian()           │     │ • zmq_dipole_loop()            │</a:t>
+            </a:r>
+          </a:p>
+          <a:p>
+            <a:pPr>
+              <a:lnSpc>
+                <a:spcPct val="100000"/>
+              </a:lnSpc>
+              <a:spcAft>
+                <a:spcPts val="0"/>
+              </a:spcAft>
+              <a:defRPr sz="800">
+                <a:solidFill>
+                  <a:srgbClr val="C9D1D9"/>
+                </a:solidFill>
+                <a:latin typeface="Consolas"/>
+              </a:defRPr>
+            </a:pPr>
+            <a:r>
+              <a:t>│                           │     │ • extract_frequencies()      │     │   (via ZMQ bridge - see slide) │</a:t>
             </a:r>
           </a:p>
           <a:p>
@@ -10377,64 +10472,102 @@
               </a:defRPr>
             </a:pPr>
             <a:r>
-              <a:t>└──────────────────────┘     └────────┬───────────┘     └─────┬────────────┘</a:t>
-            </a:r>
-          </a:p>
-          <a:p>
-            <a:pPr>
-              <a:lnSpc>
-                <a:spcPct val="100000"/>
-              </a:lnSpc>
-              <a:spcAft>
-                <a:spcPts val="0"/>
-              </a:spcAft>
-              <a:defRPr sz="800">
-                <a:solidFill>
-                  <a:srgbClr val="8B949E"/>
-                </a:solidFill>
-                <a:latin typeface="Consolas"/>
-              </a:defRPr>
-            </a:pPr>
-            <a:r>
-              <a:t>                                      │                       │</a:t>
-            </a:r>
-          </a:p>
-          <a:p>
-            <a:pPr>
-              <a:lnSpc>
-                <a:spcPct val="100000"/>
-              </a:lnSpc>
-              <a:spcAft>
-                <a:spcPts val="0"/>
-              </a:spcAft>
-              <a:defRPr sz="800">
-                <a:solidFill>
-                  <a:srgbClr val="DB6D28"/>
-                </a:solidFill>
-                <a:latin typeface="Consolas"/>
-              </a:defRPr>
-            </a:pPr>
-            <a:r>
-              <a:t>                                      │     ┌─────────────────▼────────────┐</a:t>
-            </a:r>
-          </a:p>
-          <a:p>
-            <a:pPr>
-              <a:lnSpc>
-                <a:spcPct val="100000"/>
-              </a:lnSpc>
-              <a:spcAft>
-                <a:spcPts val="0"/>
-              </a:spcAft>
-              <a:defRPr sz="800">
-                <a:solidFill>
-                  <a:srgbClr val="DB6D28"/>
-                </a:solidFill>
-                <a:latin typeface="Consolas"/>
-              </a:defRPr>
-            </a:pPr>
-            <a:r>
-              <a:t>                                      │     │ ZMQ BRIDGE                   │</a:t>
+              <a:t>└───────────────────────────┘     └──────────────┬───────────────┘     └─────────────────┬──────────────┘</a:t>
+            </a:r>
+          </a:p>
+          <a:p>
+            <a:pPr>
+              <a:lnSpc>
+                <a:spcPct val="100000"/>
+              </a:lnSpc>
+              <a:spcAft>
+                <a:spcPts val="0"/>
+              </a:spcAft>
+              <a:defRPr sz="800">
+                <a:solidFill>
+                  <a:srgbClr val="8B949E"/>
+                </a:solidFill>
+                <a:latin typeface="Consolas"/>
+              </a:defRPr>
+            </a:pPr>
+            <a:r>
+              <a:t>                                                 │                                       │</a:t>
+            </a:r>
+          </a:p>
+          <a:p>
+            <a:pPr>
+              <a:lnSpc>
+                <a:spcPct val="100000"/>
+              </a:lnSpc>
+              <a:spcAft>
+                <a:spcPts val="0"/>
+              </a:spcAft>
+              <a:defRPr sz="800">
+                <a:solidFill>
+                  <a:srgbClr val="8B949E"/>
+                </a:solidFill>
+                <a:latin typeface="Consolas"/>
+              </a:defRPr>
+            </a:pPr>
+            <a:r>
+              <a:t>                                                 └───────────────────┬───────────────────┘</a:t>
+            </a:r>
+          </a:p>
+          <a:p>
+            <a:pPr>
+              <a:lnSpc>
+                <a:spcPct val="100000"/>
+              </a:lnSpc>
+              <a:spcAft>
+                <a:spcPts val="0"/>
+              </a:spcAft>
+              <a:defRPr sz="800">
+                <a:solidFill>
+                  <a:srgbClr val="8B949E"/>
+                </a:solidFill>
+                <a:latin typeface="Consolas"/>
+              </a:defRPr>
+            </a:pPr>
+            <a:r>
+              <a:t>                                                                     │</a:t>
+            </a:r>
+          </a:p>
+          <a:p>
+            <a:pPr>
+              <a:lnSpc>
+                <a:spcPct val="100000"/>
+              </a:lnSpc>
+              <a:spcAft>
+                <a:spcPts val="0"/>
+              </a:spcAft>
+              <a:defRPr sz="800">
+                <a:solidFill>
+                  <a:srgbClr val="58A6FF"/>
+                </a:solidFill>
+                <a:latin typeface="Consolas"/>
+              </a:defRPr>
+            </a:pPr>
+            <a:r>
+              <a:t>┌────────────────────────────────────────────────▼────────────────────────────────────────────────────────┐</a:t>
+            </a:r>
+          </a:p>
+          <a:p>
+            <a:pPr>
+              <a:lnSpc>
+                <a:spcPct val="100000"/>
+              </a:lnSpc>
+              <a:spcAft>
+                <a:spcPts val="0"/>
+              </a:spcAft>
+              <a:defRPr sz="800">
+                <a:solidFill>
+                  <a:srgbClr val="58A6FF"/>
+                </a:solidFill>
+                <a:latin typeface="Consolas"/>
+              </a:defRPr>
+            </a:pPr>
+            <a:r>
+              <a:t>│ ANALYSIS &amp; COMPARISON                                                                                    │</a:t>
             </a:r>
           </a:p>
           <a:p>
@@ -10453,330 +10586,7 @@
               </a:defRPr>
             </a:pPr>
             <a:r>
-              <a:t>                                      │     │ ──────────────────────────   │</a:t>
-            </a:r>
-          </a:p>
-          <a:p>
-            <a:pPr>
-              <a:lnSpc>
-                <a:spcPct val="100000"/>
-              </a:lnSpc>
-              <a:spcAft>
-                <a:spcPts val="0"/>
-              </a:spcAft>
-              <a:defRPr sz="800">
-                <a:solidFill>
-                  <a:srgbClr val="DB6D28"/>
-                </a:solidFill>
-                <a:latin typeface="Consolas"/>
-              </a:defRPr>
-            </a:pPr>
-            <a:r>
-              <a:t>                                      │     │ ┌─────────┐  ┌────────────┐ │</a:t>
-            </a:r>
-          </a:p>
-          <a:p>
-            <a:pPr>
-              <a:lnSpc>
-                <a:spcPct val="100000"/>
-              </a:lnSpc>
-              <a:spcAft>
-                <a:spcPts val="0"/>
-              </a:spcAft>
-              <a:defRPr sz="800">
-                <a:solidFill>
-                  <a:srgbClr val="DB6D28"/>
-                </a:solidFill>
-                <a:latin typeface="Consolas"/>
-              </a:defRPr>
-            </a:pPr>
-            <a:r>
-              <a:t>                                      │     │ │ Main    │  │ Helper     │ │</a:t>
-            </a:r>
-          </a:p>
-          <a:p>
-            <a:pPr>
-              <a:lnSpc>
-                <a:spcPct val="100000"/>
-              </a:lnSpc>
-              <a:spcAft>
-                <a:spcPts val="0"/>
-              </a:spcAft>
-              <a:defRPr sz="800">
-                <a:solidFill>
-                  <a:srgbClr val="DB6D28"/>
-                </a:solidFill>
-                <a:latin typeface="Consolas"/>
-              </a:defRPr>
-            </a:pPr>
-            <a:r>
-              <a:t>                                      │     │ │ Process │◀▶│ Script     │ │</a:t>
-            </a:r>
-          </a:p>
-          <a:p>
-            <a:pPr>
-              <a:lnSpc>
-                <a:spcPct val="100000"/>
-              </a:lnSpc>
-              <a:spcAft>
-                <a:spcPts val="0"/>
-              </a:spcAft>
-              <a:defRPr sz="800">
-                <a:solidFill>
-                  <a:srgbClr val="DB6D28"/>
-                </a:solidFill>
-                <a:latin typeface="Consolas"/>
-              </a:defRPr>
-            </a:pPr>
-            <a:r>
-              <a:t>                                      │     │ └────┬────┘  └──────┬─────┘ │</a:t>
-            </a:r>
-          </a:p>
-          <a:p>
-            <a:pPr>
-              <a:lnSpc>
-                <a:spcPct val="100000"/>
-              </a:lnSpc>
-              <a:spcAft>
-                <a:spcPts val="0"/>
-              </a:spcAft>
-              <a:defRPr sz="800">
-                <a:solidFill>
-                  <a:srgbClr val="8B949E"/>
-                </a:solidFill>
-                <a:latin typeface="Consolas"/>
-              </a:defRPr>
-            </a:pPr>
-            <a:r>
-              <a:t>                                      │     │      │              │       │</a:t>
-            </a:r>
-          </a:p>
-          <a:p>
-            <a:pPr>
-              <a:lnSpc>
-                <a:spcPct val="100000"/>
-              </a:lnSpc>
-              <a:spcAft>
-                <a:spcPts val="0"/>
-              </a:spcAft>
-              <a:defRPr sz="800">
-                <a:solidFill>
-                  <a:srgbClr val="8B949E"/>
-                </a:solidFill>
-                <a:latin typeface="Consolas"/>
-              </a:defRPr>
-            </a:pPr>
-            <a:r>
-              <a:t>                                      │     │      ▼              ▼       │</a:t>
-            </a:r>
-          </a:p>
-          <a:p>
-            <a:pPr>
-              <a:lnSpc>
-                <a:spcPct val="100000"/>
-              </a:lnSpc>
-              <a:spcAft>
-                <a:spcPts val="0"/>
-              </a:spcAft>
-              <a:defRPr sz="800">
-                <a:solidFill>
-                  <a:srgbClr val="DB6D28"/>
-                </a:solidFill>
-                <a:latin typeface="Consolas"/>
-              </a:defRPr>
-            </a:pPr>
-            <a:r>
-              <a:t>                                      │     │ ┌───────────────────────┐  │</a:t>
-            </a:r>
-          </a:p>
-          <a:p>
-            <a:pPr>
-              <a:lnSpc>
-                <a:spcPct val="100000"/>
-              </a:lnSpc>
-              <a:spcAft>
-                <a:spcPts val="0"/>
-              </a:spcAft>
-              <a:defRPr sz="800">
-                <a:solidFill>
-                  <a:srgbClr val="DB6D28"/>
-                </a:solidFill>
-                <a:latin typeface="Consolas"/>
-              </a:defRPr>
-            </a:pPr>
-            <a:r>
-              <a:t>                                      │     │ │ Gaussian Freq Calc    │  │</a:t>
-            </a:r>
-          </a:p>
-          <a:p>
-            <a:pPr>
-              <a:lnSpc>
-                <a:spcPct val="100000"/>
-              </a:lnSpc>
-              <a:spcAft>
-                <a:spcPts val="0"/>
-              </a:spcAft>
-              <a:defRPr sz="800">
-                <a:solidFill>
-                  <a:srgbClr val="DB6D28"/>
-                </a:solidFill>
-                <a:latin typeface="Consolas"/>
-              </a:defRPr>
-            </a:pPr>
-            <a:r>
-              <a:t>                                      │     │ └───────────────────────┘  │</a:t>
-            </a:r>
-          </a:p>
-          <a:p>
-            <a:pPr>
-              <a:lnSpc>
-                <a:spcPct val="100000"/>
-              </a:lnSpc>
-              <a:spcAft>
-                <a:spcPts val="0"/>
-              </a:spcAft>
-              <a:defRPr sz="800">
-                <a:solidFill>
-                  <a:srgbClr val="DB6D28"/>
-                </a:solidFill>
-                <a:latin typeface="Consolas"/>
-              </a:defRPr>
-            </a:pPr>
-            <a:r>
-              <a:t>                                      │     └──────────────┬───────────────┘</a:t>
-            </a:r>
-          </a:p>
-          <a:p>
-            <a:pPr>
-              <a:lnSpc>
-                <a:spcPct val="100000"/>
-              </a:lnSpc>
-              <a:spcAft>
-                <a:spcPts val="0"/>
-              </a:spcAft>
-              <a:defRPr sz="800">
-                <a:solidFill>
-                  <a:srgbClr val="8B949E"/>
-                </a:solidFill>
-                <a:latin typeface="Consolas"/>
-              </a:defRPr>
-            </a:pPr>
-            <a:r>
-              <a:t>                                      │                    │</a:t>
-            </a:r>
-          </a:p>
-          <a:p>
-            <a:pPr>
-              <a:lnSpc>
-                <a:spcPct val="100000"/>
-              </a:lnSpc>
-              <a:spcAft>
-                <a:spcPts val="0"/>
-              </a:spcAft>
-              <a:defRPr sz="800">
-                <a:solidFill>
-                  <a:srgbClr val="DB6D28"/>
-                </a:solidFill>
-                <a:latin typeface="Consolas"/>
-              </a:defRPr>
-            </a:pPr>
-            <a:r>
-              <a:t>                                      │     ┌──────────────▼────────────┐</a:t>
-            </a:r>
-          </a:p>
-          <a:p>
-            <a:pPr>
-              <a:lnSpc>
-                <a:spcPct val="100000"/>
-              </a:lnSpc>
-              <a:spcAft>
-                <a:spcPts val="0"/>
-              </a:spcAft>
-              <a:defRPr sz="800">
-                <a:solidFill>
-                  <a:srgbClr val="DB6D28"/>
-                </a:solidFill>
-                <a:latin typeface="Consolas"/>
-              </a:defRPr>
-            </a:pPr>
-            <a:r>
-              <a:t>                                      │     │ parse_ml_results()        │</a:t>
-            </a:r>
-          </a:p>
-          <a:p>
-            <a:pPr>
-              <a:lnSpc>
-                <a:spcPct val="100000"/>
-              </a:lnSpc>
-              <a:spcAft>
-                <a:spcPts val="0"/>
-              </a:spcAft>
-              <a:defRPr sz="800">
-                <a:solidFill>
-                  <a:srgbClr val="DB6D28"/>
-                </a:solidFill>
-                <a:latin typeface="Consolas"/>
-              </a:defRPr>
-            </a:pPr>
-            <a:r>
-              <a:t>                                      │     └──────────────┬────────────┘</a:t>
-            </a:r>
-          </a:p>
-          <a:p>
-            <a:pPr>
-              <a:lnSpc>
-                <a:spcPct val="100000"/>
-              </a:lnSpc>
-              <a:spcAft>
-                <a:spcPts val="0"/>
-              </a:spcAft>
-              <a:defRPr sz="800">
-                <a:solidFill>
-                  <a:srgbClr val="8B949E"/>
-                </a:solidFill>
-                <a:latin typeface="Consolas"/>
-              </a:defRPr>
-            </a:pPr>
-            <a:r>
-              <a:t>                                      │                    │</a:t>
-            </a:r>
-          </a:p>
-          <a:p>
-            <a:pPr>
-              <a:lnSpc>
-                <a:spcPct val="100000"/>
-              </a:lnSpc>
-              <a:spcAft>
-                <a:spcPts val="0"/>
-              </a:spcAft>
-              <a:defRPr sz="800">
-                <a:solidFill>
-                  <a:srgbClr val="8B949E"/>
-                </a:solidFill>
-                <a:latin typeface="Consolas"/>
-              </a:defRPr>
-            </a:pPr>
-            <a:r>
-              <a:t>                                      └────────────────────┘</a:t>
-            </a:r>
-          </a:p>
-          <a:p>
-            <a:pPr>
-              <a:lnSpc>
-                <a:spcPct val="100000"/>
-              </a:lnSpc>
-              <a:spcAft>
-                <a:spcPts val="0"/>
-              </a:spcAft>
-              <a:defRPr sz="800">
-                <a:solidFill>
-                  <a:srgbClr val="8B949E"/>
-                </a:solidFill>
-                <a:latin typeface="Consolas"/>
-              </a:defRPr>
-            </a:pPr>
-            <a:r>
-              <a:t>                                      │</a:t>
+              <a:t>│ ───────────────────────────────────────────────────────────────────────────────────────────────────────  │</a:t>
             </a:r>
           </a:p>
           <a:p>
@@ -10795,7 +10605,7 @@
               </a:defRPr>
             </a:pPr>
             <a:r>
-              <a:t>┌─────────────────────────────────────▼──────────────────────────────────────┐</a:t>
+              <a:t>│  ┌──────────────────┐  ┌───────────────────┐  ┌─────────────────┐  ┌───────────────────────────────┐  │</a:t>
             </a:r>
           </a:p>
           <a:p>
@@ -10814,7 +10624,7 @@
               </a:defRPr>
             </a:pPr>
             <a:r>
-              <a:t>│ ANALYSIS &amp; COMPARISON                                                       │</a:t>
+              <a:t>│  │ load_all_        │─▶│ find_dft_         │─▶│ eigenvector_    │─▶│ calculate_metrics()           │  │</a:t>
             </a:r>
           </a:p>
           <a:p>
@@ -10833,7 +10643,45 @@
               </a:defRPr>
             </a:pPr>
             <a:r>
-              <a:t>│ ──────────────────────────────────────────────────────────────────────────  │</a:t>
+              <a:t>│  │ results()        │  │ baseline()        │  │ mode_matching() │  │ • MAE (cm⁻¹)                  │  │</a:t>
+            </a:r>
+          </a:p>
+          <a:p>
+            <a:pPr>
+              <a:lnSpc>
+                <a:spcPct val="100000"/>
+              </a:lnSpc>
+              <a:spcAft>
+                <a:spcPts val="0"/>
+              </a:spcAft>
+              <a:defRPr sz="800">
+                <a:solidFill>
+                  <a:srgbClr val="C9D1D9"/>
+                </a:solidFill>
+                <a:latin typeface="Consolas"/>
+              </a:defRPr>
+            </a:pPr>
+            <a:r>
+              <a:t>│  │                  │  │                   │  │                 │  │ • RMSE (cm⁻¹)                 │  │</a:t>
+            </a:r>
+          </a:p>
+          <a:p>
+            <a:pPr>
+              <a:lnSpc>
+                <a:spcPct val="100000"/>
+              </a:lnSpc>
+              <a:spcAft>
+                <a:spcPts val="0"/>
+              </a:spcAft>
+              <a:defRPr sz="800">
+                <a:solidFill>
+                  <a:srgbClr val="C9D1D9"/>
+                </a:solidFill>
+                <a:latin typeface="Consolas"/>
+              </a:defRPr>
+            </a:pPr>
+            <a:r>
+              <a:t>│  │                  │  │                   │  │                 │  │ • R² (coeff. of determination)│  │</a:t>
             </a:r>
           </a:p>
           <a:p>
@@ -10852,7 +10700,26 @@
               </a:defRPr>
             </a:pPr>
             <a:r>
-              <a:t>│  ┌──────────────┐  ┌───────────────┐  ┌──────────┐  ┌──────────────────┐  │</a:t>
+              <a:t>│  └──────────────────┘  └───────────────────┘  └─────────────────┘  └──────────┬────────────────────┘  │</a:t>
+            </a:r>
+          </a:p>
+          <a:p>
+            <a:pPr>
+              <a:lnSpc>
+                <a:spcPct val="100000"/>
+              </a:lnSpc>
+              <a:spcAft>
+                <a:spcPts val="0"/>
+              </a:spcAft>
+              <a:defRPr sz="800">
+                <a:solidFill>
+                  <a:srgbClr val="8B949E"/>
+                </a:solidFill>
+                <a:latin typeface="Consolas"/>
+              </a:defRPr>
+            </a:pPr>
+            <a:r>
+              <a:t>│                                                                                 │                       │</a:t>
             </a:r>
           </a:p>
           <a:p>
@@ -10871,7 +10738,26 @@
               </a:defRPr>
             </a:pPr>
             <a:r>
-              <a:t>│  │ load_all()   │─▶│ find_dft_     │─▶│ mode_    │─▶│ calc_metrics()   │  │</a:t>
+              <a:t>│  ┌──────────────────┐  ┌───────────────────┐  ┌─────────────────────────────▼─────────────────────┐  │</a:t>
+            </a:r>
+          </a:p>
+          <a:p>
+            <a:pPr>
+              <a:lnSpc>
+                <a:spcPct val="100000"/>
+              </a:lnSpc>
+              <a:spcAft>
+                <a:spcPts val="0"/>
+              </a:spcAft>
+              <a:defRPr sz="800">
+                <a:solidFill>
+                  <a:srgbClr val="58A6FF"/>
+                </a:solidFill>
+                <a:latin typeface="Consolas"/>
+              </a:defRPr>
+            </a:pPr>
+            <a:r>
+              <a:t>│  │ plot_regression()│  │ kde_broadening()  │  │ generate_html_report()                            │  │</a:t>
             </a:r>
           </a:p>
           <a:p>
@@ -10890,7 +10776,7 @@
               </a:defRPr>
             </a:pPr>
             <a:r>
-              <a:t>│  │              │  │ baseline()    │  │ matching │  │ (MAE/RMSE/R²)    │  │</a:t>
+              <a:t>│  │ (ML vs DFT)      │  │ (FWHM=8.0 cm⁻¹)   │  │ (interactive plots, publication-ready)            │  │</a:t>
             </a:r>
           </a:p>
           <a:p>
@@ -10909,26 +10795,7 @@
               </a:defRPr>
             </a:pPr>
             <a:r>
-              <a:t>│  └──────────────┘  └───────────────┘  └──────────┘  └─────┬────────────┘  │</a:t>
-            </a:r>
-          </a:p>
-          <a:p>
-            <a:pPr>
-              <a:lnSpc>
-                <a:spcPct val="100000"/>
-              </a:lnSpc>
-              <a:spcAft>
-                <a:spcPts val="0"/>
-              </a:spcAft>
-              <a:defRPr sz="800">
-                <a:solidFill>
-                  <a:srgbClr val="8B949E"/>
-                </a:solidFill>
-                <a:latin typeface="Consolas"/>
-              </a:defRPr>
-            </a:pPr>
-            <a:r>
-              <a:t>│                                                            │               │</a:t>
+              <a:t>│  └──────────────────┘  └───────────────────┘  └───────────────────────────────────────────────────┘  │</a:t>
             </a:r>
           </a:p>
           <a:p>
@@ -10947,102 +10814,26 @@
               </a:defRPr>
             </a:pPr>
             <a:r>
-              <a:t>│  ┌──────────────┐  ┌───────────────┐  ┌────────────────────▼───────────┐  │</a:t>
-            </a:r>
-          </a:p>
-          <a:p>
-            <a:pPr>
-              <a:lnSpc>
-                <a:spcPct val="100000"/>
-              </a:lnSpc>
-              <a:spcAft>
-                <a:spcPts val="0"/>
-              </a:spcAft>
-              <a:defRPr sz="800">
-                <a:solidFill>
-                  <a:srgbClr val="58A6FF"/>
-                </a:solidFill>
-                <a:latin typeface="Consolas"/>
-              </a:defRPr>
-            </a:pPr>
-            <a:r>
-              <a:t>│  │ plot_        │  │ kde_          │  │ generate_html_report()         │  │</a:t>
-            </a:r>
-          </a:p>
-          <a:p>
-            <a:pPr>
-              <a:lnSpc>
-                <a:spcPct val="100000"/>
-              </a:lnSpc>
-              <a:spcAft>
-                <a:spcPts val="0"/>
-              </a:spcAft>
-              <a:defRPr sz="800">
-                <a:solidFill>
-                  <a:srgbClr val="C9D1D9"/>
-                </a:solidFill>
-                <a:latin typeface="Consolas"/>
-              </a:defRPr>
-            </a:pPr>
-            <a:r>
-              <a:t>│  │ regression() │  │ broadening()  │  │ (interactive, publication)     │  │</a:t>
-            </a:r>
-          </a:p>
-          <a:p>
-            <a:pPr>
-              <a:lnSpc>
-                <a:spcPct val="100000"/>
-              </a:lnSpc>
-              <a:spcAft>
-                <a:spcPts val="0"/>
-              </a:spcAft>
-              <a:defRPr sz="800">
-                <a:solidFill>
-                  <a:srgbClr val="58A6FF"/>
-                </a:solidFill>
-                <a:latin typeface="Consolas"/>
-              </a:defRPr>
-            </a:pPr>
-            <a:r>
-              <a:t>│  └──────────────┘  └───────────────┘  └────────────────────────────────┘  │</a:t>
-            </a:r>
-          </a:p>
-          <a:p>
-            <a:pPr>
-              <a:lnSpc>
-                <a:spcPct val="100000"/>
-              </a:lnSpc>
-              <a:spcAft>
-                <a:spcPts val="0"/>
-              </a:spcAft>
-              <a:defRPr sz="800">
-                <a:solidFill>
-                  <a:srgbClr val="58A6FF"/>
-                </a:solidFill>
-                <a:latin typeface="Consolas"/>
-              </a:defRPr>
-            </a:pPr>
-            <a:r>
-              <a:t>└─────────────────────────────────────────────┬───────────────────────────────┘</a:t>
-            </a:r>
-          </a:p>
-          <a:p>
-            <a:pPr>
-              <a:lnSpc>
-                <a:spcPct val="100000"/>
-              </a:lnSpc>
-              <a:spcAft>
-                <a:spcPts val="0"/>
-              </a:spcAft>
-              <a:defRPr sz="800">
-                <a:solidFill>
-                  <a:srgbClr val="8B949E"/>
-                </a:solidFill>
-                <a:latin typeface="Consolas"/>
-              </a:defRPr>
-            </a:pPr>
-            <a:r>
-              <a:t>                                              │</a:t>
+              <a:t>└────────────────────────────────────────────────────┬─────────────────────────────────────────────────┘</a:t>
+            </a:r>
+          </a:p>
+          <a:p>
+            <a:pPr>
+              <a:lnSpc>
+                <a:spcPct val="100000"/>
+              </a:lnSpc>
+              <a:spcAft>
+                <a:spcPts val="0"/>
+              </a:spcAft>
+              <a:defRPr sz="800">
+                <a:solidFill>
+                  <a:srgbClr val="8B949E"/>
+                </a:solidFill>
+                <a:latin typeface="Consolas"/>
+              </a:defRPr>
+            </a:pPr>
+            <a:r>
+              <a:t>                                                     │</a:t>
             </a:r>
           </a:p>
           <a:p>
@@ -11061,7 +10852,7 @@
               </a:defRPr>
             </a:pPr>
             <a:r>
-              <a:t>                                   [{molecule}_spectral_analysis.html]</a:t>
+              <a:t>                                          [{molecule}_spectral_analysis.html]</a:t>
             </a:r>
           </a:p>
         </p:txBody>

</xml_diff>

<commit_message>
Add final simplified workflow diagram with reordered analysis steps
- Geometry optimizer on top feeding into both DFT and ML paths
- All analysis steps in single horizontal row
- Correct order: load → find baseline → eigenvector matching →
  kde_broadening → calculate_metrics → plot_regression
- generate_html_report() positioned below analysis block
- Full width layout (9.8") for maximum clarity
</commit_message>
<xml_diff>
--- a/presentation/test_detailed_workflow.pptx
+++ b/presentation/test_detailed_workflow.pptx
@@ -13,6 +13,7 @@
     <p:sldId id="261" r:id="rId12"/>
     <p:sldId id="262" r:id="rId13"/>
     <p:sldId id="263" r:id="rId14"/>
+    <p:sldId id="264" r:id="rId15"/>
   </p:sldIdLst>
   <p:sldSz cx="9144000" cy="6858000" type="screen4x3"/>
   <p:notesSz cx="6858000" cy="9144000"/>
@@ -10853,6 +10854,851 @@
             </a:pPr>
             <a:r>
               <a:t>                                          [{molecule}_spectral_analysis.html]</a:t>
+            </a:r>
+          </a:p>
+        </p:txBody>
+      </p:sp>
+    </p:spTree>
+  </p:cSld>
+  <p:clrMapOvr>
+    <a:masterClrMapping/>
+  </p:clrMapOvr>
+</p:sld>
+</file>
+
+<file path=ppt/slides/slide9.xml><?xml version="1.0" encoding="utf-8"?>
+<p:sld xmlns:a="http://schemas.openxmlformats.org/drawingml/2006/main" xmlns:p="http://schemas.openxmlformats.org/presentationml/2006/main" xmlns:r="http://schemas.openxmlformats.org/officeDocument/2006/relationships">
+  <p:cSld>
+    <p:bg>
+      <p:bgPr>
+        <a:solidFill>
+          <a:srgbClr val="0D1117"/>
+        </a:solidFill>
+        <a:effectLst/>
+      </p:bgPr>
+    </p:bg>
+    <p:spTree>
+      <p:nvGrpSpPr>
+        <p:cNvPr id="1" name=""/>
+        <p:cNvGrpSpPr/>
+        <p:nvPr/>
+      </p:nvGrpSpPr>
+      <p:grpSpPr/>
+      <p:sp>
+        <p:nvSpPr>
+          <p:cNvPr id="2" name="TextBox 1"/>
+          <p:cNvSpPr txBox="1"/>
+          <p:nvPr/>
+        </p:nvSpPr>
+        <p:spPr>
+          <a:xfrm>
+            <a:off x="365760" y="274320"/>
+            <a:ext cx="8412480" cy="457200"/>
+          </a:xfrm>
+          <a:prstGeom prst="rect">
+            <a:avLst/>
+          </a:prstGeom>
+          <a:noFill/>
+        </p:spPr>
+        <p:txBody>
+          <a:bodyPr wrap="none">
+            <a:spAutoFit/>
+          </a:bodyPr>
+          <a:lstStyle/>
+          <a:p>
+            <a:pPr>
+              <a:defRPr sz="2200" b="1">
+                <a:solidFill>
+                  <a:srgbClr val="58A6FF"/>
+                </a:solidFill>
+                <a:latin typeface="Consolas"/>
+              </a:defRPr>
+            </a:pPr>
+            <a:r>
+              <a:t>$ cat workflow_final.txt</a:t>
+            </a:r>
+          </a:p>
+        </p:txBody>
+      </p:sp>
+      <p:sp>
+        <p:nvSpPr>
+          <p:cNvPr id="3" name="TextBox 2"/>
+          <p:cNvSpPr txBox="1"/>
+          <p:nvPr/>
+        </p:nvSpPr>
+        <p:spPr>
+          <a:xfrm>
+            <a:off x="91440" y="822960"/>
+            <a:ext cx="8961120" cy="5852160"/>
+          </a:xfrm>
+          <a:prstGeom prst="rect">
+            <a:avLst/>
+          </a:prstGeom>
+          <a:noFill/>
+        </p:spPr>
+        <p:txBody>
+          <a:bodyPr wrap="none">
+            <a:spAutoFit/>
+          </a:bodyPr>
+          <a:lstStyle/>
+          <a:p>
+            <a:pPr>
+              <a:lnSpc>
+                <a:spcPct val="100000"/>
+              </a:lnSpc>
+              <a:spcAft>
+                <a:spcPts val="0"/>
+              </a:spcAft>
+              <a:defRPr sz="800">
+                <a:solidFill>
+                  <a:srgbClr val="57AB5A"/>
+                </a:solidFill>
+                <a:latin typeface="Consolas"/>
+              </a:defRPr>
+            </a:pPr>
+            <a:r>
+              <a:t>                                    [molecule.xyz]</a:t>
+            </a:r>
+          </a:p>
+          <a:p>
+            <a:pPr>
+              <a:lnSpc>
+                <a:spcPct val="100000"/>
+              </a:lnSpc>
+              <a:spcAft>
+                <a:spcPts val="0"/>
+              </a:spcAft>
+              <a:defRPr sz="800">
+                <a:solidFill>
+                  <a:srgbClr val="8B949E"/>
+                </a:solidFill>
+                <a:latin typeface="Consolas"/>
+              </a:defRPr>
+            </a:pPr>
+            <a:r>
+              <a:t>                                          │</a:t>
+            </a:r>
+          </a:p>
+          <a:p>
+            <a:pPr>
+              <a:lnSpc>
+                <a:spcPct val="100000"/>
+              </a:lnSpc>
+              <a:spcAft>
+                <a:spcPts val="0"/>
+              </a:spcAft>
+              <a:defRPr sz="800">
+                <a:solidFill>
+                  <a:srgbClr val="58A6FF"/>
+                </a:solidFill>
+                <a:latin typeface="Consolas"/>
+              </a:defRPr>
+            </a:pPr>
+            <a:r>
+              <a:t>        ┌─────────────────────────────────▼─────────────────────────────────────┐</a:t>
+            </a:r>
+          </a:p>
+          <a:p>
+            <a:pPr>
+              <a:lnSpc>
+                <a:spcPct val="100000"/>
+              </a:lnSpc>
+              <a:spcAft>
+                <a:spcPts val="0"/>
+              </a:spcAft>
+              <a:defRPr sz="800">
+                <a:solidFill>
+                  <a:srgbClr val="58A6FF"/>
+                </a:solidFill>
+                <a:latin typeface="Consolas"/>
+              </a:defRPr>
+            </a:pPr>
+            <a:r>
+              <a:t>        │ GEOMETRY OPTIMIZER                                                     │</a:t>
+            </a:r>
+          </a:p>
+          <a:p>
+            <a:pPr>
+              <a:lnSpc>
+                <a:spcPct val="100000"/>
+              </a:lnSpc>
+              <a:spcAft>
+                <a:spcPts val="0"/>
+              </a:spcAft>
+              <a:defRPr sz="800">
+                <a:solidFill>
+                  <a:srgbClr val="C9D1D9"/>
+                </a:solidFill>
+                <a:latin typeface="Consolas"/>
+              </a:defRPr>
+            </a:pPr>
+            <a:r>
+              <a:t>        │ ────────────────────────────────────────────────────────────────────   │</a:t>
+            </a:r>
+          </a:p>
+          <a:p>
+            <a:pPr>
+              <a:lnSpc>
+                <a:spcPct val="100000"/>
+              </a:lnSpc>
+              <a:spcAft>
+                <a:spcPts val="0"/>
+              </a:spcAft>
+              <a:defRPr sz="800">
+                <a:solidFill>
+                  <a:srgbClr val="C9D1D9"/>
+                </a:solidFill>
+                <a:latin typeface="Consolas"/>
+              </a:defRPr>
+            </a:pPr>
+            <a:r>
+              <a:t>        │ • load_geometry()  • mace_omol.optimize()  • save_optimized()          │</a:t>
+            </a:r>
+          </a:p>
+          <a:p>
+            <a:pPr>
+              <a:lnSpc>
+                <a:spcPct val="100000"/>
+              </a:lnSpc>
+              <a:spcAft>
+                <a:spcPts val="0"/>
+              </a:spcAft>
+              <a:defRPr sz="800">
+                <a:solidFill>
+                  <a:srgbClr val="58A6FF"/>
+                </a:solidFill>
+                <a:latin typeface="Consolas"/>
+              </a:defRPr>
+            </a:pPr>
+            <a:r>
+              <a:t>        └─────────────────────────┬──────────────────────────────────────────────┘</a:t>
+            </a:r>
+          </a:p>
+          <a:p>
+            <a:pPr>
+              <a:lnSpc>
+                <a:spcPct val="100000"/>
+              </a:lnSpc>
+              <a:spcAft>
+                <a:spcPts val="0"/>
+              </a:spcAft>
+              <a:defRPr sz="800">
+                <a:solidFill>
+                  <a:srgbClr val="8B949E"/>
+                </a:solidFill>
+                <a:latin typeface="Consolas"/>
+              </a:defRPr>
+            </a:pPr>
+            <a:r>
+              <a:t>                                  │</a:t>
+            </a:r>
+          </a:p>
+          <a:p>
+            <a:pPr>
+              <a:lnSpc>
+                <a:spcPct val="100000"/>
+              </a:lnSpc>
+              <a:spcAft>
+                <a:spcPts val="0"/>
+              </a:spcAft>
+              <a:defRPr sz="800">
+                <a:solidFill>
+                  <a:srgbClr val="8B949E"/>
+                </a:solidFill>
+                <a:latin typeface="Consolas"/>
+              </a:defRPr>
+            </a:pPr>
+            <a:r>
+              <a:t>                ┌─────────────────┴─────────────────┐</a:t>
+            </a:r>
+          </a:p>
+          <a:p>
+            <a:pPr>
+              <a:lnSpc>
+                <a:spcPct val="100000"/>
+              </a:lnSpc>
+              <a:spcAft>
+                <a:spcPts val="0"/>
+              </a:spcAft>
+              <a:defRPr sz="800">
+                <a:solidFill>
+                  <a:srgbClr val="8B949E"/>
+                </a:solidFill>
+                <a:latin typeface="Consolas"/>
+              </a:defRPr>
+            </a:pPr>
+            <a:r>
+              <a:t>                │                                   │</a:t>
+            </a:r>
+          </a:p>
+          <a:p>
+            <a:pPr>
+              <a:lnSpc>
+                <a:spcPct val="100000"/>
+              </a:lnSpc>
+              <a:spcAft>
+                <a:spcPts val="0"/>
+              </a:spcAft>
+              <a:defRPr sz="800">
+                <a:solidFill>
+                  <a:srgbClr val="58A6FF"/>
+                </a:solidFill>
+                <a:latin typeface="Consolas"/>
+              </a:defRPr>
+            </a:pPr>
+            <a:r>
+              <a:t>┌───────────────▼─────────────┐     ┌───────────────▼──────────────────────────┐</a:t>
+            </a:r>
+          </a:p>
+          <a:p>
+            <a:pPr>
+              <a:lnSpc>
+                <a:spcPct val="100000"/>
+              </a:lnSpc>
+              <a:spcAft>
+                <a:spcPts val="0"/>
+              </a:spcAft>
+              <a:defRPr sz="800">
+                <a:solidFill>
+                  <a:srgbClr val="58A6FF"/>
+                </a:solidFill>
+                <a:latin typeface="Consolas"/>
+              </a:defRPr>
+            </a:pPr>
+            <a:r>
+              <a:t>│ DFT BASELINE                │     │ ML FREQ CALC                             │</a:t>
+            </a:r>
+          </a:p>
+          <a:p>
+            <a:pPr>
+              <a:lnSpc>
+                <a:spcPct val="100000"/>
+              </a:lnSpc>
+              <a:spcAft>
+                <a:spcPts val="0"/>
+              </a:spcAft>
+              <a:defRPr sz="800">
+                <a:solidFill>
+                  <a:srgbClr val="C9D1D9"/>
+                </a:solidFill>
+                <a:latin typeface="Consolas"/>
+              </a:defRPr>
+            </a:pPr>
+            <a:r>
+              <a:t>│ ──────────────────────────  │     │ ────────────────────────────────────────  │</a:t>
+            </a:r>
+          </a:p>
+          <a:p>
+            <a:pPr>
+              <a:lnSpc>
+                <a:spcPct val="100000"/>
+              </a:lnSpc>
+              <a:spcAft>
+                <a:spcPts val="0"/>
+              </a:spcAft>
+              <a:defRPr sz="800">
+                <a:solidFill>
+                  <a:srgbClr val="C9D1D9"/>
+                </a:solidFill>
+                <a:latin typeface="Consolas"/>
+              </a:defRPr>
+            </a:pPr>
+            <a:r>
+              <a:t>│    ╭─────────────────╮      │     │ • load_mace_calculator()                 │</a:t>
+            </a:r>
+          </a:p>
+          <a:p>
+            <a:pPr>
+              <a:lnSpc>
+                <a:spcPct val="100000"/>
+              </a:lnSpc>
+              <a:spcAft>
+                <a:spcPts val="0"/>
+              </a:spcAft>
+              <a:defRPr sz="800">
+                <a:solidFill>
+                  <a:srgbClr val="C9D1D9"/>
+                </a:solidFill>
+                <a:latin typeface="Consolas"/>
+              </a:defRPr>
+            </a:pPr>
+            <a:r>
+              <a:t>│    │ Built-in opt    │      │     │   (MACE-MP/MACE-OMOL)                    │</a:t>
+            </a:r>
+          </a:p>
+          <a:p>
+            <a:pPr>
+              <a:lnSpc>
+                <a:spcPct val="100000"/>
+              </a:lnSpc>
+              <a:spcAft>
+                <a:spcPts val="0"/>
+              </a:spcAft>
+              <a:defRPr sz="800">
+                <a:solidFill>
+                  <a:srgbClr val="C9D1D9"/>
+                </a:solidFill>
+                <a:latin typeface="Consolas"/>
+              </a:defRPr>
+            </a:pPr>
+            <a:r>
+              <a:t>│    │ B3LYP/6-31G(d,p)│      │     │ • get_dipole_calculator()                │</a:t>
+            </a:r>
+          </a:p>
+          <a:p>
+            <a:pPr>
+              <a:lnSpc>
+                <a:spcPct val="100000"/>
+              </a:lnSpc>
+              <a:spcAft>
+                <a:spcPts val="0"/>
+              </a:spcAft>
+              <a:defRPr sz="800">
+                <a:solidFill>
+                  <a:srgbClr val="C9D1D9"/>
+                </a:solidFill>
+                <a:latin typeface="Consolas"/>
+              </a:defRPr>
+            </a:pPr>
+            <a:r>
+              <a:t>│    ╰────────┬────────╯      │     │   (Espaloma/MACE-ML/xTB)                 │</a:t>
+            </a:r>
+          </a:p>
+          <a:p>
+            <a:pPr>
+              <a:lnSpc>
+                <a:spcPct val="100000"/>
+              </a:lnSpc>
+              <a:spcAft>
+                <a:spcPts val="0"/>
+              </a:spcAft>
+              <a:defRPr sz="800">
+                <a:solidFill>
+                  <a:srgbClr val="C9D1D9"/>
+                </a:solidFill>
+                <a:latin typeface="Consolas"/>
+              </a:defRPr>
+            </a:pPr>
+            <a:r>
+              <a:t>│             ▼               │     │ • setup_zmq_server()                     │</a:t>
+            </a:r>
+          </a:p>
+          <a:p>
+            <a:pPr>
+              <a:lnSpc>
+                <a:spcPct val="100000"/>
+              </a:lnSpc>
+              <a:spcAft>
+                <a:spcPts val="0"/>
+              </a:spcAft>
+              <a:defRPr sz="800">
+                <a:solidFill>
+                  <a:srgbClr val="C9D1D9"/>
+                </a:solidFill>
+                <a:latin typeface="Consolas"/>
+              </a:defRPr>
+            </a:pPr>
+            <a:r>
+              <a:t>│ • gaussian_freq()           │     │ • launch_gaussian()                      │</a:t>
+            </a:r>
+          </a:p>
+          <a:p>
+            <a:pPr>
+              <a:lnSpc>
+                <a:spcPct val="100000"/>
+              </a:lnSpc>
+              <a:spcAft>
+                <a:spcPts val="0"/>
+              </a:spcAft>
+              <a:defRPr sz="800">
+                <a:solidFill>
+                  <a:srgbClr val="C9D1D9"/>
+                </a:solidFill>
+                <a:latin typeface="Consolas"/>
+              </a:defRPr>
+            </a:pPr>
+            <a:r>
+              <a:t>│ • parse_gaussian()          │     │ • zmq_dipole_loop()                      │</a:t>
+            </a:r>
+          </a:p>
+          <a:p>
+            <a:pPr>
+              <a:lnSpc>
+                <a:spcPct val="100000"/>
+              </a:lnSpc>
+              <a:spcAft>
+                <a:spcPts val="0"/>
+              </a:spcAft>
+              <a:defRPr sz="800">
+                <a:solidFill>
+                  <a:srgbClr val="C9D1D9"/>
+                </a:solidFill>
+                <a:latin typeface="Consolas"/>
+              </a:defRPr>
+            </a:pPr>
+            <a:r>
+              <a:t>│ • extract_frequencies()     │     │   (via ZMQ bridge - see slide)           │</a:t>
+            </a:r>
+          </a:p>
+          <a:p>
+            <a:pPr>
+              <a:lnSpc>
+                <a:spcPct val="100000"/>
+              </a:lnSpc>
+              <a:spcAft>
+                <a:spcPts val="0"/>
+              </a:spcAft>
+              <a:defRPr sz="800">
+                <a:solidFill>
+                  <a:srgbClr val="58A6FF"/>
+                </a:solidFill>
+                <a:latin typeface="Consolas"/>
+              </a:defRPr>
+            </a:pPr>
+            <a:r>
+              <a:t>└───────────────┬─────────────┘     └──────────────┬───────────────────────────┘</a:t>
+            </a:r>
+          </a:p>
+          <a:p>
+            <a:pPr>
+              <a:lnSpc>
+                <a:spcPct val="100000"/>
+              </a:lnSpc>
+              <a:spcAft>
+                <a:spcPts val="0"/>
+              </a:spcAft>
+              <a:defRPr sz="800">
+                <a:solidFill>
+                  <a:srgbClr val="8B949E"/>
+                </a:solidFill>
+                <a:latin typeface="Consolas"/>
+              </a:defRPr>
+            </a:pPr>
+            <a:r>
+              <a:t>                │                                  │</a:t>
+            </a:r>
+          </a:p>
+          <a:p>
+            <a:pPr>
+              <a:lnSpc>
+                <a:spcPct val="100000"/>
+              </a:lnSpc>
+              <a:spcAft>
+                <a:spcPts val="0"/>
+              </a:spcAft>
+              <a:defRPr sz="800">
+                <a:solidFill>
+                  <a:srgbClr val="8B949E"/>
+                </a:solidFill>
+                <a:latin typeface="Consolas"/>
+              </a:defRPr>
+            </a:pPr>
+            <a:r>
+              <a:t>                └──────────────┬───────────────────┘</a:t>
+            </a:r>
+          </a:p>
+          <a:p>
+            <a:pPr>
+              <a:lnSpc>
+                <a:spcPct val="100000"/>
+              </a:lnSpc>
+              <a:spcAft>
+                <a:spcPts val="0"/>
+              </a:spcAft>
+              <a:defRPr sz="800">
+                <a:solidFill>
+                  <a:srgbClr val="8B949E"/>
+                </a:solidFill>
+                <a:latin typeface="Consolas"/>
+              </a:defRPr>
+            </a:pPr>
+            <a:r>
+              <a:t>                               │</a:t>
+            </a:r>
+          </a:p>
+          <a:p>
+            <a:pPr>
+              <a:lnSpc>
+                <a:spcPct val="100000"/>
+              </a:lnSpc>
+              <a:spcAft>
+                <a:spcPts val="0"/>
+              </a:spcAft>
+              <a:defRPr sz="800">
+                <a:solidFill>
+                  <a:srgbClr val="58A6FF"/>
+                </a:solidFill>
+                <a:latin typeface="Consolas"/>
+              </a:defRPr>
+            </a:pPr>
+            <a:r>
+              <a:t>┌──────────────────────────────▼───────────────────────────────────────────────────────────────────────────────────┐</a:t>
+            </a:r>
+          </a:p>
+          <a:p>
+            <a:pPr>
+              <a:lnSpc>
+                <a:spcPct val="100000"/>
+              </a:lnSpc>
+              <a:spcAft>
+                <a:spcPts val="0"/>
+              </a:spcAft>
+              <a:defRPr sz="800">
+                <a:solidFill>
+                  <a:srgbClr val="58A6FF"/>
+                </a:solidFill>
+                <a:latin typeface="Consolas"/>
+              </a:defRPr>
+            </a:pPr>
+            <a:r>
+              <a:t>│ ANALYSIS &amp; COMPARISON                                                                                             │</a:t>
+            </a:r>
+          </a:p>
+          <a:p>
+            <a:pPr>
+              <a:lnSpc>
+                <a:spcPct val="100000"/>
+              </a:lnSpc>
+              <a:spcAft>
+                <a:spcPts val="0"/>
+              </a:spcAft>
+              <a:defRPr sz="800">
+                <a:solidFill>
+                  <a:srgbClr val="C9D1D9"/>
+                </a:solidFill>
+                <a:latin typeface="Consolas"/>
+              </a:defRPr>
+            </a:pPr>
+            <a:r>
+              <a:t>│ ────────────────────────────────────────────────────────────────────────────────────────────────────────────────  │</a:t>
+            </a:r>
+          </a:p>
+          <a:p>
+            <a:pPr>
+              <a:lnSpc>
+                <a:spcPct val="100000"/>
+              </a:lnSpc>
+              <a:spcAft>
+                <a:spcPts val="0"/>
+              </a:spcAft>
+              <a:defRPr sz="800">
+                <a:solidFill>
+                  <a:srgbClr val="58A6FF"/>
+                </a:solidFill>
+                <a:latin typeface="Consolas"/>
+              </a:defRPr>
+            </a:pPr>
+            <a:r>
+              <a:t>│  ┌──────────┐  ┌───────────┐  ┌─────────────┐  ┌───────────┐  ┌────────────────┐  ┌─────────────┐             │</a:t>
+            </a:r>
+          </a:p>
+          <a:p>
+            <a:pPr>
+              <a:lnSpc>
+                <a:spcPct val="100000"/>
+              </a:lnSpc>
+              <a:spcAft>
+                <a:spcPts val="0"/>
+              </a:spcAft>
+              <a:defRPr sz="800">
+                <a:solidFill>
+                  <a:srgbClr val="58A6FF"/>
+                </a:solidFill>
+                <a:latin typeface="Consolas"/>
+              </a:defRPr>
+            </a:pPr>
+            <a:r>
+              <a:t>│  │ load_all │─▶│ find_dft_ │─▶│ eigenvector │─▶│ kde_      │─▶│ calculate_     │─▶│ plot_       │             │</a:t>
+            </a:r>
+          </a:p>
+          <a:p>
+            <a:pPr>
+              <a:lnSpc>
+                <a:spcPct val="100000"/>
+              </a:lnSpc>
+              <a:spcAft>
+                <a:spcPts val="0"/>
+              </a:spcAft>
+              <a:defRPr sz="800">
+                <a:solidFill>
+                  <a:srgbClr val="C9D1D9"/>
+                </a:solidFill>
+                <a:latin typeface="Consolas"/>
+              </a:defRPr>
+            </a:pPr>
+            <a:r>
+              <a:t>│  │ results()│  │ baseline()│  │ matching()  │  │ broaden() │  │ metrics()      │  │ regression()│             │</a:t>
+            </a:r>
+          </a:p>
+          <a:p>
+            <a:pPr>
+              <a:lnSpc>
+                <a:spcPct val="100000"/>
+              </a:lnSpc>
+              <a:spcAft>
+                <a:spcPts val="0"/>
+              </a:spcAft>
+              <a:defRPr sz="800">
+                <a:solidFill>
+                  <a:srgbClr val="58A6FF"/>
+                </a:solidFill>
+                <a:latin typeface="Consolas"/>
+              </a:defRPr>
+            </a:pPr>
+            <a:r>
+              <a:t>│  └──────────┘  └───────────┘  └─────────────┘  └───────────┘  └────────────────┘  └─────────────┘             │</a:t>
+            </a:r>
+          </a:p>
+          <a:p>
+            <a:pPr>
+              <a:lnSpc>
+                <a:spcPct val="100000"/>
+              </a:lnSpc>
+              <a:spcAft>
+                <a:spcPts val="0"/>
+              </a:spcAft>
+              <a:defRPr sz="800">
+                <a:solidFill>
+                  <a:srgbClr val="58A6FF"/>
+                </a:solidFill>
+                <a:latin typeface="Consolas"/>
+              </a:defRPr>
+            </a:pPr>
+            <a:r>
+              <a:t>└───────────────────────────────────────────────────────────────────────────────────────────────────────────────────┘</a:t>
+            </a:r>
+          </a:p>
+          <a:p>
+            <a:pPr>
+              <a:lnSpc>
+                <a:spcPct val="100000"/>
+              </a:lnSpc>
+              <a:spcAft>
+                <a:spcPts val="0"/>
+              </a:spcAft>
+              <a:defRPr sz="800">
+                <a:solidFill>
+                  <a:srgbClr val="8B949E"/>
+                </a:solidFill>
+                <a:latin typeface="Consolas"/>
+              </a:defRPr>
+            </a:pPr>
+            <a:r>
+              <a:t>                                          │</a:t>
+            </a:r>
+          </a:p>
+          <a:p>
+            <a:pPr>
+              <a:lnSpc>
+                <a:spcPct val="100000"/>
+              </a:lnSpc>
+              <a:spcAft>
+                <a:spcPts val="0"/>
+              </a:spcAft>
+              <a:defRPr sz="800">
+                <a:solidFill>
+                  <a:srgbClr val="8B949E"/>
+                </a:solidFill>
+                <a:latin typeface="Consolas"/>
+              </a:defRPr>
+            </a:pPr>
+            <a:r>
+              <a:t>                                          ▼</a:t>
+            </a:r>
+          </a:p>
+          <a:p>
+            <a:pPr>
+              <a:lnSpc>
+                <a:spcPct val="100000"/>
+              </a:lnSpc>
+              <a:spcAft>
+                <a:spcPts val="0"/>
+              </a:spcAft>
+              <a:defRPr sz="800">
+                <a:solidFill>
+                  <a:srgbClr val="58A6FF"/>
+                </a:solidFill>
+                <a:latin typeface="Consolas"/>
+              </a:defRPr>
+            </a:pPr>
+            <a:r>
+              <a:t>                            ┌─────────────────────────────────┐</a:t>
+            </a:r>
+          </a:p>
+          <a:p>
+            <a:pPr>
+              <a:lnSpc>
+                <a:spcPct val="100000"/>
+              </a:lnSpc>
+              <a:spcAft>
+                <a:spcPts val="0"/>
+              </a:spcAft>
+              <a:defRPr sz="800">
+                <a:solidFill>
+                  <a:srgbClr val="58A6FF"/>
+                </a:solidFill>
+                <a:latin typeface="Consolas"/>
+              </a:defRPr>
+            </a:pPr>
+            <a:r>
+              <a:t>                            │ generate_html_report()          │</a:t>
+            </a:r>
+          </a:p>
+          <a:p>
+            <a:pPr>
+              <a:lnSpc>
+                <a:spcPct val="100000"/>
+              </a:lnSpc>
+              <a:spcAft>
+                <a:spcPts val="0"/>
+              </a:spcAft>
+              <a:defRPr sz="800">
+                <a:solidFill>
+                  <a:srgbClr val="C9D1D9"/>
+                </a:solidFill>
+                <a:latin typeface="Consolas"/>
+              </a:defRPr>
+            </a:pPr>
+            <a:r>
+              <a:t>                            │ (interactive plots,             │</a:t>
+            </a:r>
+          </a:p>
+          <a:p>
+            <a:pPr>
+              <a:lnSpc>
+                <a:spcPct val="100000"/>
+              </a:lnSpc>
+              <a:spcAft>
+                <a:spcPts val="0"/>
+              </a:spcAft>
+              <a:defRPr sz="800">
+                <a:solidFill>
+                  <a:srgbClr val="C9D1D9"/>
+                </a:solidFill>
+                <a:latin typeface="Consolas"/>
+              </a:defRPr>
+            </a:pPr>
+            <a:r>
+              <a:t>                            │  publication-ready)             │</a:t>
+            </a:r>
+          </a:p>
+          <a:p>
+            <a:pPr>
+              <a:lnSpc>
+                <a:spcPct val="100000"/>
+              </a:lnSpc>
+              <a:spcAft>
+                <a:spcPts val="0"/>
+              </a:spcAft>
+              <a:defRPr sz="800">
+                <a:solidFill>
+                  <a:srgbClr val="58A6FF"/>
+                </a:solidFill>
+                <a:latin typeface="Consolas"/>
+              </a:defRPr>
+            </a:pPr>
+            <a:r>
+              <a:t>                            └─────────────────────────────────┘</a:t>
             </a:r>
           </a:p>
         </p:txBody>

</xml_diff>

<commit_message>
Center workflow diagram and fix arrow rendering in PowerPoint
- Center entire diagram for better visual balance
- Replace ─▶ arrows with -> to avoid PowerPoint play button conversion
- Keep vertical arrows (│ ▼) for up/down flow
- Add word_wrap=False to prevent text breaking
- Slightly condense last label (plot regr.) for better fit
</commit_message>
<xml_diff>
--- a/presentation/test_detailed_workflow.pptx
+++ b/presentation/test_detailed_workflow.pptx
@@ -10928,8 +10928,8 @@
         </p:nvSpPr>
         <p:spPr>
           <a:xfrm>
-            <a:off x="91440" y="822960"/>
-            <a:ext cx="8961120" cy="5852160"/>
+            <a:off x="457200" y="822960"/>
+            <a:ext cx="8229600" cy="5852160"/>
           </a:xfrm>
           <a:prstGeom prst="rect">
             <a:avLst/>
@@ -10957,26 +10957,26 @@
               </a:defRPr>
             </a:pPr>
             <a:r>
-              <a:t>                                    [molecule.xyz]</a:t>
-            </a:r>
-          </a:p>
-          <a:p>
-            <a:pPr>
-              <a:lnSpc>
-                <a:spcPct val="100000"/>
-              </a:lnSpc>
-              <a:spcAft>
-                <a:spcPts val="0"/>
-              </a:spcAft>
-              <a:defRPr sz="800">
-                <a:solidFill>
-                  <a:srgbClr val="8B949E"/>
-                </a:solidFill>
-                <a:latin typeface="Consolas"/>
-              </a:defRPr>
-            </a:pPr>
-            <a:r>
-              <a:t>                                          │</a:t>
+              <a:t>                                  [molecule.xyz]</a:t>
+            </a:r>
+          </a:p>
+          <a:p>
+            <a:pPr>
+              <a:lnSpc>
+                <a:spcPct val="100000"/>
+              </a:lnSpc>
+              <a:spcAft>
+                <a:spcPts val="0"/>
+              </a:spcAft>
+              <a:defRPr sz="800">
+                <a:solidFill>
+                  <a:srgbClr val="8B949E"/>
+                </a:solidFill>
+                <a:latin typeface="Consolas"/>
+              </a:defRPr>
+            </a:pPr>
+            <a:r>
+              <a:t>                                        │</a:t>
             </a:r>
           </a:p>
           <a:p>
@@ -10995,7 +10995,7 @@
               </a:defRPr>
             </a:pPr>
             <a:r>
-              <a:t>        ┌─────────────────────────────────▼─────────────────────────────────────┐</a:t>
+              <a:t>      ┌─────────────────────────────────▼─────────────────────────────────────┐</a:t>
             </a:r>
           </a:p>
           <a:p>
@@ -11014,7 +11014,7 @@
               </a:defRPr>
             </a:pPr>
             <a:r>
-              <a:t>        │ GEOMETRY OPTIMIZER                                                     │</a:t>
+              <a:t>      │ GEOMETRY OPTIMIZER                                                     │</a:t>
             </a:r>
           </a:p>
           <a:p>
@@ -11033,7 +11033,7 @@
               </a:defRPr>
             </a:pPr>
             <a:r>
-              <a:t>        │ ────────────────────────────────────────────────────────────────────   │</a:t>
+              <a:t>      │ ────────────────────────────────────────────────────────────────────   │</a:t>
             </a:r>
           </a:p>
           <a:p>
@@ -11052,7 +11052,7 @@
               </a:defRPr>
             </a:pPr>
             <a:r>
-              <a:t>        │ • load_geometry()  • mace_omol.optimize()  • save_optimized()          │</a:t>
+              <a:t>      │ • load_geometry()  • mace_omol.optimize()  • save_optimized()          │</a:t>
             </a:r>
           </a:p>
           <a:p>
@@ -11071,64 +11071,64 @@
               </a:defRPr>
             </a:pPr>
             <a:r>
-              <a:t>        └─────────────────────────┬──────────────────────────────────────────────┘</a:t>
-            </a:r>
-          </a:p>
-          <a:p>
-            <a:pPr>
-              <a:lnSpc>
-                <a:spcPct val="100000"/>
-              </a:lnSpc>
-              <a:spcAft>
-                <a:spcPts val="0"/>
-              </a:spcAft>
-              <a:defRPr sz="800">
-                <a:solidFill>
-                  <a:srgbClr val="8B949E"/>
-                </a:solidFill>
-                <a:latin typeface="Consolas"/>
-              </a:defRPr>
-            </a:pPr>
-            <a:r>
-              <a:t>                                  │</a:t>
-            </a:r>
-          </a:p>
-          <a:p>
-            <a:pPr>
-              <a:lnSpc>
-                <a:spcPct val="100000"/>
-              </a:lnSpc>
-              <a:spcAft>
-                <a:spcPts val="0"/>
-              </a:spcAft>
-              <a:defRPr sz="800">
-                <a:solidFill>
-                  <a:srgbClr val="8B949E"/>
-                </a:solidFill>
-                <a:latin typeface="Consolas"/>
-              </a:defRPr>
-            </a:pPr>
-            <a:r>
-              <a:t>                ┌─────────────────┴─────────────────┐</a:t>
-            </a:r>
-          </a:p>
-          <a:p>
-            <a:pPr>
-              <a:lnSpc>
-                <a:spcPct val="100000"/>
-              </a:lnSpc>
-              <a:spcAft>
-                <a:spcPts val="0"/>
-              </a:spcAft>
-              <a:defRPr sz="800">
-                <a:solidFill>
-                  <a:srgbClr val="8B949E"/>
-                </a:solidFill>
-                <a:latin typeface="Consolas"/>
-              </a:defRPr>
-            </a:pPr>
-            <a:r>
-              <a:t>                │                                   │</a:t>
+              <a:t>      └─────────────────────────┬──────────────────────────────────────────────┘</a:t>
+            </a:r>
+          </a:p>
+          <a:p>
+            <a:pPr>
+              <a:lnSpc>
+                <a:spcPct val="100000"/>
+              </a:lnSpc>
+              <a:spcAft>
+                <a:spcPts val="0"/>
+              </a:spcAft>
+              <a:defRPr sz="800">
+                <a:solidFill>
+                  <a:srgbClr val="8B949E"/>
+                </a:solidFill>
+                <a:latin typeface="Consolas"/>
+              </a:defRPr>
+            </a:pPr>
+            <a:r>
+              <a:t>                                │</a:t>
+            </a:r>
+          </a:p>
+          <a:p>
+            <a:pPr>
+              <a:lnSpc>
+                <a:spcPct val="100000"/>
+              </a:lnSpc>
+              <a:spcAft>
+                <a:spcPts val="0"/>
+              </a:spcAft>
+              <a:defRPr sz="800">
+                <a:solidFill>
+                  <a:srgbClr val="8B949E"/>
+                </a:solidFill>
+                <a:latin typeface="Consolas"/>
+              </a:defRPr>
+            </a:pPr>
+            <a:r>
+              <a:t>              ┌─────────────────┴─────────────────┐</a:t>
+            </a:r>
+          </a:p>
+          <a:p>
+            <a:pPr>
+              <a:lnSpc>
+                <a:spcPct val="100000"/>
+              </a:lnSpc>
+              <a:spcAft>
+                <a:spcPts val="0"/>
+              </a:spcAft>
+              <a:defRPr sz="800">
+                <a:solidFill>
+                  <a:srgbClr val="8B949E"/>
+                </a:solidFill>
+                <a:latin typeface="Consolas"/>
+              </a:defRPr>
+            </a:pPr>
+            <a:r>
+              <a:t>              │                                   │</a:t>
             </a:r>
           </a:p>
           <a:p>
@@ -11147,7 +11147,7 @@
               </a:defRPr>
             </a:pPr>
             <a:r>
-              <a:t>┌───────────────▼─────────────┐     ┌───────────────▼──────────────────────────┐</a:t>
+              <a:t>┌─────────────▼───────────┐     ┌─────────────────▼────────────────────────┐</a:t>
             </a:r>
           </a:p>
           <a:p>
@@ -11166,7 +11166,7 @@
               </a:defRPr>
             </a:pPr>
             <a:r>
-              <a:t>│ DFT BASELINE                │     │ ML FREQ CALC                             │</a:t>
+              <a:t>│ DFT BASELINE            │     │ ML FREQ CALC                             │</a:t>
             </a:r>
           </a:p>
           <a:p>
@@ -11185,7 +11185,7 @@
               </a:defRPr>
             </a:pPr>
             <a:r>
-              <a:t>│ ──────────────────────────  │     │ ────────────────────────────────────────  │</a:t>
+              <a:t>│ ──────────────────────  │     │ ──────────────────────────────────────── │</a:t>
             </a:r>
           </a:p>
           <a:p>
@@ -11204,7 +11204,7 @@
               </a:defRPr>
             </a:pPr>
             <a:r>
-              <a:t>│    ╭─────────────────╮      │     │ • load_mace_calculator()                 │</a:t>
+              <a:t>│    ╭─────────────────╮  │     │ • load_mace_calculator()                 │</a:t>
             </a:r>
           </a:p>
           <a:p>
@@ -11223,7 +11223,7 @@
               </a:defRPr>
             </a:pPr>
             <a:r>
-              <a:t>│    │ Built-in opt    │      │     │   (MACE-MP/MACE-OMOL)                    │</a:t>
+              <a:t>│    │ Built-in opt    │  │     │   (MACE-MP/MACE-OMOL)                    │</a:t>
             </a:r>
           </a:p>
           <a:p>
@@ -11242,7 +11242,7 @@
               </a:defRPr>
             </a:pPr>
             <a:r>
-              <a:t>│    │ B3LYP/6-31G(d,p)│      │     │ • get_dipole_calculator()                │</a:t>
+              <a:t>│    │ B3LYP/6-31G(d,p)│  │     │ • get_dipole_calculator()                │</a:t>
             </a:r>
           </a:p>
           <a:p>
@@ -11261,7 +11261,7 @@
               </a:defRPr>
             </a:pPr>
             <a:r>
-              <a:t>│    ╰────────┬────────╯      │     │   (Espaloma/MACE-ML/xTB)                 │</a:t>
+              <a:t>│    ╰────────┬────────╯  │     │   (Espaloma/MACE-ML/xTB)                 │</a:t>
             </a:r>
           </a:p>
           <a:p>
@@ -11280,7 +11280,7 @@
               </a:defRPr>
             </a:pPr>
             <a:r>
-              <a:t>│             ▼               │     │ • setup_zmq_server()                     │</a:t>
+              <a:t>│             ▼           │     │ • setup_zmq_server()                     │</a:t>
             </a:r>
           </a:p>
           <a:p>
@@ -11299,7 +11299,7 @@
               </a:defRPr>
             </a:pPr>
             <a:r>
-              <a:t>│ • gaussian_freq()           │     │ • launch_gaussian()                      │</a:t>
+              <a:t>│ • gaussian_freq()       │     │ • launch_gaussian()                      │</a:t>
             </a:r>
           </a:p>
           <a:p>
@@ -11318,7 +11318,7 @@
               </a:defRPr>
             </a:pPr>
             <a:r>
-              <a:t>│ • parse_gaussian()          │     │ • zmq_dipole_loop()                      │</a:t>
+              <a:t>│ • parse_gaussian()      │     │ • zmq_dipole_loop()                      │</a:t>
             </a:r>
           </a:p>
           <a:p>
@@ -11337,7 +11337,7 @@
               </a:defRPr>
             </a:pPr>
             <a:r>
-              <a:t>│ • extract_frequencies()     │     │   (via ZMQ bridge - see slide)           │</a:t>
+              <a:t>│ • extract_frequencies() │     │   (via ZMQ bridge - see slide)           │</a:t>
             </a:r>
           </a:p>
           <a:p>
@@ -11356,45 +11356,45 @@
               </a:defRPr>
             </a:pPr>
             <a:r>
-              <a:t>└───────────────┬─────────────┘     └──────────────┬───────────────────────────┘</a:t>
-            </a:r>
-          </a:p>
-          <a:p>
-            <a:pPr>
-              <a:lnSpc>
-                <a:spcPct val="100000"/>
-              </a:lnSpc>
-              <a:spcAft>
-                <a:spcPts val="0"/>
-              </a:spcAft>
-              <a:defRPr sz="800">
-                <a:solidFill>
-                  <a:srgbClr val="8B949E"/>
-                </a:solidFill>
-                <a:latin typeface="Consolas"/>
-              </a:defRPr>
-            </a:pPr>
-            <a:r>
-              <a:t>                │                                  │</a:t>
-            </a:r>
-          </a:p>
-          <a:p>
-            <a:pPr>
-              <a:lnSpc>
-                <a:spcPct val="100000"/>
-              </a:lnSpc>
-              <a:spcAft>
-                <a:spcPts val="0"/>
-              </a:spcAft>
-              <a:defRPr sz="800">
-                <a:solidFill>
-                  <a:srgbClr val="8B949E"/>
-                </a:solidFill>
-                <a:latin typeface="Consolas"/>
-              </a:defRPr>
-            </a:pPr>
-            <a:r>
-              <a:t>                └──────────────┬───────────────────┘</a:t>
+              <a:t>└─────────────┬───────────┘     └──────────────┬───────────────────────────┘</a:t>
+            </a:r>
+          </a:p>
+          <a:p>
+            <a:pPr>
+              <a:lnSpc>
+                <a:spcPct val="100000"/>
+              </a:lnSpc>
+              <a:spcAft>
+                <a:spcPts val="0"/>
+              </a:spcAft>
+              <a:defRPr sz="800">
+                <a:solidFill>
+                  <a:srgbClr val="8B949E"/>
+                </a:solidFill>
+                <a:latin typeface="Consolas"/>
+              </a:defRPr>
+            </a:pPr>
+            <a:r>
+              <a:t>              │                                │</a:t>
+            </a:r>
+          </a:p>
+          <a:p>
+            <a:pPr>
+              <a:lnSpc>
+                <a:spcPct val="100000"/>
+              </a:lnSpc>
+              <a:spcAft>
+                <a:spcPts val="0"/>
+              </a:spcAft>
+              <a:defRPr sz="800">
+                <a:solidFill>
+                  <a:srgbClr val="8B949E"/>
+                </a:solidFill>
+                <a:latin typeface="Consolas"/>
+              </a:defRPr>
+            </a:pPr>
+            <a:r>
+              <a:t>              └────────────────┬───────────────┘</a:t>
             </a:r>
           </a:p>
           <a:p>
@@ -11432,7 +11432,7 @@
               </a:defRPr>
             </a:pPr>
             <a:r>
-              <a:t>┌──────────────────────────────▼───────────────────────────────────────────────────────────────────────────────────┐</a:t>
+              <a:t>┌──────────────────────────────▼──────────────────────────────────────────────────────────┐</a:t>
             </a:r>
           </a:p>
           <a:p>
@@ -11451,7 +11451,7 @@
               </a:defRPr>
             </a:pPr>
             <a:r>
-              <a:t>│ ANALYSIS &amp; COMPARISON                                                                                             │</a:t>
+              <a:t>│ ANALYSIS &amp; COMPARISON                                                                    │</a:t>
             </a:r>
           </a:p>
           <a:p>
@@ -11470,7 +11470,7 @@
               </a:defRPr>
             </a:pPr>
             <a:r>
-              <a:t>│ ────────────────────────────────────────────────────────────────────────────────────────────────────────────────  │</a:t>
+              <a:t>│ ──────────────────────────────────────────────────────────────────────────────────────── │</a:t>
             </a:r>
           </a:p>
           <a:p>
@@ -11489,7 +11489,7 @@
               </a:defRPr>
             </a:pPr>
             <a:r>
-              <a:t>│  ┌──────────┐  ┌───────────┐  ┌─────────────┐  ┌───────────┐  ┌────────────────┐  ┌─────────────┐             │</a:t>
+              <a:t>│  ┌──────────┐  ┌───────────┐  ┌─────────────┐  ┌───────────┐  ┌────────────┐  ┌──────┐│</a:t>
             </a:r>
           </a:p>
           <a:p>
@@ -11508,7 +11508,7 @@
               </a:defRPr>
             </a:pPr>
             <a:r>
-              <a:t>│  │ load_all │─▶│ find_dft_ │─▶│ eigenvector │─▶│ kde_      │─▶│ calculate_     │─▶│ plot_       │             │</a:t>
+              <a:t>│  │ load_all │-&gt;│ find_dft_ │-&gt;│ eigenvector │-&gt;│ kde_      │-&gt;│ calculate_ │-&gt;│ plot ││</a:t>
             </a:r>
           </a:p>
           <a:p>
@@ -11527,7 +11527,7 @@
               </a:defRPr>
             </a:pPr>
             <a:r>
-              <a:t>│  │ results()│  │ baseline()│  │ matching()  │  │ broaden() │  │ metrics()      │  │ regression()│             │</a:t>
+              <a:t>│  │ results()│  │ baseline()│  │ matching()  │  │ broaden() │  │ metrics()  │  │ regr.││</a:t>
             </a:r>
           </a:p>
           <a:p>
@@ -11546,7 +11546,7 @@
               </a:defRPr>
             </a:pPr>
             <a:r>
-              <a:t>│  └──────────┘  └───────────┘  └─────────────┘  └───────────┘  └────────────────┘  └─────────────┘             │</a:t>
+              <a:t>│  └──────────┘  └───────────┘  └─────────────┘  └───────────┘  └────────────┘  └──────┘│</a:t>
             </a:r>
           </a:p>
           <a:p>
@@ -11565,45 +11565,45 @@
               </a:defRPr>
             </a:pPr>
             <a:r>
-              <a:t>└───────────────────────────────────────────────────────────────────────────────────────────────────────────────────┘</a:t>
-            </a:r>
-          </a:p>
-          <a:p>
-            <a:pPr>
-              <a:lnSpc>
-                <a:spcPct val="100000"/>
-              </a:lnSpc>
-              <a:spcAft>
-                <a:spcPts val="0"/>
-              </a:spcAft>
-              <a:defRPr sz="800">
-                <a:solidFill>
-                  <a:srgbClr val="8B949E"/>
-                </a:solidFill>
-                <a:latin typeface="Consolas"/>
-              </a:defRPr>
-            </a:pPr>
-            <a:r>
-              <a:t>                                          │</a:t>
-            </a:r>
-          </a:p>
-          <a:p>
-            <a:pPr>
-              <a:lnSpc>
-                <a:spcPct val="100000"/>
-              </a:lnSpc>
-              <a:spcAft>
-                <a:spcPts val="0"/>
-              </a:spcAft>
-              <a:defRPr sz="800">
-                <a:solidFill>
-                  <a:srgbClr val="8B949E"/>
-                </a:solidFill>
-                <a:latin typeface="Consolas"/>
-              </a:defRPr>
-            </a:pPr>
-            <a:r>
-              <a:t>                                          ▼</a:t>
+              <a:t>└──────────────────────────────────────────────────────────────────────────────────────────┘</a:t>
+            </a:r>
+          </a:p>
+          <a:p>
+            <a:pPr>
+              <a:lnSpc>
+                <a:spcPct val="100000"/>
+              </a:lnSpc>
+              <a:spcAft>
+                <a:spcPts val="0"/>
+              </a:spcAft>
+              <a:defRPr sz="800">
+                <a:solidFill>
+                  <a:srgbClr val="8B949E"/>
+                </a:solidFill>
+                <a:latin typeface="Consolas"/>
+              </a:defRPr>
+            </a:pPr>
+            <a:r>
+              <a:t>                                        │</a:t>
+            </a:r>
+          </a:p>
+          <a:p>
+            <a:pPr>
+              <a:lnSpc>
+                <a:spcPct val="100000"/>
+              </a:lnSpc>
+              <a:spcAft>
+                <a:spcPts val="0"/>
+              </a:spcAft>
+              <a:defRPr sz="800">
+                <a:solidFill>
+                  <a:srgbClr val="8B949E"/>
+                </a:solidFill>
+                <a:latin typeface="Consolas"/>
+              </a:defRPr>
+            </a:pPr>
+            <a:r>
+              <a:t>                                        ▼</a:t>
             </a:r>
           </a:p>
           <a:p>
@@ -11622,7 +11622,7 @@
               </a:defRPr>
             </a:pPr>
             <a:r>
-              <a:t>                            ┌─────────────────────────────────┐</a:t>
+              <a:t>                          ┌─────────────────────────────────┐</a:t>
             </a:r>
           </a:p>
           <a:p>
@@ -11641,7 +11641,7 @@
               </a:defRPr>
             </a:pPr>
             <a:r>
-              <a:t>                            │ generate_html_report()          │</a:t>
+              <a:t>                          │ generate_html_report()          │</a:t>
             </a:r>
           </a:p>
           <a:p>
@@ -11660,7 +11660,7 @@
               </a:defRPr>
             </a:pPr>
             <a:r>
-              <a:t>                            │ (interactive plots,             │</a:t>
+              <a:t>                          │ (interactive plots,             │</a:t>
             </a:r>
           </a:p>
           <a:p>
@@ -11679,7 +11679,7 @@
               </a:defRPr>
             </a:pPr>
             <a:r>
-              <a:t>                            │  publication-ready)             │</a:t>
+              <a:t>                          │  publication-ready)             │</a:t>
             </a:r>
           </a:p>
           <a:p>
@@ -11698,7 +11698,7 @@
               </a:defRPr>
             </a:pPr>
             <a:r>
-              <a:t>                            └─────────────────────────────────┘</a:t>
+              <a:t>                          └─────────────────────────────────┘</a:t>
             </a:r>
           </a:p>
         </p:txBody>

</xml_diff>

<commit_message>
Update workflow diagram: add DFT dipoles, remove ZMQ note, expand labels
- Add "• dipoles via DFT" to DFT BASELINE section
- Remove "(via ZMQ bridge - see slide)" from ML FREQ CALC
- Expand "plot_ regr." to full "plot_regression()"
- Remove descriptive text from generate_html_report() parentheses
- Centered layout with -> arrows for horizontal flow
</commit_message>
<xml_diff>
--- a/presentation/test_detailed_workflow.pptx
+++ b/presentation/test_detailed_workflow.pptx
@@ -11337,7 +11337,7 @@
               </a:defRPr>
             </a:pPr>
             <a:r>
-              <a:t>│ • extract_frequencies() │     │   (via ZMQ bridge - see slide)           │</a:t>
+              <a:t>│ • dipoles via DFT       │     │                                          │</a:t>
             </a:r>
           </a:p>
           <a:p>
@@ -11432,7 +11432,7 @@
               </a:defRPr>
             </a:pPr>
             <a:r>
-              <a:t>┌──────────────────────────────▼──────────────────────────────────────────────────────────┐</a:t>
+              <a:t>┌──────────────────────────────▼───────────────────────────────────────────────────────────┐</a:t>
             </a:r>
           </a:p>
           <a:p>
@@ -11451,7 +11451,7 @@
               </a:defRPr>
             </a:pPr>
             <a:r>
-              <a:t>│ ANALYSIS &amp; COMPARISON                                                                    │</a:t>
+              <a:t>│ ANALYSIS &amp; COMPARISON                                                                     │</a:t>
             </a:r>
           </a:p>
           <a:p>
@@ -11470,7 +11470,7 @@
               </a:defRPr>
             </a:pPr>
             <a:r>
-              <a:t>│ ──────────────────────────────────────────────────────────────────────────────────────── │</a:t>
+              <a:t>│ ───────────────────────────────────────────────────────────────────────────────────────── │</a:t>
             </a:r>
           </a:p>
           <a:p>
@@ -11489,7 +11489,7 @@
               </a:defRPr>
             </a:pPr>
             <a:r>
-              <a:t>│  ┌──────────┐  ┌───────────┐  ┌─────────────┐  ┌───────────┐  ┌────────────┐  ┌──────┐│</a:t>
+              <a:t>│  ┌──────────┐  ┌───────────┐  ┌─────────────┐  ┌───────────┐  ┌────────────┐  ┌────────────┐│</a:t>
             </a:r>
           </a:p>
           <a:p>
@@ -11508,7 +11508,7 @@
               </a:defRPr>
             </a:pPr>
             <a:r>
-              <a:t>│  │ load_all │-&gt;│ find_dft_ │-&gt;│ eigenvector │-&gt;│ kde_      │-&gt;│ calculate_ │-&gt;│ plot ││</a:t>
+              <a:t>│  │ load_all │-&gt;│ find_dft_ │-&gt;│ eigenvector │-&gt;│ kde_      │-&gt;│ calculate_ │-&gt;│ plot_      ││</a:t>
             </a:r>
           </a:p>
           <a:p>
@@ -11527,7 +11527,7 @@
               </a:defRPr>
             </a:pPr>
             <a:r>
-              <a:t>│  │ results()│  │ baseline()│  │ matching()  │  │ broaden() │  │ metrics()  │  │ regr.││</a:t>
+              <a:t>│  │ results()│  │ baseline()│  │ matching()  │  │ broaden() │  │ metrics()  │  │ regression()││</a:t>
             </a:r>
           </a:p>
           <a:p>
@@ -11546,7 +11546,7 @@
               </a:defRPr>
             </a:pPr>
             <a:r>
-              <a:t>│  └──────────┘  └───────────┘  └─────────────┘  └───────────┘  └────────────┘  └──────┘│</a:t>
+              <a:t>│  └──────────┘  └───────────┘  └─────────────┘  └───────────┘  └────────────┘  └────────────┘│</a:t>
             </a:r>
           </a:p>
           <a:p>
@@ -11565,7 +11565,7 @@
               </a:defRPr>
             </a:pPr>
             <a:r>
-              <a:t>└──────────────────────────────────────────────────────────────────────────────────────────┘</a:t>
+              <a:t>└───────────────────────────────────────────────────────────────────────────────────────────┘</a:t>
             </a:r>
           </a:p>
           <a:p>
@@ -11642,44 +11642,6 @@
             </a:pPr>
             <a:r>
               <a:t>                          │ generate_html_report()          │</a:t>
-            </a:r>
-          </a:p>
-          <a:p>
-            <a:pPr>
-              <a:lnSpc>
-                <a:spcPct val="100000"/>
-              </a:lnSpc>
-              <a:spcAft>
-                <a:spcPts val="0"/>
-              </a:spcAft>
-              <a:defRPr sz="800">
-                <a:solidFill>
-                  <a:srgbClr val="C9D1D9"/>
-                </a:solidFill>
-                <a:latin typeface="Consolas"/>
-              </a:defRPr>
-            </a:pPr>
-            <a:r>
-              <a:t>                          │ (interactive plots,             │</a:t>
-            </a:r>
-          </a:p>
-          <a:p>
-            <a:pPr>
-              <a:lnSpc>
-                <a:spcPct val="100000"/>
-              </a:lnSpc>
-              <a:spcAft>
-                <a:spcPts val="0"/>
-              </a:spcAft>
-              <a:defRPr sz="800">
-                <a:solidFill>
-                  <a:srgbClr val="C9D1D9"/>
-                </a:solidFill>
-                <a:latin typeface="Consolas"/>
-              </a:defRPr>
-            </a:pPr>
-            <a:r>
-              <a:t>                          │  publication-ready)             │</a:t>
             </a:r>
           </a:p>
           <a:p>

</xml_diff>